<commit_message>
Most Recent Version with FTIR spectra included
</commit_message>
<xml_diff>
--- a/exciton_CO.pptx
+++ b/exciton_CO.pptx
@@ -5,7 +5,7 @@
     <p:sldMasterId id="2147483648" r:id="rId1"/>
   </p:sldMasterIdLst>
   <p:notesMasterIdLst>
-    <p:notesMasterId r:id="rId9"/>
+    <p:notesMasterId r:id="rId16"/>
   </p:notesMasterIdLst>
   <p:sldIdLst>
     <p:sldId id="256" r:id="rId2"/>
@@ -14,7 +14,14 @@
     <p:sldId id="259" r:id="rId5"/>
     <p:sldId id="260" r:id="rId6"/>
     <p:sldId id="262" r:id="rId7"/>
-    <p:sldId id="261" r:id="rId8"/>
+    <p:sldId id="263" r:id="rId8"/>
+    <p:sldId id="264" r:id="rId9"/>
+    <p:sldId id="265" r:id="rId10"/>
+    <p:sldId id="266" r:id="rId11"/>
+    <p:sldId id="267" r:id="rId12"/>
+    <p:sldId id="268" r:id="rId13"/>
+    <p:sldId id="269" r:id="rId14"/>
+    <p:sldId id="270" r:id="rId15"/>
   </p:sldIdLst>
   <p:sldSz cx="12192000" cy="6858000"/>
   <p:notesSz cx="6858000" cy="9144000"/>
@@ -214,7 +221,7 @@
           <a:p>
             <a:fld id="{DB214083-9EE7-4E8F-81A4-DA52BC10460F}" type="datetimeFigureOut">
               <a:rPr lang="en-US" smtClean="0"/>
-              <a:t>8/2/2024</a:t>
+              <a:t>12/5/2024</a:t>
             </a:fld>
             <a:endParaRPr lang="en-US"/>
           </a:p>
@@ -581,6 +588,298 @@
 </p:notes>
 </file>
 
+<file path=ppt/notesSlides/notesSlide10.xml><?xml version="1.0" encoding="utf-8"?>
+<p:notes xmlns:a="http://schemas.openxmlformats.org/drawingml/2006/main" xmlns:r="http://schemas.openxmlformats.org/officeDocument/2006/relationships" xmlns:p="http://schemas.openxmlformats.org/presentationml/2006/main">
+  <p:cSld>
+    <p:spTree>
+      <p:nvGrpSpPr>
+        <p:cNvPr id="1" name=""/>
+        <p:cNvGrpSpPr/>
+        <p:nvPr/>
+      </p:nvGrpSpPr>
+      <p:grpSpPr>
+        <a:xfrm>
+          <a:off x="0" y="0"/>
+          <a:ext cx="0" cy="0"/>
+          <a:chOff x="0" y="0"/>
+          <a:chExt cx="0" cy="0"/>
+        </a:xfrm>
+      </p:grpSpPr>
+      <p:sp>
+        <p:nvSpPr>
+          <p:cNvPr id="2" name="Slide Image Placeholder 1"/>
+          <p:cNvSpPr>
+            <a:spLocks noGrp="1" noRot="1" noChangeAspect="1"/>
+          </p:cNvSpPr>
+          <p:nvPr>
+            <p:ph type="sldImg"/>
+          </p:nvPr>
+        </p:nvSpPr>
+        <p:spPr/>
+      </p:sp>
+      <p:sp>
+        <p:nvSpPr>
+          <p:cNvPr id="3" name="Notes Placeholder 2"/>
+          <p:cNvSpPr>
+            <a:spLocks noGrp="1"/>
+          </p:cNvSpPr>
+          <p:nvPr>
+            <p:ph type="body" idx="1"/>
+          </p:nvPr>
+        </p:nvSpPr>
+        <p:spPr/>
+        <p:txBody>
+          <a:bodyPr/>
+          <a:lstStyle/>
+          <a:p>
+            <a:r>
+              <a:rPr lang="de-DE" dirty="0"/>
+              <a:t>Takes </a:t>
+            </a:r>
+            <a:r>
+              <a:rPr lang="de-DE" dirty="0" err="1"/>
+              <a:t>about</a:t>
+            </a:r>
+            <a:r>
+              <a:rPr lang="de-DE" dirty="0"/>
+              <a:t> 2 </a:t>
+            </a:r>
+            <a:r>
+              <a:rPr lang="de-DE" dirty="0" err="1"/>
+              <a:t>mins</a:t>
+            </a:r>
+            <a:endParaRPr lang="en-US" dirty="0"/>
+          </a:p>
+        </p:txBody>
+      </p:sp>
+      <p:sp>
+        <p:nvSpPr>
+          <p:cNvPr id="4" name="Slide Number Placeholder 3"/>
+          <p:cNvSpPr>
+            <a:spLocks noGrp="1"/>
+          </p:cNvSpPr>
+          <p:nvPr>
+            <p:ph type="sldNum" sz="quarter" idx="5"/>
+          </p:nvPr>
+        </p:nvSpPr>
+        <p:spPr/>
+        <p:txBody>
+          <a:bodyPr/>
+          <a:lstStyle/>
+          <a:p>
+            <a:fld id="{C3ADA3BE-8651-44EF-90D8-D9C485CA2681}" type="slidenum">
+              <a:rPr lang="en-US" smtClean="0"/>
+              <a:t>12</a:t>
+            </a:fld>
+            <a:endParaRPr lang="en-US"/>
+          </a:p>
+        </p:txBody>
+      </p:sp>
+    </p:spTree>
+    <p:extLst>
+      <p:ext uri="{BB962C8B-B14F-4D97-AF65-F5344CB8AC3E}">
+        <p14:creationId xmlns:p14="http://schemas.microsoft.com/office/powerpoint/2010/main" val="268521087"/>
+      </p:ext>
+    </p:extLst>
+  </p:cSld>
+  <p:clrMapOvr>
+    <a:masterClrMapping/>
+  </p:clrMapOvr>
+</p:notes>
+</file>
+
+<file path=ppt/notesSlides/notesSlide11.xml><?xml version="1.0" encoding="utf-8"?>
+<p:notes xmlns:a="http://schemas.openxmlformats.org/drawingml/2006/main" xmlns:r="http://schemas.openxmlformats.org/officeDocument/2006/relationships" xmlns:p="http://schemas.openxmlformats.org/presentationml/2006/main">
+  <p:cSld>
+    <p:spTree>
+      <p:nvGrpSpPr>
+        <p:cNvPr id="1" name=""/>
+        <p:cNvGrpSpPr/>
+        <p:nvPr/>
+      </p:nvGrpSpPr>
+      <p:grpSpPr>
+        <a:xfrm>
+          <a:off x="0" y="0"/>
+          <a:ext cx="0" cy="0"/>
+          <a:chOff x="0" y="0"/>
+          <a:chExt cx="0" cy="0"/>
+        </a:xfrm>
+      </p:grpSpPr>
+      <p:sp>
+        <p:nvSpPr>
+          <p:cNvPr id="2" name="Slide Image Placeholder 1"/>
+          <p:cNvSpPr>
+            <a:spLocks noGrp="1" noRot="1" noChangeAspect="1"/>
+          </p:cNvSpPr>
+          <p:nvPr>
+            <p:ph type="sldImg"/>
+          </p:nvPr>
+        </p:nvSpPr>
+        <p:spPr/>
+      </p:sp>
+      <p:sp>
+        <p:nvSpPr>
+          <p:cNvPr id="3" name="Notes Placeholder 2"/>
+          <p:cNvSpPr>
+            <a:spLocks noGrp="1"/>
+          </p:cNvSpPr>
+          <p:nvPr>
+            <p:ph type="body" idx="1"/>
+          </p:nvPr>
+        </p:nvSpPr>
+        <p:spPr/>
+        <p:txBody>
+          <a:bodyPr/>
+          <a:lstStyle/>
+          <a:p>
+            <a:r>
+              <a:rPr lang="de-DE" dirty="0"/>
+              <a:t>Takes </a:t>
+            </a:r>
+            <a:r>
+              <a:rPr lang="de-DE" dirty="0" err="1"/>
+              <a:t>about</a:t>
+            </a:r>
+            <a:r>
+              <a:rPr lang="de-DE" dirty="0"/>
+              <a:t> 6 min</a:t>
+            </a:r>
+            <a:endParaRPr lang="en-US" dirty="0"/>
+          </a:p>
+        </p:txBody>
+      </p:sp>
+      <p:sp>
+        <p:nvSpPr>
+          <p:cNvPr id="4" name="Slide Number Placeholder 3"/>
+          <p:cNvSpPr>
+            <a:spLocks noGrp="1"/>
+          </p:cNvSpPr>
+          <p:nvPr>
+            <p:ph type="sldNum" sz="quarter" idx="5"/>
+          </p:nvPr>
+        </p:nvSpPr>
+        <p:spPr/>
+        <p:txBody>
+          <a:bodyPr/>
+          <a:lstStyle/>
+          <a:p>
+            <a:fld id="{C3ADA3BE-8651-44EF-90D8-D9C485CA2681}" type="slidenum">
+              <a:rPr lang="en-US" smtClean="0"/>
+              <a:t>13</a:t>
+            </a:fld>
+            <a:endParaRPr lang="en-US"/>
+          </a:p>
+        </p:txBody>
+      </p:sp>
+    </p:spTree>
+    <p:extLst>
+      <p:ext uri="{BB962C8B-B14F-4D97-AF65-F5344CB8AC3E}">
+        <p14:creationId xmlns:p14="http://schemas.microsoft.com/office/powerpoint/2010/main" val="885917717"/>
+      </p:ext>
+    </p:extLst>
+  </p:cSld>
+  <p:clrMapOvr>
+    <a:masterClrMapping/>
+  </p:clrMapOvr>
+</p:notes>
+</file>
+
+<file path=ppt/notesSlides/notesSlide12.xml><?xml version="1.0" encoding="utf-8"?>
+<p:notes xmlns:a="http://schemas.openxmlformats.org/drawingml/2006/main" xmlns:r="http://schemas.openxmlformats.org/officeDocument/2006/relationships" xmlns:p="http://schemas.openxmlformats.org/presentationml/2006/main">
+  <p:cSld>
+    <p:spTree>
+      <p:nvGrpSpPr>
+        <p:cNvPr id="1" name=""/>
+        <p:cNvGrpSpPr/>
+        <p:nvPr/>
+      </p:nvGrpSpPr>
+      <p:grpSpPr>
+        <a:xfrm>
+          <a:off x="0" y="0"/>
+          <a:ext cx="0" cy="0"/>
+          <a:chOff x="0" y="0"/>
+          <a:chExt cx="0" cy="0"/>
+        </a:xfrm>
+      </p:grpSpPr>
+      <p:sp>
+        <p:nvSpPr>
+          <p:cNvPr id="2" name="Slide Image Placeholder 1"/>
+          <p:cNvSpPr>
+            <a:spLocks noGrp="1" noRot="1" noChangeAspect="1"/>
+          </p:cNvSpPr>
+          <p:nvPr>
+            <p:ph type="sldImg"/>
+          </p:nvPr>
+        </p:nvSpPr>
+        <p:spPr/>
+      </p:sp>
+      <p:sp>
+        <p:nvSpPr>
+          <p:cNvPr id="3" name="Notes Placeholder 2"/>
+          <p:cNvSpPr>
+            <a:spLocks noGrp="1"/>
+          </p:cNvSpPr>
+          <p:nvPr>
+            <p:ph type="body" idx="1"/>
+          </p:nvPr>
+        </p:nvSpPr>
+        <p:spPr/>
+        <p:txBody>
+          <a:bodyPr/>
+          <a:lstStyle/>
+          <a:p>
+            <a:r>
+              <a:rPr lang="de-DE" dirty="0"/>
+              <a:t>Takes </a:t>
+            </a:r>
+            <a:r>
+              <a:rPr lang="de-DE" dirty="0" err="1"/>
+              <a:t>about</a:t>
+            </a:r>
+            <a:r>
+              <a:rPr lang="de-DE" dirty="0"/>
+              <a:t> 30 min</a:t>
+            </a:r>
+            <a:endParaRPr lang="en-US" dirty="0"/>
+          </a:p>
+        </p:txBody>
+      </p:sp>
+      <p:sp>
+        <p:nvSpPr>
+          <p:cNvPr id="4" name="Slide Number Placeholder 3"/>
+          <p:cNvSpPr>
+            <a:spLocks noGrp="1"/>
+          </p:cNvSpPr>
+          <p:nvPr>
+            <p:ph type="sldNum" sz="quarter" idx="5"/>
+          </p:nvPr>
+        </p:nvSpPr>
+        <p:spPr/>
+        <p:txBody>
+          <a:bodyPr/>
+          <a:lstStyle/>
+          <a:p>
+            <a:fld id="{C3ADA3BE-8651-44EF-90D8-D9C485CA2681}" type="slidenum">
+              <a:rPr lang="en-US" smtClean="0"/>
+              <a:t>14</a:t>
+            </a:fld>
+            <a:endParaRPr lang="en-US"/>
+          </a:p>
+        </p:txBody>
+      </p:sp>
+    </p:spTree>
+    <p:extLst>
+      <p:ext uri="{BB962C8B-B14F-4D97-AF65-F5344CB8AC3E}">
+        <p14:creationId xmlns:p14="http://schemas.microsoft.com/office/powerpoint/2010/main" val="840813296"/>
+      </p:ext>
+    </p:extLst>
+  </p:cSld>
+  <p:clrMapOvr>
+    <a:masterClrMapping/>
+  </p:clrMapOvr>
+</p:notes>
+</file>
+
 <file path=ppt/notesSlides/notesSlide2.xml><?xml version="1.0" encoding="utf-8"?>
 <p:notes xmlns:a="http://schemas.openxmlformats.org/drawingml/2006/main" xmlns:r="http://schemas.openxmlformats.org/officeDocument/2006/relationships" xmlns:p="http://schemas.openxmlformats.org/presentationml/2006/main">
   <p:cSld>
@@ -1025,56 +1324,240 @@
           <a:bodyPr/>
           <a:lstStyle/>
           <a:p>
-            <a:r>
-              <a:rPr lang="de-DE" dirty="0"/>
-              <a:t>After </a:t>
-            </a:r>
-            <a:r>
-              <a:rPr lang="de-DE" dirty="0" err="1"/>
-              <a:t>around</a:t>
-            </a:r>
-            <a:r>
-              <a:rPr lang="de-DE" dirty="0"/>
-              <a:t> 300 </a:t>
-            </a:r>
-            <a:r>
-              <a:rPr lang="de-DE" dirty="0" err="1"/>
-              <a:t>mins</a:t>
-            </a:r>
-            <a:r>
-              <a:rPr lang="de-DE" dirty="0"/>
-              <a:t> </a:t>
-            </a:r>
-            <a:r>
-              <a:rPr lang="de-DE" dirty="0" err="1"/>
-              <a:t>crashes</a:t>
-            </a:r>
-            <a:endParaRPr lang="de-DE" dirty="0"/>
-          </a:p>
-          <a:p>
-            <a:r>
-              <a:rPr lang="en-US" b="0" i="0" dirty="0" err="1">
+            <a:endParaRPr lang="en-US" dirty="0"/>
+          </a:p>
+        </p:txBody>
+      </p:sp>
+      <p:sp>
+        <p:nvSpPr>
+          <p:cNvPr id="4" name="Slide Number Placeholder 3"/>
+          <p:cNvSpPr>
+            <a:spLocks noGrp="1"/>
+          </p:cNvSpPr>
+          <p:nvPr>
+            <p:ph type="sldNum" sz="quarter" idx="5"/>
+          </p:nvPr>
+        </p:nvSpPr>
+        <p:spPr/>
+        <p:txBody>
+          <a:bodyPr/>
+          <a:lstStyle/>
+          <a:p>
+            <a:fld id="{C3ADA3BE-8651-44EF-90D8-D9C485CA2681}" type="slidenum">
+              <a:rPr lang="en-US" smtClean="0"/>
+              <a:t>7</a:t>
+            </a:fld>
+            <a:endParaRPr lang="en-US"/>
+          </a:p>
+        </p:txBody>
+      </p:sp>
+    </p:spTree>
+    <p:extLst>
+      <p:ext uri="{BB962C8B-B14F-4D97-AF65-F5344CB8AC3E}">
+        <p14:creationId xmlns:p14="http://schemas.microsoft.com/office/powerpoint/2010/main" val="41939220"/>
+      </p:ext>
+    </p:extLst>
+  </p:cSld>
+  <p:clrMapOvr>
+    <a:masterClrMapping/>
+  </p:clrMapOvr>
+</p:notes>
+</file>
+
+<file path=ppt/notesSlides/notesSlide7.xml><?xml version="1.0" encoding="utf-8"?>
+<p:notes xmlns:a="http://schemas.openxmlformats.org/drawingml/2006/main" xmlns:r="http://schemas.openxmlformats.org/officeDocument/2006/relationships" xmlns:p="http://schemas.openxmlformats.org/presentationml/2006/main">
+  <p:cSld>
+    <p:spTree>
+      <p:nvGrpSpPr>
+        <p:cNvPr id="1" name=""/>
+        <p:cNvGrpSpPr/>
+        <p:nvPr/>
+      </p:nvGrpSpPr>
+      <p:grpSpPr>
+        <a:xfrm>
+          <a:off x="0" y="0"/>
+          <a:ext cx="0" cy="0"/>
+          <a:chOff x="0" y="0"/>
+          <a:chExt cx="0" cy="0"/>
+        </a:xfrm>
+      </p:grpSpPr>
+      <p:sp>
+        <p:nvSpPr>
+          <p:cNvPr id="2" name="Slide Image Placeholder 1"/>
+          <p:cNvSpPr>
+            <a:spLocks noGrp="1" noRot="1" noChangeAspect="1"/>
+          </p:cNvSpPr>
+          <p:nvPr>
+            <p:ph type="sldImg"/>
+          </p:nvPr>
+        </p:nvSpPr>
+        <p:spPr/>
+      </p:sp>
+      <p:sp>
+        <p:nvSpPr>
+          <p:cNvPr id="3" name="Notes Placeholder 2"/>
+          <p:cNvSpPr>
+            <a:spLocks noGrp="1"/>
+          </p:cNvSpPr>
+          <p:nvPr>
+            <p:ph type="body" idx="1"/>
+          </p:nvPr>
+        </p:nvSpPr>
+        <p:spPr/>
+        <p:txBody>
+          <a:bodyPr/>
+          <a:lstStyle/>
+          <a:p>
+            <a:endParaRPr lang="en-US" dirty="0"/>
+          </a:p>
+        </p:txBody>
+      </p:sp>
+      <p:sp>
+        <p:nvSpPr>
+          <p:cNvPr id="4" name="Slide Number Placeholder 3"/>
+          <p:cNvSpPr>
+            <a:spLocks noGrp="1"/>
+          </p:cNvSpPr>
+          <p:nvPr>
+            <p:ph type="sldNum" sz="quarter" idx="5"/>
+          </p:nvPr>
+        </p:nvSpPr>
+        <p:spPr/>
+        <p:txBody>
+          <a:bodyPr/>
+          <a:lstStyle/>
+          <a:p>
+            <a:fld id="{C3ADA3BE-8651-44EF-90D8-D9C485CA2681}" type="slidenum">
+              <a:rPr lang="en-US" smtClean="0"/>
+              <a:t>8</a:t>
+            </a:fld>
+            <a:endParaRPr lang="en-US"/>
+          </a:p>
+        </p:txBody>
+      </p:sp>
+    </p:spTree>
+    <p:extLst>
+      <p:ext uri="{BB962C8B-B14F-4D97-AF65-F5344CB8AC3E}">
+        <p14:creationId xmlns:p14="http://schemas.microsoft.com/office/powerpoint/2010/main" val="3091198704"/>
+      </p:ext>
+    </p:extLst>
+  </p:cSld>
+  <p:clrMapOvr>
+    <a:masterClrMapping/>
+  </p:clrMapOvr>
+</p:notes>
+</file>
+
+<file path=ppt/notesSlides/notesSlide8.xml><?xml version="1.0" encoding="utf-8"?>
+<p:notes xmlns:a="http://schemas.openxmlformats.org/drawingml/2006/main" xmlns:r="http://schemas.openxmlformats.org/officeDocument/2006/relationships" xmlns:p="http://schemas.openxmlformats.org/presentationml/2006/main">
+  <p:cSld>
+    <p:spTree>
+      <p:nvGrpSpPr>
+        <p:cNvPr id="1" name=""/>
+        <p:cNvGrpSpPr/>
+        <p:nvPr/>
+      </p:nvGrpSpPr>
+      <p:grpSpPr>
+        <a:xfrm>
+          <a:off x="0" y="0"/>
+          <a:ext cx="0" cy="0"/>
+          <a:chOff x="0" y="0"/>
+          <a:chExt cx="0" cy="0"/>
+        </a:xfrm>
+      </p:grpSpPr>
+      <p:sp>
+        <p:nvSpPr>
+          <p:cNvPr id="2" name="Slide Image Placeholder 1"/>
+          <p:cNvSpPr>
+            <a:spLocks noGrp="1" noRot="1" noChangeAspect="1"/>
+          </p:cNvSpPr>
+          <p:nvPr>
+            <p:ph type="sldImg"/>
+          </p:nvPr>
+        </p:nvSpPr>
+        <p:spPr/>
+      </p:sp>
+      <p:sp>
+        <p:nvSpPr>
+          <p:cNvPr id="3" name="Notes Placeholder 2"/>
+          <p:cNvSpPr>
+            <a:spLocks noGrp="1"/>
+          </p:cNvSpPr>
+          <p:nvPr>
+            <p:ph type="body" idx="1"/>
+          </p:nvPr>
+        </p:nvSpPr>
+        <p:spPr/>
+        <p:txBody>
+          <a:bodyPr/>
+          <a:lstStyle/>
+          <a:p>
+            <a:pPr marL="0" marR="0" lvl="0" indent="0" algn="l" defTabSz="914400" rtl="0" eaLnBrk="1" fontAlgn="auto" latinLnBrk="0" hangingPunct="1">
+              <a:lnSpc>
+                <a:spcPct val="100000"/>
+              </a:lnSpc>
+              <a:spcBef>
+                <a:spcPts val="0"/>
+              </a:spcBef>
+              <a:spcAft>
+                <a:spcPts val="0"/>
+              </a:spcAft>
+              <a:buClrTx/>
+              <a:buSzTx/>
+              <a:buFontTx/>
+              <a:buNone/>
+              <a:tabLst/>
+              <a:defRPr/>
+            </a:pPr>
+            <a:r>
+              <a:rPr lang="el-GR" b="0" dirty="0">
                 <a:solidFill>
                   <a:srgbClr val="CCCCCC"/>
                 </a:solidFill>
                 <a:effectLst/>
                 <a:latin typeface="Consolas" panose="020B0609020204030204" pitchFamily="49" charset="0"/>
               </a:rPr>
-              <a:t>OutOfMemoryError</a:t>
-            </a:r>
-            <a:r>
-              <a:rPr lang="en-US" b="0" i="0" dirty="0">
+              <a:t>ν0 </a:t>
+            </a:r>
+            <a:r>
+              <a:rPr lang="el-GR" b="0" dirty="0">
+                <a:solidFill>
+                  <a:srgbClr val="D4D4D4"/>
+                </a:solidFill>
+                <a:effectLst/>
+                <a:latin typeface="Consolas" panose="020B0609020204030204" pitchFamily="49" charset="0"/>
+              </a:rPr>
+              <a:t>=</a:t>
+            </a:r>
+            <a:r>
+              <a:rPr lang="el-GR" b="0" dirty="0">
                 <a:solidFill>
                   <a:srgbClr val="CCCCCC"/>
                 </a:solidFill>
                 <a:effectLst/>
                 <a:latin typeface="Consolas" panose="020B0609020204030204" pitchFamily="49" charset="0"/>
               </a:rPr>
-              <a:t>() </a:t>
-            </a:r>
-            <a:br>
-              <a:rPr lang="en-US" dirty="0"/>
-            </a:br>
+              <a:t> </a:t>
+            </a:r>
+            <a:r>
+              <a:rPr lang="el-GR" b="0" dirty="0">
+                <a:solidFill>
+                  <a:srgbClr val="B5CEA8"/>
+                </a:solidFill>
+                <a:effectLst/>
+                <a:latin typeface="Consolas" panose="020B0609020204030204" pitchFamily="49" charset="0"/>
+              </a:rPr>
+              <a:t>2130.937</a:t>
+            </a:r>
+            <a:endParaRPr lang="el-GR" b="0" dirty="0">
+              <a:solidFill>
+                <a:srgbClr val="CCCCCC"/>
+              </a:solidFill>
+              <a:effectLst/>
+              <a:latin typeface="Consolas" panose="020B0609020204030204" pitchFamily="49" charset="0"/>
+            </a:endParaRPr>
+          </a:p>
+          <a:p>
             <a:endParaRPr lang="en-US" dirty="0"/>
           </a:p>
         </p:txBody>
@@ -1096,7 +1579,7 @@
           <a:p>
             <a:fld id="{C3ADA3BE-8651-44EF-90D8-D9C485CA2681}" type="slidenum">
               <a:rPr lang="en-US" smtClean="0"/>
-              <a:t>7</a:t>
+              <a:t>10</a:t>
             </a:fld>
             <a:endParaRPr lang="en-US"/>
           </a:p>
@@ -1105,7 +1588,103 @@
     </p:spTree>
     <p:extLst>
       <p:ext uri="{BB962C8B-B14F-4D97-AF65-F5344CB8AC3E}">
-        <p14:creationId xmlns:p14="http://schemas.microsoft.com/office/powerpoint/2010/main" val="2092875842"/>
+        <p14:creationId xmlns:p14="http://schemas.microsoft.com/office/powerpoint/2010/main" val="3388317219"/>
+      </p:ext>
+    </p:extLst>
+  </p:cSld>
+  <p:clrMapOvr>
+    <a:masterClrMapping/>
+  </p:clrMapOvr>
+</p:notes>
+</file>
+
+<file path=ppt/notesSlides/notesSlide9.xml><?xml version="1.0" encoding="utf-8"?>
+<p:notes xmlns:a="http://schemas.openxmlformats.org/drawingml/2006/main" xmlns:r="http://schemas.openxmlformats.org/officeDocument/2006/relationships" xmlns:p="http://schemas.openxmlformats.org/presentationml/2006/main">
+  <p:cSld>
+    <p:spTree>
+      <p:nvGrpSpPr>
+        <p:cNvPr id="1" name=""/>
+        <p:cNvGrpSpPr/>
+        <p:nvPr/>
+      </p:nvGrpSpPr>
+      <p:grpSpPr>
+        <a:xfrm>
+          <a:off x="0" y="0"/>
+          <a:ext cx="0" cy="0"/>
+          <a:chOff x="0" y="0"/>
+          <a:chExt cx="0" cy="0"/>
+        </a:xfrm>
+      </p:grpSpPr>
+      <p:sp>
+        <p:nvSpPr>
+          <p:cNvPr id="2" name="Slide Image Placeholder 1"/>
+          <p:cNvSpPr>
+            <a:spLocks noGrp="1" noRot="1" noChangeAspect="1"/>
+          </p:cNvSpPr>
+          <p:nvPr>
+            <p:ph type="sldImg"/>
+          </p:nvPr>
+        </p:nvSpPr>
+        <p:spPr/>
+      </p:sp>
+      <p:sp>
+        <p:nvSpPr>
+          <p:cNvPr id="3" name="Notes Placeholder 2"/>
+          <p:cNvSpPr>
+            <a:spLocks noGrp="1"/>
+          </p:cNvSpPr>
+          <p:nvPr>
+            <p:ph type="body" idx="1"/>
+          </p:nvPr>
+        </p:nvSpPr>
+        <p:spPr/>
+        <p:txBody>
+          <a:bodyPr/>
+          <a:lstStyle/>
+          <a:p>
+            <a:r>
+              <a:rPr lang="de-DE" dirty="0"/>
+              <a:t>Takes </a:t>
+            </a:r>
+            <a:r>
+              <a:rPr lang="de-DE" dirty="0" err="1"/>
+              <a:t>about</a:t>
+            </a:r>
+            <a:r>
+              <a:rPr lang="de-DE" dirty="0"/>
+              <a:t> 44s</a:t>
+            </a:r>
+            <a:endParaRPr lang="en-US" dirty="0"/>
+          </a:p>
+        </p:txBody>
+      </p:sp>
+      <p:sp>
+        <p:nvSpPr>
+          <p:cNvPr id="4" name="Slide Number Placeholder 3"/>
+          <p:cNvSpPr>
+            <a:spLocks noGrp="1"/>
+          </p:cNvSpPr>
+          <p:nvPr>
+            <p:ph type="sldNum" sz="quarter" idx="5"/>
+          </p:nvPr>
+        </p:nvSpPr>
+        <p:spPr/>
+        <p:txBody>
+          <a:bodyPr/>
+          <a:lstStyle/>
+          <a:p>
+            <a:fld id="{C3ADA3BE-8651-44EF-90D8-D9C485CA2681}" type="slidenum">
+              <a:rPr lang="en-US" smtClean="0"/>
+              <a:t>11</a:t>
+            </a:fld>
+            <a:endParaRPr lang="en-US"/>
+          </a:p>
+        </p:txBody>
+      </p:sp>
+    </p:spTree>
+    <p:extLst>
+      <p:ext uri="{BB962C8B-B14F-4D97-AF65-F5344CB8AC3E}">
+        <p14:creationId xmlns:p14="http://schemas.microsoft.com/office/powerpoint/2010/main" val="545634253"/>
       </p:ext>
     </p:extLst>
   </p:cSld>
@@ -1264,7 +1843,7 @@
           <a:p>
             <a:fld id="{D2EC6751-3BEE-4E9B-B2EE-26D93AD5FB0C}" type="datetimeFigureOut">
               <a:rPr lang="en-IN" smtClean="0"/>
-              <a:t>02-08-2024</a:t>
+              <a:t>05-12-2024</a:t>
             </a:fld>
             <a:endParaRPr lang="en-IN"/>
           </a:p>
@@ -1464,7 +2043,7 @@
           <a:p>
             <a:fld id="{D2EC6751-3BEE-4E9B-B2EE-26D93AD5FB0C}" type="datetimeFigureOut">
               <a:rPr lang="en-IN" smtClean="0"/>
-              <a:t>02-08-2024</a:t>
+              <a:t>05-12-2024</a:t>
             </a:fld>
             <a:endParaRPr lang="en-IN"/>
           </a:p>
@@ -1674,7 +2253,7 @@
           <a:p>
             <a:fld id="{D2EC6751-3BEE-4E9B-B2EE-26D93AD5FB0C}" type="datetimeFigureOut">
               <a:rPr lang="en-IN" smtClean="0"/>
-              <a:t>02-08-2024</a:t>
+              <a:t>05-12-2024</a:t>
             </a:fld>
             <a:endParaRPr lang="en-IN"/>
           </a:p>
@@ -1874,7 +2453,7 @@
           <a:p>
             <a:fld id="{D2EC6751-3BEE-4E9B-B2EE-26D93AD5FB0C}" type="datetimeFigureOut">
               <a:rPr lang="en-IN" smtClean="0"/>
-              <a:t>02-08-2024</a:t>
+              <a:t>05-12-2024</a:t>
             </a:fld>
             <a:endParaRPr lang="en-IN"/>
           </a:p>
@@ -2150,7 +2729,7 @@
           <a:p>
             <a:fld id="{D2EC6751-3BEE-4E9B-B2EE-26D93AD5FB0C}" type="datetimeFigureOut">
               <a:rPr lang="en-IN" smtClean="0"/>
-              <a:t>02-08-2024</a:t>
+              <a:t>05-12-2024</a:t>
             </a:fld>
             <a:endParaRPr lang="en-IN"/>
           </a:p>
@@ -2418,7 +2997,7 @@
           <a:p>
             <a:fld id="{D2EC6751-3BEE-4E9B-B2EE-26D93AD5FB0C}" type="datetimeFigureOut">
               <a:rPr lang="en-IN" smtClean="0"/>
-              <a:t>02-08-2024</a:t>
+              <a:t>05-12-2024</a:t>
             </a:fld>
             <a:endParaRPr lang="en-IN"/>
           </a:p>
@@ -2833,7 +3412,7 @@
           <a:p>
             <a:fld id="{D2EC6751-3BEE-4E9B-B2EE-26D93AD5FB0C}" type="datetimeFigureOut">
               <a:rPr lang="en-IN" smtClean="0"/>
-              <a:t>02-08-2024</a:t>
+              <a:t>05-12-2024</a:t>
             </a:fld>
             <a:endParaRPr lang="en-IN"/>
           </a:p>
@@ -2975,7 +3554,7 @@
           <a:p>
             <a:fld id="{D2EC6751-3BEE-4E9B-B2EE-26D93AD5FB0C}" type="datetimeFigureOut">
               <a:rPr lang="en-IN" smtClean="0"/>
-              <a:t>02-08-2024</a:t>
+              <a:t>05-12-2024</a:t>
             </a:fld>
             <a:endParaRPr lang="en-IN"/>
           </a:p>
@@ -3088,7 +3667,7 @@
           <a:p>
             <a:fld id="{D2EC6751-3BEE-4E9B-B2EE-26D93AD5FB0C}" type="datetimeFigureOut">
               <a:rPr lang="en-IN" smtClean="0"/>
-              <a:t>02-08-2024</a:t>
+              <a:t>05-12-2024</a:t>
             </a:fld>
             <a:endParaRPr lang="en-IN"/>
           </a:p>
@@ -3401,7 +3980,7 @@
           <a:p>
             <a:fld id="{D2EC6751-3BEE-4E9B-B2EE-26D93AD5FB0C}" type="datetimeFigureOut">
               <a:rPr lang="en-IN" smtClean="0"/>
-              <a:t>02-08-2024</a:t>
+              <a:t>05-12-2024</a:t>
             </a:fld>
             <a:endParaRPr lang="en-IN"/>
           </a:p>
@@ -3690,7 +4269,7 @@
           <a:p>
             <a:fld id="{D2EC6751-3BEE-4E9B-B2EE-26D93AD5FB0C}" type="datetimeFigureOut">
               <a:rPr lang="en-IN" smtClean="0"/>
-              <a:t>02-08-2024</a:t>
+              <a:t>05-12-2024</a:t>
             </a:fld>
             <a:endParaRPr lang="en-IN"/>
           </a:p>
@@ -3933,7 +4512,7 @@
           <a:p>
             <a:fld id="{D2EC6751-3BEE-4E9B-B2EE-26D93AD5FB0C}" type="datetimeFigureOut">
               <a:rPr lang="en-IN" smtClean="0"/>
-              <a:t>02-08-2024</a:t>
+              <a:t>05-12-2024</a:t>
             </a:fld>
             <a:endParaRPr lang="en-IN"/>
           </a:p>
@@ -4413,6 +4992,1144 @@
 </p:sld>
 </file>
 
+<file path=ppt/slides/slide10.xml><?xml version="1.0" encoding="utf-8"?>
+<p:sld xmlns:a="http://schemas.openxmlformats.org/drawingml/2006/main" xmlns:r="http://schemas.openxmlformats.org/officeDocument/2006/relationships" xmlns:p="http://schemas.openxmlformats.org/presentationml/2006/main">
+  <p:cSld>
+    <p:spTree>
+      <p:nvGrpSpPr>
+        <p:cNvPr id="1" name=""/>
+        <p:cNvGrpSpPr/>
+        <p:nvPr/>
+      </p:nvGrpSpPr>
+      <p:grpSpPr>
+        <a:xfrm>
+          <a:off x="0" y="0"/>
+          <a:ext cx="0" cy="0"/>
+          <a:chOff x="0" y="0"/>
+          <a:chExt cx="0" cy="0"/>
+        </a:xfrm>
+      </p:grpSpPr>
+      <mc:AlternateContent xmlns:mc="http://schemas.openxmlformats.org/markup-compatibility/2006">
+        <mc:Choice xmlns:a14="http://schemas.microsoft.com/office/drawing/2010/main" Requires="a14">
+          <p:sp>
+            <p:nvSpPr>
+              <p:cNvPr id="2" name="TextBox 1">
+                <a:extLst>
+                  <a:ext uri="{FF2B5EF4-FFF2-40B4-BE49-F238E27FC236}">
+                    <a16:creationId xmlns:a16="http://schemas.microsoft.com/office/drawing/2014/main" id="{7156A1CE-21DE-493D-9DB5-E6AD484E0208}"/>
+                  </a:ext>
+                </a:extLst>
+              </p:cNvPr>
+              <p:cNvSpPr txBox="1"/>
+              <p:nvPr/>
+            </p:nvSpPr>
+            <p:spPr>
+              <a:xfrm>
+                <a:off x="200025" y="333375"/>
+                <a:ext cx="9757864" cy="646331"/>
+              </a:xfrm>
+              <a:prstGeom prst="rect">
+                <a:avLst/>
+              </a:prstGeom>
+              <a:noFill/>
+            </p:spPr>
+            <p:txBody>
+              <a:bodyPr wrap="none" rtlCol="0">
+                <a:spAutoFit/>
+              </a:bodyPr>
+              <a:lstStyle/>
+              <a:p>
+                <a:r>
+                  <a:rPr lang="de-DE" dirty="0"/>
+                  <a:t>Choose </a:t>
+                </a:r>
+                <a:r>
+                  <a:rPr lang="de-DE" b="1" dirty="0"/>
+                  <a:t>Theta = 50°, </a:t>
+                </a:r>
+                <a14:m>
+                  <m:oMath xmlns:m="http://schemas.openxmlformats.org/officeDocument/2006/math">
+                    <m:r>
+                      <a:rPr lang="de-DE" b="0" i="1" smtClean="0">
+                        <a:latin typeface="Cambria Math" panose="02040503050406030204" pitchFamily="18" charset="0"/>
+                      </a:rPr>
+                      <m:t>𝛼</m:t>
+                    </m:r>
+                  </m:oMath>
+                </a14:m>
+                <a:r>
+                  <a:rPr lang="en-US" dirty="0"/>
+                  <a:t>=0 and </a:t>
+                </a:r>
+                <a:r>
+                  <a:rPr lang="en-US" b="1" dirty="0"/>
+                  <a:t>µ01</a:t>
+                </a:r>
+                <a:r>
+                  <a:rPr lang="en-US" dirty="0"/>
+                  <a:t> increased to </a:t>
+                </a:r>
+                <a:r>
+                  <a:rPr lang="en-US" b="1" dirty="0"/>
+                  <a:t>0.195</a:t>
+                </a:r>
+                <a:r>
+                  <a:rPr lang="en-US" dirty="0"/>
+                  <a:t> (0.105 before) to match measured spectra, 8x8x8</a:t>
+                </a:r>
+              </a:p>
+              <a:p>
+                <a:r>
+                  <a:rPr lang="en-US" dirty="0"/>
+                  <a:t> </a:t>
+                </a:r>
+              </a:p>
+            </p:txBody>
+          </p:sp>
+        </mc:Choice>
+        <mc:Fallback>
+          <p:sp>
+            <p:nvSpPr>
+              <p:cNvPr id="2" name="TextBox 1">
+                <a:extLst>
+                  <a:ext uri="{FF2B5EF4-FFF2-40B4-BE49-F238E27FC236}">
+                    <a16:creationId xmlns:a16="http://schemas.microsoft.com/office/drawing/2014/main" id="{7156A1CE-21DE-493D-9DB5-E6AD484E0208}"/>
+                  </a:ext>
+                </a:extLst>
+              </p:cNvPr>
+              <p:cNvSpPr txBox="1">
+                <a:spLocks noRot="1" noChangeAspect="1" noMove="1" noResize="1" noEditPoints="1" noAdjustHandles="1" noChangeArrowheads="1" noChangeShapeType="1" noTextEdit="1"/>
+              </p:cNvSpPr>
+              <p:nvPr/>
+            </p:nvSpPr>
+            <p:spPr>
+              <a:xfrm>
+                <a:off x="200025" y="333375"/>
+                <a:ext cx="9757864" cy="646331"/>
+              </a:xfrm>
+              <a:prstGeom prst="rect">
+                <a:avLst/>
+              </a:prstGeom>
+              <a:blipFill>
+                <a:blip r:embed="rId3"/>
+                <a:stretch>
+                  <a:fillRect l="-562" t="-5660"/>
+                </a:stretch>
+              </a:blipFill>
+            </p:spPr>
+            <p:txBody>
+              <a:bodyPr/>
+              <a:lstStyle/>
+              <a:p>
+                <a:r>
+                  <a:rPr lang="en-US">
+                    <a:noFill/>
+                  </a:rPr>
+                  <a:t> </a:t>
+                </a:r>
+              </a:p>
+            </p:txBody>
+          </p:sp>
+        </mc:Fallback>
+      </mc:AlternateContent>
+      <p:pic>
+        <p:nvPicPr>
+          <p:cNvPr id="4" name="Picture 3">
+            <a:extLst>
+              <a:ext uri="{FF2B5EF4-FFF2-40B4-BE49-F238E27FC236}">
+                <a16:creationId xmlns:a16="http://schemas.microsoft.com/office/drawing/2014/main" id="{91364D4F-4BB3-4B43-AF2F-B11246C4C7F0}"/>
+              </a:ext>
+            </a:extLst>
+          </p:cNvPr>
+          <p:cNvPicPr>
+            <a:picLocks noChangeAspect="1"/>
+          </p:cNvPicPr>
+          <p:nvPr/>
+        </p:nvPicPr>
+        <p:blipFill>
+          <a:blip r:embed="rId4">
+            <a:extLst>
+              <a:ext uri="{28A0092B-C50C-407E-A947-70E740481C1C}">
+                <a14:useLocalDpi xmlns:a14="http://schemas.microsoft.com/office/drawing/2010/main" val="0"/>
+              </a:ext>
+            </a:extLst>
+          </a:blip>
+          <a:stretch>
+            <a:fillRect/>
+          </a:stretch>
+        </p:blipFill>
+        <p:spPr>
+          <a:xfrm>
+            <a:off x="684513" y="1751651"/>
+            <a:ext cx="4578693" cy="3194088"/>
+          </a:xfrm>
+          <a:prstGeom prst="rect">
+            <a:avLst/>
+          </a:prstGeom>
+        </p:spPr>
+      </p:pic>
+      <p:sp>
+        <p:nvSpPr>
+          <p:cNvPr id="5" name="TextBox 4">
+            <a:extLst>
+              <a:ext uri="{FF2B5EF4-FFF2-40B4-BE49-F238E27FC236}">
+                <a16:creationId xmlns:a16="http://schemas.microsoft.com/office/drawing/2014/main" id="{9DF2EEDF-70A4-4A8E-8393-F10BA7609CFA}"/>
+              </a:ext>
+            </a:extLst>
+          </p:cNvPr>
+          <p:cNvSpPr txBox="1"/>
+          <p:nvPr/>
+        </p:nvSpPr>
+        <p:spPr>
+          <a:xfrm>
+            <a:off x="1877454" y="1382319"/>
+            <a:ext cx="1646605" cy="369332"/>
+          </a:xfrm>
+          <a:prstGeom prst="rect">
+            <a:avLst/>
+          </a:prstGeom>
+          <a:noFill/>
+        </p:spPr>
+        <p:txBody>
+          <a:bodyPr wrap="none" rtlCol="0">
+            <a:spAutoFit/>
+          </a:bodyPr>
+          <a:lstStyle/>
+          <a:p>
+            <a:r>
+              <a:rPr lang="de-DE" dirty="0" err="1"/>
+              <a:t>Randomised</a:t>
+            </a:r>
+            <a:r>
+              <a:rPr lang="de-DE" dirty="0"/>
+              <a:t> on</a:t>
+            </a:r>
+            <a:endParaRPr lang="en-US" dirty="0"/>
+          </a:p>
+        </p:txBody>
+      </p:sp>
+      <p:sp>
+        <p:nvSpPr>
+          <p:cNvPr id="6" name="TextBox 5">
+            <a:extLst>
+              <a:ext uri="{FF2B5EF4-FFF2-40B4-BE49-F238E27FC236}">
+                <a16:creationId xmlns:a16="http://schemas.microsoft.com/office/drawing/2014/main" id="{5763A915-E8EE-4452-B67C-B8E7E678ABF5}"/>
+              </a:ext>
+            </a:extLst>
+          </p:cNvPr>
+          <p:cNvSpPr txBox="1"/>
+          <p:nvPr/>
+        </p:nvSpPr>
+        <p:spPr>
+          <a:xfrm>
+            <a:off x="8405941" y="1382319"/>
+            <a:ext cx="1663597" cy="369332"/>
+          </a:xfrm>
+          <a:prstGeom prst="rect">
+            <a:avLst/>
+          </a:prstGeom>
+          <a:noFill/>
+        </p:spPr>
+        <p:txBody>
+          <a:bodyPr wrap="none" rtlCol="0">
+            <a:spAutoFit/>
+          </a:bodyPr>
+          <a:lstStyle/>
+          <a:p>
+            <a:r>
+              <a:rPr lang="de-DE" dirty="0" err="1"/>
+              <a:t>Randomised</a:t>
+            </a:r>
+            <a:r>
+              <a:rPr lang="de-DE" dirty="0"/>
+              <a:t> off</a:t>
+            </a:r>
+            <a:endParaRPr lang="en-US" dirty="0"/>
+          </a:p>
+        </p:txBody>
+      </p:sp>
+      <p:pic>
+        <p:nvPicPr>
+          <p:cNvPr id="8" name="Picture 7">
+            <a:extLst>
+              <a:ext uri="{FF2B5EF4-FFF2-40B4-BE49-F238E27FC236}">
+                <a16:creationId xmlns:a16="http://schemas.microsoft.com/office/drawing/2014/main" id="{FBB7482C-B248-4011-B5F3-D447871515CE}"/>
+              </a:ext>
+            </a:extLst>
+          </p:cNvPr>
+          <p:cNvPicPr>
+            <a:picLocks noChangeAspect="1"/>
+          </p:cNvPicPr>
+          <p:nvPr/>
+        </p:nvPicPr>
+        <p:blipFill>
+          <a:blip r:embed="rId5">
+            <a:extLst>
+              <a:ext uri="{28A0092B-C50C-407E-A947-70E740481C1C}">
+                <a14:useLocalDpi xmlns:a14="http://schemas.microsoft.com/office/drawing/2010/main" val="0"/>
+              </a:ext>
+            </a:extLst>
+          </a:blip>
+          <a:stretch>
+            <a:fillRect/>
+          </a:stretch>
+        </p:blipFill>
+        <p:spPr>
+          <a:xfrm>
+            <a:off x="7008596" y="1751651"/>
+            <a:ext cx="4578693" cy="3194088"/>
+          </a:xfrm>
+          <a:prstGeom prst="rect">
+            <a:avLst/>
+          </a:prstGeom>
+        </p:spPr>
+      </p:pic>
+    </p:spTree>
+    <p:extLst>
+      <p:ext uri="{BB962C8B-B14F-4D97-AF65-F5344CB8AC3E}">
+        <p14:creationId xmlns:p14="http://schemas.microsoft.com/office/powerpoint/2010/main" val="3702339991"/>
+      </p:ext>
+    </p:extLst>
+  </p:cSld>
+  <p:clrMapOvr>
+    <a:masterClrMapping/>
+  </p:clrMapOvr>
+</p:sld>
+</file>
+
+<file path=ppt/slides/slide11.xml><?xml version="1.0" encoding="utf-8"?>
+<p:sld xmlns:a="http://schemas.openxmlformats.org/drawingml/2006/main" xmlns:r="http://schemas.openxmlformats.org/officeDocument/2006/relationships" xmlns:p="http://schemas.openxmlformats.org/presentationml/2006/main">
+  <p:cSld>
+    <p:spTree>
+      <p:nvGrpSpPr>
+        <p:cNvPr id="1" name=""/>
+        <p:cNvGrpSpPr/>
+        <p:nvPr/>
+      </p:nvGrpSpPr>
+      <p:grpSpPr>
+        <a:xfrm>
+          <a:off x="0" y="0"/>
+          <a:ext cx="0" cy="0"/>
+          <a:chOff x="0" y="0"/>
+          <a:chExt cx="0" cy="0"/>
+        </a:xfrm>
+      </p:grpSpPr>
+      <mc:AlternateContent xmlns:mc="http://schemas.openxmlformats.org/markup-compatibility/2006">
+        <mc:Choice xmlns:a14="http://schemas.microsoft.com/office/drawing/2010/main" Requires="a14">
+          <p:sp>
+            <p:nvSpPr>
+              <p:cNvPr id="5" name="TextBox 4">
+                <a:extLst>
+                  <a:ext uri="{FF2B5EF4-FFF2-40B4-BE49-F238E27FC236}">
+                    <a16:creationId xmlns:a16="http://schemas.microsoft.com/office/drawing/2014/main" id="{1918EE88-9342-467E-B5E8-69B2B065BBA6}"/>
+                  </a:ext>
+                </a:extLst>
+              </p:cNvPr>
+              <p:cNvSpPr txBox="1"/>
+              <p:nvPr/>
+            </p:nvSpPr>
+            <p:spPr>
+              <a:xfrm>
+                <a:off x="149133" y="352697"/>
+                <a:ext cx="2241369" cy="2585323"/>
+              </a:xfrm>
+              <a:prstGeom prst="rect">
+                <a:avLst/>
+              </a:prstGeom>
+              <a:noFill/>
+            </p:spPr>
+            <p:txBody>
+              <a:bodyPr wrap="square" rtlCol="0">
+                <a:spAutoFit/>
+              </a:bodyPr>
+              <a:lstStyle/>
+              <a:p>
+                <a:r>
+                  <a:rPr lang="en-US" dirty="0"/>
+                  <a:t>Unit cells </a:t>
+                </a:r>
+                <a:r>
+                  <a:rPr lang="de-DE" dirty="0"/>
+                  <a:t>12x12x12</a:t>
+                </a:r>
+                <a:endParaRPr lang="en-US" dirty="0"/>
+              </a:p>
+              <a:p>
+                <a:r>
+                  <a:rPr lang="en-US" dirty="0"/>
+                  <a:t>R</a:t>
+                </a:r>
+                <a:r>
+                  <a:rPr lang="en-IN" dirty="0" err="1"/>
+                  <a:t>andom</a:t>
+                </a:r>
+                <a:r>
+                  <a:rPr lang="en-IN" dirty="0"/>
+                  <a:t> orientations</a:t>
+                </a:r>
+              </a:p>
+              <a:p>
+                <a:endParaRPr lang="en-IN" dirty="0"/>
+              </a:p>
+              <a:p>
+                <a:r>
+                  <a:rPr lang="en-IN" dirty="0"/>
+                  <a:t>Frequency shifted (</a:t>
+                </a:r>
+                <a:r>
+                  <a:rPr lang="el-GR" dirty="0"/>
+                  <a:t>ν0 = 2130.937</a:t>
+                </a:r>
+                <a:r>
+                  <a:rPr lang="en-IN" dirty="0"/>
+                  <a:t>)</a:t>
+                </a:r>
+              </a:p>
+              <a:p>
+                <a:endParaRPr lang="en-IN" dirty="0"/>
+              </a:p>
+              <a:p>
+                <a:r>
+                  <a:rPr lang="de-DE" dirty="0"/>
+                  <a:t>Theta = 50°, </a:t>
+                </a:r>
+                <a14:m>
+                  <m:oMath xmlns:m="http://schemas.openxmlformats.org/officeDocument/2006/math">
+                    <m:r>
+                      <a:rPr lang="de-DE" b="0" i="1" smtClean="0">
+                        <a:latin typeface="Cambria Math" panose="02040503050406030204" pitchFamily="18" charset="0"/>
+                      </a:rPr>
+                      <m:t>𝛼</m:t>
+                    </m:r>
+                  </m:oMath>
+                </a14:m>
+                <a:r>
+                  <a:rPr lang="en-US" dirty="0"/>
+                  <a:t>=0 and µ01 increased to 0.195</a:t>
+                </a:r>
+                <a:endParaRPr lang="en-IN" dirty="0"/>
+              </a:p>
+            </p:txBody>
+          </p:sp>
+        </mc:Choice>
+        <mc:Fallback>
+          <p:sp>
+            <p:nvSpPr>
+              <p:cNvPr id="5" name="TextBox 4">
+                <a:extLst>
+                  <a:ext uri="{FF2B5EF4-FFF2-40B4-BE49-F238E27FC236}">
+                    <a16:creationId xmlns:a16="http://schemas.microsoft.com/office/drawing/2014/main" id="{1918EE88-9342-467E-B5E8-69B2B065BBA6}"/>
+                  </a:ext>
+                </a:extLst>
+              </p:cNvPr>
+              <p:cNvSpPr txBox="1">
+                <a:spLocks noRot="1" noChangeAspect="1" noMove="1" noResize="1" noEditPoints="1" noAdjustHandles="1" noChangeArrowheads="1" noChangeShapeType="1" noTextEdit="1"/>
+              </p:cNvSpPr>
+              <p:nvPr/>
+            </p:nvSpPr>
+            <p:spPr>
+              <a:xfrm>
+                <a:off x="149133" y="352697"/>
+                <a:ext cx="2241369" cy="2585323"/>
+              </a:xfrm>
+              <a:prstGeom prst="rect">
+                <a:avLst/>
+              </a:prstGeom>
+              <a:blipFill>
+                <a:blip r:embed="rId3"/>
+                <a:stretch>
+                  <a:fillRect l="-2174" t="-1415" r="-2446" b="-2830"/>
+                </a:stretch>
+              </a:blipFill>
+            </p:spPr>
+            <p:txBody>
+              <a:bodyPr/>
+              <a:lstStyle/>
+              <a:p>
+                <a:r>
+                  <a:rPr lang="en-US">
+                    <a:noFill/>
+                  </a:rPr>
+                  <a:t> </a:t>
+                </a:r>
+              </a:p>
+            </p:txBody>
+          </p:sp>
+        </mc:Fallback>
+      </mc:AlternateContent>
+      <p:pic>
+        <p:nvPicPr>
+          <p:cNvPr id="4" name="Picture 3">
+            <a:extLst>
+              <a:ext uri="{FF2B5EF4-FFF2-40B4-BE49-F238E27FC236}">
+                <a16:creationId xmlns:a16="http://schemas.microsoft.com/office/drawing/2014/main" id="{15819FDE-1B20-4BC3-9F30-258124233930}"/>
+              </a:ext>
+            </a:extLst>
+          </p:cNvPr>
+          <p:cNvPicPr>
+            <a:picLocks noChangeAspect="1"/>
+          </p:cNvPicPr>
+          <p:nvPr/>
+        </p:nvPicPr>
+        <p:blipFill>
+          <a:blip r:embed="rId4">
+            <a:extLst>
+              <a:ext uri="{28A0092B-C50C-407E-A947-70E740481C1C}">
+                <a14:useLocalDpi xmlns:a14="http://schemas.microsoft.com/office/drawing/2010/main" val="0"/>
+              </a:ext>
+            </a:extLst>
+          </a:blip>
+          <a:stretch>
+            <a:fillRect/>
+          </a:stretch>
+        </p:blipFill>
+        <p:spPr>
+          <a:xfrm>
+            <a:off x="2856891" y="352697"/>
+            <a:ext cx="8726118" cy="6087325"/>
+          </a:xfrm>
+          <a:prstGeom prst="rect">
+            <a:avLst/>
+          </a:prstGeom>
+        </p:spPr>
+      </p:pic>
+    </p:spTree>
+    <p:extLst>
+      <p:ext uri="{BB962C8B-B14F-4D97-AF65-F5344CB8AC3E}">
+        <p14:creationId xmlns:p14="http://schemas.microsoft.com/office/powerpoint/2010/main" val="1874777255"/>
+      </p:ext>
+    </p:extLst>
+  </p:cSld>
+  <p:clrMapOvr>
+    <a:masterClrMapping/>
+  </p:clrMapOvr>
+</p:sld>
+</file>
+
+<file path=ppt/slides/slide12.xml><?xml version="1.0" encoding="utf-8"?>
+<p:sld xmlns:a="http://schemas.openxmlformats.org/drawingml/2006/main" xmlns:r="http://schemas.openxmlformats.org/officeDocument/2006/relationships" xmlns:p="http://schemas.openxmlformats.org/presentationml/2006/main">
+  <p:cSld>
+    <p:spTree>
+      <p:nvGrpSpPr>
+        <p:cNvPr id="1" name=""/>
+        <p:cNvGrpSpPr/>
+        <p:nvPr/>
+      </p:nvGrpSpPr>
+      <p:grpSpPr>
+        <a:xfrm>
+          <a:off x="0" y="0"/>
+          <a:ext cx="0" cy="0"/>
+          <a:chOff x="0" y="0"/>
+          <a:chExt cx="0" cy="0"/>
+        </a:xfrm>
+      </p:grpSpPr>
+      <mc:AlternateContent xmlns:mc="http://schemas.openxmlformats.org/markup-compatibility/2006">
+        <mc:Choice xmlns:a14="http://schemas.microsoft.com/office/drawing/2010/main" Requires="a14">
+          <p:sp>
+            <p:nvSpPr>
+              <p:cNvPr id="5" name="TextBox 4">
+                <a:extLst>
+                  <a:ext uri="{FF2B5EF4-FFF2-40B4-BE49-F238E27FC236}">
+                    <a16:creationId xmlns:a16="http://schemas.microsoft.com/office/drawing/2014/main" id="{1918EE88-9342-467E-B5E8-69B2B065BBA6}"/>
+                  </a:ext>
+                </a:extLst>
+              </p:cNvPr>
+              <p:cNvSpPr txBox="1"/>
+              <p:nvPr/>
+            </p:nvSpPr>
+            <p:spPr>
+              <a:xfrm>
+                <a:off x="149133" y="352697"/>
+                <a:ext cx="2241369" cy="2585323"/>
+              </a:xfrm>
+              <a:prstGeom prst="rect">
+                <a:avLst/>
+              </a:prstGeom>
+              <a:noFill/>
+            </p:spPr>
+            <p:txBody>
+              <a:bodyPr wrap="square" rtlCol="0">
+                <a:spAutoFit/>
+              </a:bodyPr>
+              <a:lstStyle/>
+              <a:p>
+                <a:r>
+                  <a:rPr lang="en-US" dirty="0"/>
+                  <a:t>Unit cells </a:t>
+                </a:r>
+                <a:r>
+                  <a:rPr lang="de-DE" dirty="0"/>
+                  <a:t>14x14x14</a:t>
+                </a:r>
+                <a:endParaRPr lang="en-US" dirty="0"/>
+              </a:p>
+              <a:p>
+                <a:r>
+                  <a:rPr lang="en-US" dirty="0"/>
+                  <a:t>R</a:t>
+                </a:r>
+                <a:r>
+                  <a:rPr lang="en-IN" dirty="0" err="1"/>
+                  <a:t>andom</a:t>
+                </a:r>
+                <a:r>
+                  <a:rPr lang="en-IN" dirty="0"/>
+                  <a:t> orientations</a:t>
+                </a:r>
+              </a:p>
+              <a:p>
+                <a:endParaRPr lang="en-IN" dirty="0"/>
+              </a:p>
+              <a:p>
+                <a:r>
+                  <a:rPr lang="en-IN" dirty="0"/>
+                  <a:t>Frequency shifted (</a:t>
+                </a:r>
+                <a:r>
+                  <a:rPr lang="el-GR" dirty="0"/>
+                  <a:t>ν0 = 2130.937</a:t>
+                </a:r>
+                <a:r>
+                  <a:rPr lang="en-IN" dirty="0"/>
+                  <a:t>)</a:t>
+                </a:r>
+              </a:p>
+              <a:p>
+                <a:endParaRPr lang="en-IN" dirty="0"/>
+              </a:p>
+              <a:p>
+                <a:r>
+                  <a:rPr lang="de-DE" dirty="0"/>
+                  <a:t>Theta = 50°, </a:t>
+                </a:r>
+                <a14:m>
+                  <m:oMath xmlns:m="http://schemas.openxmlformats.org/officeDocument/2006/math">
+                    <m:r>
+                      <a:rPr lang="de-DE" b="0" i="1" smtClean="0">
+                        <a:latin typeface="Cambria Math" panose="02040503050406030204" pitchFamily="18" charset="0"/>
+                      </a:rPr>
+                      <m:t>𝛼</m:t>
+                    </m:r>
+                  </m:oMath>
+                </a14:m>
+                <a:r>
+                  <a:rPr lang="en-US" dirty="0"/>
+                  <a:t>=0 and µ01 increased to 0.195</a:t>
+                </a:r>
+                <a:endParaRPr lang="en-IN" dirty="0"/>
+              </a:p>
+            </p:txBody>
+          </p:sp>
+        </mc:Choice>
+        <mc:Fallback>
+          <p:sp>
+            <p:nvSpPr>
+              <p:cNvPr id="5" name="TextBox 4">
+                <a:extLst>
+                  <a:ext uri="{FF2B5EF4-FFF2-40B4-BE49-F238E27FC236}">
+                    <a16:creationId xmlns:a16="http://schemas.microsoft.com/office/drawing/2014/main" id="{1918EE88-9342-467E-B5E8-69B2B065BBA6}"/>
+                  </a:ext>
+                </a:extLst>
+              </p:cNvPr>
+              <p:cNvSpPr txBox="1">
+                <a:spLocks noRot="1" noChangeAspect="1" noMove="1" noResize="1" noEditPoints="1" noAdjustHandles="1" noChangeArrowheads="1" noChangeShapeType="1" noTextEdit="1"/>
+              </p:cNvSpPr>
+              <p:nvPr/>
+            </p:nvSpPr>
+            <p:spPr>
+              <a:xfrm>
+                <a:off x="149133" y="352697"/>
+                <a:ext cx="2241369" cy="2585323"/>
+              </a:xfrm>
+              <a:prstGeom prst="rect">
+                <a:avLst/>
+              </a:prstGeom>
+              <a:blipFill>
+                <a:blip r:embed="rId3"/>
+                <a:stretch>
+                  <a:fillRect l="-2174" t="-1415" r="-2446" b="-2830"/>
+                </a:stretch>
+              </a:blipFill>
+            </p:spPr>
+            <p:txBody>
+              <a:bodyPr/>
+              <a:lstStyle/>
+              <a:p>
+                <a:r>
+                  <a:rPr lang="en-US">
+                    <a:noFill/>
+                  </a:rPr>
+                  <a:t> </a:t>
+                </a:r>
+              </a:p>
+            </p:txBody>
+          </p:sp>
+        </mc:Fallback>
+      </mc:AlternateContent>
+      <p:pic>
+        <p:nvPicPr>
+          <p:cNvPr id="4" name="Picture 3">
+            <a:extLst>
+              <a:ext uri="{FF2B5EF4-FFF2-40B4-BE49-F238E27FC236}">
+                <a16:creationId xmlns:a16="http://schemas.microsoft.com/office/drawing/2014/main" id="{15819FDE-1B20-4BC3-9F30-258124233930}"/>
+              </a:ext>
+            </a:extLst>
+          </p:cNvPr>
+          <p:cNvPicPr>
+            <a:picLocks noChangeAspect="1"/>
+          </p:cNvPicPr>
+          <p:nvPr/>
+        </p:nvPicPr>
+        <p:blipFill>
+          <a:blip r:embed="rId4">
+            <a:extLst>
+              <a:ext uri="{28A0092B-C50C-407E-A947-70E740481C1C}">
+                <a14:useLocalDpi xmlns:a14="http://schemas.microsoft.com/office/drawing/2010/main" val="0"/>
+              </a:ext>
+            </a:extLst>
+          </a:blip>
+          <a:srcRect/>
+          <a:stretch/>
+        </p:blipFill>
+        <p:spPr>
+          <a:xfrm>
+            <a:off x="2857062" y="352697"/>
+            <a:ext cx="8725775" cy="6087325"/>
+          </a:xfrm>
+          <a:prstGeom prst="rect">
+            <a:avLst/>
+          </a:prstGeom>
+        </p:spPr>
+      </p:pic>
+    </p:spTree>
+    <p:extLst>
+      <p:ext uri="{BB962C8B-B14F-4D97-AF65-F5344CB8AC3E}">
+        <p14:creationId xmlns:p14="http://schemas.microsoft.com/office/powerpoint/2010/main" val="2816614603"/>
+      </p:ext>
+    </p:extLst>
+  </p:cSld>
+  <p:clrMapOvr>
+    <a:masterClrMapping/>
+  </p:clrMapOvr>
+</p:sld>
+</file>
+
+<file path=ppt/slides/slide13.xml><?xml version="1.0" encoding="utf-8"?>
+<p:sld xmlns:a="http://schemas.openxmlformats.org/drawingml/2006/main" xmlns:r="http://schemas.openxmlformats.org/officeDocument/2006/relationships" xmlns:p="http://schemas.openxmlformats.org/presentationml/2006/main">
+  <p:cSld>
+    <p:spTree>
+      <p:nvGrpSpPr>
+        <p:cNvPr id="1" name=""/>
+        <p:cNvGrpSpPr/>
+        <p:nvPr/>
+      </p:nvGrpSpPr>
+      <p:grpSpPr>
+        <a:xfrm>
+          <a:off x="0" y="0"/>
+          <a:ext cx="0" cy="0"/>
+          <a:chOff x="0" y="0"/>
+          <a:chExt cx="0" cy="0"/>
+        </a:xfrm>
+      </p:grpSpPr>
+      <mc:AlternateContent xmlns:mc="http://schemas.openxmlformats.org/markup-compatibility/2006">
+        <mc:Choice xmlns:a14="http://schemas.microsoft.com/office/drawing/2010/main" Requires="a14">
+          <p:sp>
+            <p:nvSpPr>
+              <p:cNvPr id="5" name="TextBox 4">
+                <a:extLst>
+                  <a:ext uri="{FF2B5EF4-FFF2-40B4-BE49-F238E27FC236}">
+                    <a16:creationId xmlns:a16="http://schemas.microsoft.com/office/drawing/2014/main" id="{1918EE88-9342-467E-B5E8-69B2B065BBA6}"/>
+                  </a:ext>
+                </a:extLst>
+              </p:cNvPr>
+              <p:cNvSpPr txBox="1"/>
+              <p:nvPr/>
+            </p:nvSpPr>
+            <p:spPr>
+              <a:xfrm>
+                <a:off x="149133" y="352697"/>
+                <a:ext cx="2241369" cy="2585323"/>
+              </a:xfrm>
+              <a:prstGeom prst="rect">
+                <a:avLst/>
+              </a:prstGeom>
+              <a:noFill/>
+            </p:spPr>
+            <p:txBody>
+              <a:bodyPr wrap="square" rtlCol="0">
+                <a:spAutoFit/>
+              </a:bodyPr>
+              <a:lstStyle/>
+              <a:p>
+                <a:r>
+                  <a:rPr lang="en-US" dirty="0"/>
+                  <a:t>Unit cells </a:t>
+                </a:r>
+                <a:r>
+                  <a:rPr lang="de-DE" dirty="0"/>
+                  <a:t>16x16x16</a:t>
+                </a:r>
+                <a:endParaRPr lang="en-US" dirty="0"/>
+              </a:p>
+              <a:p>
+                <a:r>
+                  <a:rPr lang="en-US" dirty="0"/>
+                  <a:t>R</a:t>
+                </a:r>
+                <a:r>
+                  <a:rPr lang="en-IN" dirty="0" err="1"/>
+                  <a:t>andom</a:t>
+                </a:r>
+                <a:r>
+                  <a:rPr lang="en-IN" dirty="0"/>
+                  <a:t> orientations</a:t>
+                </a:r>
+              </a:p>
+              <a:p>
+                <a:endParaRPr lang="en-IN" dirty="0"/>
+              </a:p>
+              <a:p>
+                <a:r>
+                  <a:rPr lang="en-IN" dirty="0"/>
+                  <a:t>Frequency shifted (</a:t>
+                </a:r>
+                <a:r>
+                  <a:rPr lang="el-GR" dirty="0"/>
+                  <a:t>ν0 = 2130.937</a:t>
+                </a:r>
+                <a:r>
+                  <a:rPr lang="en-IN" dirty="0"/>
+                  <a:t>)</a:t>
+                </a:r>
+              </a:p>
+              <a:p>
+                <a:endParaRPr lang="en-IN" dirty="0"/>
+              </a:p>
+              <a:p>
+                <a:r>
+                  <a:rPr lang="de-DE" dirty="0"/>
+                  <a:t>Theta = 50°, </a:t>
+                </a:r>
+                <a14:m>
+                  <m:oMath xmlns:m="http://schemas.openxmlformats.org/officeDocument/2006/math">
+                    <m:r>
+                      <a:rPr lang="de-DE" b="0" i="1" smtClean="0">
+                        <a:latin typeface="Cambria Math" panose="02040503050406030204" pitchFamily="18" charset="0"/>
+                      </a:rPr>
+                      <m:t>𝛼</m:t>
+                    </m:r>
+                  </m:oMath>
+                </a14:m>
+                <a:r>
+                  <a:rPr lang="en-US" dirty="0"/>
+                  <a:t>=0 and µ01 increased to 0.195</a:t>
+                </a:r>
+                <a:endParaRPr lang="en-IN" dirty="0"/>
+              </a:p>
+            </p:txBody>
+          </p:sp>
+        </mc:Choice>
+        <mc:Fallback>
+          <p:sp>
+            <p:nvSpPr>
+              <p:cNvPr id="5" name="TextBox 4">
+                <a:extLst>
+                  <a:ext uri="{FF2B5EF4-FFF2-40B4-BE49-F238E27FC236}">
+                    <a16:creationId xmlns:a16="http://schemas.microsoft.com/office/drawing/2014/main" id="{1918EE88-9342-467E-B5E8-69B2B065BBA6}"/>
+                  </a:ext>
+                </a:extLst>
+              </p:cNvPr>
+              <p:cNvSpPr txBox="1">
+                <a:spLocks noRot="1" noChangeAspect="1" noMove="1" noResize="1" noEditPoints="1" noAdjustHandles="1" noChangeArrowheads="1" noChangeShapeType="1" noTextEdit="1"/>
+              </p:cNvSpPr>
+              <p:nvPr/>
+            </p:nvSpPr>
+            <p:spPr>
+              <a:xfrm>
+                <a:off x="149133" y="352697"/>
+                <a:ext cx="2241369" cy="2585323"/>
+              </a:xfrm>
+              <a:prstGeom prst="rect">
+                <a:avLst/>
+              </a:prstGeom>
+              <a:blipFill>
+                <a:blip r:embed="rId3"/>
+                <a:stretch>
+                  <a:fillRect l="-2174" t="-1415" r="-2446" b="-2830"/>
+                </a:stretch>
+              </a:blipFill>
+            </p:spPr>
+            <p:txBody>
+              <a:bodyPr/>
+              <a:lstStyle/>
+              <a:p>
+                <a:r>
+                  <a:rPr lang="en-US">
+                    <a:noFill/>
+                  </a:rPr>
+                  <a:t> </a:t>
+                </a:r>
+              </a:p>
+            </p:txBody>
+          </p:sp>
+        </mc:Fallback>
+      </mc:AlternateContent>
+      <p:pic>
+        <p:nvPicPr>
+          <p:cNvPr id="6" name="Picture 5">
+            <a:extLst>
+              <a:ext uri="{FF2B5EF4-FFF2-40B4-BE49-F238E27FC236}">
+                <a16:creationId xmlns:a16="http://schemas.microsoft.com/office/drawing/2014/main" id="{801FD322-D6ED-44CF-82D5-29919DADDC24}"/>
+              </a:ext>
+            </a:extLst>
+          </p:cNvPr>
+          <p:cNvPicPr>
+            <a:picLocks noChangeAspect="1"/>
+          </p:cNvPicPr>
+          <p:nvPr/>
+        </p:nvPicPr>
+        <p:blipFill>
+          <a:blip r:embed="rId4">
+            <a:extLst>
+              <a:ext uri="{28A0092B-C50C-407E-A947-70E740481C1C}">
+                <a14:useLocalDpi xmlns:a14="http://schemas.microsoft.com/office/drawing/2010/main" val="0"/>
+              </a:ext>
+            </a:extLst>
+          </a:blip>
+          <a:srcRect/>
+          <a:stretch/>
+        </p:blipFill>
+        <p:spPr>
+          <a:xfrm>
+            <a:off x="2857062" y="352697"/>
+            <a:ext cx="8725775" cy="6087324"/>
+          </a:xfrm>
+          <a:prstGeom prst="rect">
+            <a:avLst/>
+          </a:prstGeom>
+        </p:spPr>
+      </p:pic>
+    </p:spTree>
+    <p:extLst>
+      <p:ext uri="{BB962C8B-B14F-4D97-AF65-F5344CB8AC3E}">
+        <p14:creationId xmlns:p14="http://schemas.microsoft.com/office/powerpoint/2010/main" val="2427911086"/>
+      </p:ext>
+    </p:extLst>
+  </p:cSld>
+  <p:clrMapOvr>
+    <a:masterClrMapping/>
+  </p:clrMapOvr>
+</p:sld>
+</file>
+
+<file path=ppt/slides/slide14.xml><?xml version="1.0" encoding="utf-8"?>
+<p:sld xmlns:a="http://schemas.openxmlformats.org/drawingml/2006/main" xmlns:r="http://schemas.openxmlformats.org/officeDocument/2006/relationships" xmlns:p="http://schemas.openxmlformats.org/presentationml/2006/main">
+  <p:cSld>
+    <p:spTree>
+      <p:nvGrpSpPr>
+        <p:cNvPr id="1" name=""/>
+        <p:cNvGrpSpPr/>
+        <p:nvPr/>
+      </p:nvGrpSpPr>
+      <p:grpSpPr>
+        <a:xfrm>
+          <a:off x="0" y="0"/>
+          <a:ext cx="0" cy="0"/>
+          <a:chOff x="0" y="0"/>
+          <a:chExt cx="0" cy="0"/>
+        </a:xfrm>
+      </p:grpSpPr>
+      <mc:AlternateContent xmlns:mc="http://schemas.openxmlformats.org/markup-compatibility/2006">
+        <mc:Choice xmlns:a14="http://schemas.microsoft.com/office/drawing/2010/main" Requires="a14">
+          <p:sp>
+            <p:nvSpPr>
+              <p:cNvPr id="5" name="TextBox 4">
+                <a:extLst>
+                  <a:ext uri="{FF2B5EF4-FFF2-40B4-BE49-F238E27FC236}">
+                    <a16:creationId xmlns:a16="http://schemas.microsoft.com/office/drawing/2014/main" id="{1918EE88-9342-467E-B5E8-69B2B065BBA6}"/>
+                  </a:ext>
+                </a:extLst>
+              </p:cNvPr>
+              <p:cNvSpPr txBox="1"/>
+              <p:nvPr/>
+            </p:nvSpPr>
+            <p:spPr>
+              <a:xfrm>
+                <a:off x="149133" y="352697"/>
+                <a:ext cx="2241369" cy="2585323"/>
+              </a:xfrm>
+              <a:prstGeom prst="rect">
+                <a:avLst/>
+              </a:prstGeom>
+              <a:noFill/>
+            </p:spPr>
+            <p:txBody>
+              <a:bodyPr wrap="square" rtlCol="0">
+                <a:spAutoFit/>
+              </a:bodyPr>
+              <a:lstStyle/>
+              <a:p>
+                <a:r>
+                  <a:rPr lang="en-US" dirty="0"/>
+                  <a:t>Unit cells </a:t>
+                </a:r>
+                <a:r>
+                  <a:rPr lang="de-DE" dirty="0"/>
+                  <a:t>20x20x20</a:t>
+                </a:r>
+                <a:endParaRPr lang="en-US" dirty="0"/>
+              </a:p>
+              <a:p>
+                <a:r>
+                  <a:rPr lang="en-US" dirty="0"/>
+                  <a:t>R</a:t>
+                </a:r>
+                <a:r>
+                  <a:rPr lang="en-IN" dirty="0" err="1"/>
+                  <a:t>andom</a:t>
+                </a:r>
+                <a:r>
+                  <a:rPr lang="en-IN" dirty="0"/>
+                  <a:t> orientations</a:t>
+                </a:r>
+              </a:p>
+              <a:p>
+                <a:endParaRPr lang="en-IN" dirty="0"/>
+              </a:p>
+              <a:p>
+                <a:r>
+                  <a:rPr lang="en-IN" dirty="0"/>
+                  <a:t>Frequency shifted (</a:t>
+                </a:r>
+                <a:r>
+                  <a:rPr lang="el-GR" dirty="0"/>
+                  <a:t>ν0 = 2130.937</a:t>
+                </a:r>
+                <a:r>
+                  <a:rPr lang="en-IN" dirty="0"/>
+                  <a:t>)</a:t>
+                </a:r>
+              </a:p>
+              <a:p>
+                <a:endParaRPr lang="en-IN" dirty="0"/>
+              </a:p>
+              <a:p>
+                <a:r>
+                  <a:rPr lang="de-DE" dirty="0"/>
+                  <a:t>Theta = 50°, </a:t>
+                </a:r>
+                <a14:m>
+                  <m:oMath xmlns:m="http://schemas.openxmlformats.org/officeDocument/2006/math">
+                    <m:r>
+                      <a:rPr lang="de-DE" b="0" i="1" smtClean="0">
+                        <a:latin typeface="Cambria Math" panose="02040503050406030204" pitchFamily="18" charset="0"/>
+                      </a:rPr>
+                      <m:t>𝛼</m:t>
+                    </m:r>
+                  </m:oMath>
+                </a14:m>
+                <a:r>
+                  <a:rPr lang="en-US" dirty="0"/>
+                  <a:t>=0 and µ01 increased to 0.195</a:t>
+                </a:r>
+                <a:endParaRPr lang="en-IN" dirty="0"/>
+              </a:p>
+            </p:txBody>
+          </p:sp>
+        </mc:Choice>
+        <mc:Fallback>
+          <p:sp>
+            <p:nvSpPr>
+              <p:cNvPr id="5" name="TextBox 4">
+                <a:extLst>
+                  <a:ext uri="{FF2B5EF4-FFF2-40B4-BE49-F238E27FC236}">
+                    <a16:creationId xmlns:a16="http://schemas.microsoft.com/office/drawing/2014/main" id="{1918EE88-9342-467E-B5E8-69B2B065BBA6}"/>
+                  </a:ext>
+                </a:extLst>
+              </p:cNvPr>
+              <p:cNvSpPr txBox="1">
+                <a:spLocks noRot="1" noChangeAspect="1" noMove="1" noResize="1" noEditPoints="1" noAdjustHandles="1" noChangeArrowheads="1" noChangeShapeType="1" noTextEdit="1"/>
+              </p:cNvSpPr>
+              <p:nvPr/>
+            </p:nvSpPr>
+            <p:spPr>
+              <a:xfrm>
+                <a:off x="149133" y="352697"/>
+                <a:ext cx="2241369" cy="2585323"/>
+              </a:xfrm>
+              <a:prstGeom prst="rect">
+                <a:avLst/>
+              </a:prstGeom>
+              <a:blipFill>
+                <a:blip r:embed="rId3"/>
+                <a:stretch>
+                  <a:fillRect l="-2174" t="-1415" r="-2446" b="-2830"/>
+                </a:stretch>
+              </a:blipFill>
+            </p:spPr>
+            <p:txBody>
+              <a:bodyPr/>
+              <a:lstStyle/>
+              <a:p>
+                <a:r>
+                  <a:rPr lang="en-US">
+                    <a:noFill/>
+                  </a:rPr>
+                  <a:t> </a:t>
+                </a:r>
+              </a:p>
+            </p:txBody>
+          </p:sp>
+        </mc:Fallback>
+      </mc:AlternateContent>
+      <p:pic>
+        <p:nvPicPr>
+          <p:cNvPr id="4" name="Picture 3">
+            <a:extLst>
+              <a:ext uri="{FF2B5EF4-FFF2-40B4-BE49-F238E27FC236}">
+                <a16:creationId xmlns:a16="http://schemas.microsoft.com/office/drawing/2014/main" id="{874968B1-EC28-47AF-9971-6F00D8543D7A}"/>
+              </a:ext>
+            </a:extLst>
+          </p:cNvPr>
+          <p:cNvPicPr>
+            <a:picLocks noChangeAspect="1"/>
+          </p:cNvPicPr>
+          <p:nvPr/>
+        </p:nvPicPr>
+        <p:blipFill>
+          <a:blip r:embed="rId4">
+            <a:extLst>
+              <a:ext uri="{28A0092B-C50C-407E-A947-70E740481C1C}">
+                <a14:useLocalDpi xmlns:a14="http://schemas.microsoft.com/office/drawing/2010/main" val="0"/>
+              </a:ext>
+            </a:extLst>
+          </a:blip>
+          <a:srcRect/>
+          <a:stretch/>
+        </p:blipFill>
+        <p:spPr>
+          <a:xfrm>
+            <a:off x="2857063" y="352697"/>
+            <a:ext cx="8725773" cy="6087324"/>
+          </a:xfrm>
+          <a:prstGeom prst="rect">
+            <a:avLst/>
+          </a:prstGeom>
+        </p:spPr>
+      </p:pic>
+    </p:spTree>
+    <p:extLst>
+      <p:ext uri="{BB962C8B-B14F-4D97-AF65-F5344CB8AC3E}">
+        <p14:creationId xmlns:p14="http://schemas.microsoft.com/office/powerpoint/2010/main" val="2572281986"/>
+      </p:ext>
+    </p:extLst>
+  </p:cSld>
+  <p:clrMapOvr>
+    <a:masterClrMapping/>
+  </p:clrMapOvr>
+</p:sld>
+</file>
+
 <file path=ppt/slides/slide2.xml><?xml version="1.0" encoding="utf-8"?>
 <p:sld xmlns:a="http://schemas.openxmlformats.org/drawingml/2006/main" xmlns:r="http://schemas.openxmlformats.org/officeDocument/2006/relationships" xmlns:p="http://schemas.openxmlformats.org/presentationml/2006/main">
   <p:cSld>
@@ -4460,8 +6177,8 @@
           </a:prstGeom>
         </p:spPr>
       </p:pic>
-      <mc:AlternateContent xmlns:mc="http://schemas.openxmlformats.org/markup-compatibility/2006" xmlns:a14="http://schemas.microsoft.com/office/drawing/2010/main">
-        <mc:Choice Requires="a14">
+      <mc:AlternateContent xmlns:mc="http://schemas.openxmlformats.org/markup-compatibility/2006">
+        <mc:Choice xmlns:a14="http://schemas.microsoft.com/office/drawing/2010/main" Requires="a14">
           <p:sp>
             <p:nvSpPr>
               <p:cNvPr id="5" name="TextBox 4">
@@ -4492,12 +6209,16 @@
               <a:p>
                 <a:r>
                   <a:rPr lang="en-US" dirty="0"/>
-                  <a:t>Unit cells 15</a:t>
+                  <a:t>Unit cells </a:t>
+                </a:r>
+                <a:r>
+                  <a:rPr lang="en-US" b="1" dirty="0"/>
+                  <a:t>15</a:t>
                 </a:r>
                 <a14:m>
                   <m:oMath xmlns:m="http://schemas.openxmlformats.org/officeDocument/2006/math">
                     <m:r>
-                      <a:rPr lang="en-US" b="0" i="1" smtClean="0">
+                      <a:rPr lang="en-US" b="1" i="1" smtClean="0">
                         <a:latin typeface="Cambria Math" panose="02040503050406030204" pitchFamily="18" charset="0"/>
                       </a:rPr>
                       <m:t>×</m:t>
@@ -4505,13 +6226,13 @@
                   </m:oMath>
                 </a14:m>
                 <a:r>
-                  <a:rPr lang="en-IN" dirty="0"/>
+                  <a:rPr lang="en-IN" b="1" dirty="0"/>
                   <a:t>15</a:t>
                 </a:r>
                 <a14:m>
                   <m:oMath xmlns:m="http://schemas.openxmlformats.org/officeDocument/2006/math">
                     <m:r>
-                      <a:rPr lang="en-US" b="0" i="1" smtClean="0">
+                      <a:rPr lang="en-US" b="1" i="1" smtClean="0">
                         <a:latin typeface="Cambria Math" panose="02040503050406030204" pitchFamily="18" charset="0"/>
                       </a:rPr>
                       <m:t>×</m:t>
@@ -4519,7 +6240,7 @@
                   </m:oMath>
                 </a14:m>
                 <a:r>
-                  <a:rPr lang="en-IN" dirty="0"/>
+                  <a:rPr lang="en-IN" b="1" dirty="0"/>
                   <a:t>15</a:t>
                 </a:r>
               </a:p>
@@ -4543,7 +6264,7 @@
             </p:txBody>
           </p:sp>
         </mc:Choice>
-        <mc:Fallback xmlns="">
+        <mc:Fallback>
           <p:sp>
             <p:nvSpPr>
               <p:cNvPr id="5" name="TextBox 4">
@@ -4578,7 +6299,7 @@
               <a:lstStyle/>
               <a:p>
                 <a:r>
-                  <a:rPr lang="en-IN">
+                  <a:rPr lang="en-US">
                     <a:noFill/>
                   </a:rPr>
                   <a:t> </a:t>
@@ -4618,8 +6339,8 @@
           <a:chExt cx="0" cy="0"/>
         </a:xfrm>
       </p:grpSpPr>
-      <mc:AlternateContent xmlns:mc="http://schemas.openxmlformats.org/markup-compatibility/2006" xmlns:a14="http://schemas.microsoft.com/office/drawing/2010/main">
-        <mc:Choice Requires="a14">
+      <mc:AlternateContent xmlns:mc="http://schemas.openxmlformats.org/markup-compatibility/2006">
+        <mc:Choice xmlns:a14="http://schemas.microsoft.com/office/drawing/2010/main" Requires="a14">
           <p:sp>
             <p:nvSpPr>
               <p:cNvPr id="5" name="TextBox 4">
@@ -4650,12 +6371,16 @@
               <a:p>
                 <a:r>
                   <a:rPr lang="en-US" dirty="0"/>
-                  <a:t>Unit cells 20</a:t>
+                  <a:t>Unit cells </a:t>
+                </a:r>
+                <a:r>
+                  <a:rPr lang="en-US" b="1" dirty="0"/>
+                  <a:t>20</a:t>
                 </a:r>
                 <a14:m>
                   <m:oMath xmlns:m="http://schemas.openxmlformats.org/officeDocument/2006/math">
                     <m:r>
-                      <a:rPr lang="en-US" b="0" i="1" smtClean="0">
+                      <a:rPr lang="en-US" b="1" i="1" smtClean="0">
                         <a:latin typeface="Cambria Math" panose="02040503050406030204" pitchFamily="18" charset="0"/>
                       </a:rPr>
                       <m:t>×</m:t>
@@ -4663,13 +6388,13 @@
                   </m:oMath>
                 </a14:m>
                 <a:r>
-                  <a:rPr lang="en-IN" dirty="0"/>
+                  <a:rPr lang="en-IN" b="1" dirty="0"/>
                   <a:t>20</a:t>
                 </a:r>
                 <a14:m>
                   <m:oMath xmlns:m="http://schemas.openxmlformats.org/officeDocument/2006/math">
                     <m:r>
-                      <a:rPr lang="en-US" b="0" i="1" smtClean="0">
+                      <a:rPr lang="en-US" b="1" i="1" smtClean="0">
                         <a:latin typeface="Cambria Math" panose="02040503050406030204" pitchFamily="18" charset="0"/>
                       </a:rPr>
                       <m:t>×</m:t>
@@ -4677,7 +6402,7 @@
                   </m:oMath>
                 </a14:m>
                 <a:r>
-                  <a:rPr lang="en-IN" dirty="0"/>
+                  <a:rPr lang="en-IN" b="1" dirty="0"/>
                   <a:t>20</a:t>
                 </a:r>
               </a:p>
@@ -4701,7 +6426,7 @@
             </p:txBody>
           </p:sp>
         </mc:Choice>
-        <mc:Fallback xmlns="">
+        <mc:Fallback>
           <p:sp>
             <p:nvSpPr>
               <p:cNvPr id="5" name="TextBox 4">
@@ -4806,8 +6531,8 @@
           <a:chExt cx="0" cy="0"/>
         </a:xfrm>
       </p:grpSpPr>
-      <mc:AlternateContent xmlns:mc="http://schemas.openxmlformats.org/markup-compatibility/2006" xmlns:a14="http://schemas.microsoft.com/office/drawing/2010/main">
-        <mc:Choice Requires="a14">
+      <mc:AlternateContent xmlns:mc="http://schemas.openxmlformats.org/markup-compatibility/2006">
+        <mc:Choice xmlns:a14="http://schemas.microsoft.com/office/drawing/2010/main" Requires="a14">
           <p:sp>
             <p:nvSpPr>
               <p:cNvPr id="5" name="TextBox 4">
@@ -4838,12 +6563,16 @@
               <a:p>
                 <a:r>
                   <a:rPr lang="en-US" dirty="0"/>
-                  <a:t>Unit cells 23</a:t>
+                  <a:t>Unit cells </a:t>
+                </a:r>
+                <a:r>
+                  <a:rPr lang="en-US" b="1" dirty="0"/>
+                  <a:t>23</a:t>
                 </a:r>
                 <a14:m>
                   <m:oMath xmlns:m="http://schemas.openxmlformats.org/officeDocument/2006/math">
                     <m:r>
-                      <a:rPr lang="en-US" b="0" i="1" smtClean="0">
+                      <a:rPr lang="en-US" b="1" i="1" smtClean="0">
                         <a:latin typeface="Cambria Math" panose="02040503050406030204" pitchFamily="18" charset="0"/>
                       </a:rPr>
                       <m:t>×</m:t>
@@ -4851,13 +6580,13 @@
                   </m:oMath>
                 </a14:m>
                 <a:r>
-                  <a:rPr lang="en-IN" dirty="0"/>
+                  <a:rPr lang="en-IN" b="1" dirty="0"/>
                   <a:t>23</a:t>
                 </a:r>
                 <a14:m>
                   <m:oMath xmlns:m="http://schemas.openxmlformats.org/officeDocument/2006/math">
                     <m:r>
-                      <a:rPr lang="en-US" b="0" i="1" smtClean="0">
+                      <a:rPr lang="en-US" b="1" i="1" smtClean="0">
                         <a:latin typeface="Cambria Math" panose="02040503050406030204" pitchFamily="18" charset="0"/>
                       </a:rPr>
                       <m:t>×</m:t>
@@ -4865,7 +6594,7 @@
                   </m:oMath>
                 </a14:m>
                 <a:r>
-                  <a:rPr lang="en-IN" dirty="0"/>
+                  <a:rPr lang="en-IN" b="1" dirty="0"/>
                   <a:t>23</a:t>
                 </a:r>
               </a:p>
@@ -4889,7 +6618,7 @@
             </p:txBody>
           </p:sp>
         </mc:Choice>
-        <mc:Fallback xmlns="">
+        <mc:Fallback>
           <p:sp>
             <p:nvSpPr>
               <p:cNvPr id="5" name="TextBox 4">
@@ -5000,8 +6729,8 @@
           <a:chExt cx="0" cy="0"/>
         </a:xfrm>
       </p:grpSpPr>
-      <mc:AlternateContent xmlns:mc="http://schemas.openxmlformats.org/markup-compatibility/2006" xmlns:a14="http://schemas.microsoft.com/office/drawing/2010/main">
-        <mc:Choice Requires="a14">
+      <mc:AlternateContent xmlns:mc="http://schemas.openxmlformats.org/markup-compatibility/2006">
+        <mc:Choice xmlns:a14="http://schemas.microsoft.com/office/drawing/2010/main" Requires="a14">
           <p:sp>
             <p:nvSpPr>
               <p:cNvPr id="5" name="TextBox 4">
@@ -5032,12 +6761,16 @@
               <a:p>
                 <a:r>
                   <a:rPr lang="en-US" dirty="0"/>
-                  <a:t>Unit cells 24</a:t>
+                  <a:t>Unit cells </a:t>
+                </a:r>
+                <a:r>
+                  <a:rPr lang="en-US" b="1" dirty="0"/>
+                  <a:t>24</a:t>
                 </a:r>
                 <a14:m>
                   <m:oMath xmlns:m="http://schemas.openxmlformats.org/officeDocument/2006/math">
                     <m:r>
-                      <a:rPr lang="en-US" b="0" i="1" smtClean="0">
+                      <a:rPr lang="en-US" b="1" i="1" smtClean="0">
                         <a:latin typeface="Cambria Math" panose="02040503050406030204" pitchFamily="18" charset="0"/>
                       </a:rPr>
                       <m:t>×</m:t>
@@ -5045,13 +6778,13 @@
                   </m:oMath>
                 </a14:m>
                 <a:r>
-                  <a:rPr lang="en-IN" dirty="0"/>
+                  <a:rPr lang="en-IN" b="1" dirty="0"/>
                   <a:t>24</a:t>
                 </a:r>
                 <a14:m>
                   <m:oMath xmlns:m="http://schemas.openxmlformats.org/officeDocument/2006/math">
                     <m:r>
-                      <a:rPr lang="en-US" b="0" i="1" smtClean="0">
+                      <a:rPr lang="en-US" b="1" i="1" smtClean="0">
                         <a:latin typeface="Cambria Math" panose="02040503050406030204" pitchFamily="18" charset="0"/>
                       </a:rPr>
                       <m:t>×</m:t>
@@ -5059,7 +6792,7 @@
                   </m:oMath>
                 </a14:m>
                 <a:r>
-                  <a:rPr lang="en-IN" dirty="0"/>
+                  <a:rPr lang="en-IN" b="1" dirty="0"/>
                   <a:t>24</a:t>
                 </a:r>
               </a:p>
@@ -5083,7 +6816,7 @@
             </p:txBody>
           </p:sp>
         </mc:Choice>
-        <mc:Fallback xmlns="">
+        <mc:Fallback>
           <p:sp>
             <p:nvSpPr>
               <p:cNvPr id="5" name="TextBox 4">
@@ -5226,12 +6959,16 @@
               <a:p>
                 <a:r>
                   <a:rPr lang="en-US" dirty="0"/>
-                  <a:t>Unit cells 24</a:t>
+                  <a:t>Unit cells </a:t>
+                </a:r>
+                <a:r>
+                  <a:rPr lang="en-US" b="1" dirty="0"/>
+                  <a:t>24</a:t>
                 </a:r>
                 <a14:m>
                   <m:oMath xmlns:m="http://schemas.openxmlformats.org/officeDocument/2006/math">
                     <m:r>
-                      <a:rPr lang="en-US" b="0" i="1" smtClean="0">
+                      <a:rPr lang="en-US" b="1" i="1" smtClean="0">
                         <a:latin typeface="Cambria Math" panose="02040503050406030204" pitchFamily="18" charset="0"/>
                       </a:rPr>
                       <m:t>×</m:t>
@@ -5239,13 +6976,13 @@
                   </m:oMath>
                 </a14:m>
                 <a:r>
-                  <a:rPr lang="en-IN" dirty="0"/>
+                  <a:rPr lang="en-IN" b="1" dirty="0"/>
                   <a:t>24</a:t>
                 </a:r>
                 <a14:m>
                   <m:oMath xmlns:m="http://schemas.openxmlformats.org/officeDocument/2006/math">
                     <m:r>
-                      <a:rPr lang="en-US" b="0" i="1" smtClean="0">
+                      <a:rPr lang="en-US" b="1" i="1" smtClean="0">
                         <a:latin typeface="Cambria Math" panose="02040503050406030204" pitchFamily="18" charset="0"/>
                       </a:rPr>
                       <m:t>×</m:t>
@@ -5253,7 +6990,7 @@
                   </m:oMath>
                 </a14:m>
                 <a:r>
-                  <a:rPr lang="en-IN" dirty="0"/>
+                  <a:rPr lang="en-IN" b="1" dirty="0"/>
                   <a:t>24</a:t>
                 </a:r>
               </a:p>
@@ -5397,8 +7134,8 @@
           <a:chExt cx="0" cy="0"/>
         </a:xfrm>
       </p:grpSpPr>
-      <mc:AlternateContent xmlns:mc="http://schemas.openxmlformats.org/markup-compatibility/2006" xmlns:a14="http://schemas.microsoft.com/office/drawing/2010/main">
-        <mc:Choice Requires="a14">
+      <mc:AlternateContent xmlns:mc="http://schemas.openxmlformats.org/markup-compatibility/2006">
+        <mc:Choice xmlns:a14="http://schemas.microsoft.com/office/drawing/2010/main" Requires="a14">
           <p:sp>
             <p:nvSpPr>
               <p:cNvPr id="5" name="TextBox 4">
@@ -5414,7 +7151,7 @@
             <p:spPr>
               <a:xfrm>
                 <a:off x="149133" y="352697"/>
-                <a:ext cx="2241369" cy="923330"/>
+                <a:ext cx="2460717" cy="4247317"/>
               </a:xfrm>
               <a:prstGeom prst="rect">
                 <a:avLst/>
@@ -5429,12 +7166,16 @@
               <a:p>
                 <a:r>
                   <a:rPr lang="en-US" dirty="0"/>
-                  <a:t>Unit cells 25</a:t>
+                  <a:t>Unit cells </a:t>
+                </a:r>
+                <a:r>
+                  <a:rPr lang="en-US" b="1" dirty="0"/>
+                  <a:t>24</a:t>
                 </a:r>
                 <a14:m>
                   <m:oMath xmlns:m="http://schemas.openxmlformats.org/officeDocument/2006/math">
                     <m:r>
-                      <a:rPr lang="en-US" b="0" i="1" smtClean="0">
+                      <a:rPr lang="en-US" b="1" i="1" smtClean="0">
                         <a:latin typeface="Cambria Math" panose="02040503050406030204" pitchFamily="18" charset="0"/>
                       </a:rPr>
                       <m:t>×</m:t>
@@ -5442,13 +7183,13 @@
                   </m:oMath>
                 </a14:m>
                 <a:r>
-                  <a:rPr lang="en-IN" dirty="0"/>
-                  <a:t>25</a:t>
+                  <a:rPr lang="en-IN" b="1" dirty="0"/>
+                  <a:t>24</a:t>
                 </a:r>
                 <a14:m>
                   <m:oMath xmlns:m="http://schemas.openxmlformats.org/officeDocument/2006/math">
                     <m:r>
-                      <a:rPr lang="en-US" b="0" i="1" smtClean="0">
+                      <a:rPr lang="en-US" b="1" i="1" smtClean="0">
                         <a:latin typeface="Cambria Math" panose="02040503050406030204" pitchFamily="18" charset="0"/>
                       </a:rPr>
                       <m:t>×</m:t>
@@ -5456,8 +7197,8 @@
                   </m:oMath>
                 </a14:m>
                 <a:r>
-                  <a:rPr lang="en-IN" dirty="0"/>
-                  <a:t>25</a:t>
+                  <a:rPr lang="en-IN" b="1" dirty="0"/>
+                  <a:t>24</a:t>
                 </a:r>
               </a:p>
               <a:p>
@@ -5477,10 +7218,88 @@
                   <a:t> orientations</a:t>
                 </a:r>
               </a:p>
+              <a:p>
+                <a:endParaRPr lang="en-IN" dirty="0"/>
+              </a:p>
+              <a:p>
+                <a:r>
+                  <a:rPr lang="en-IN" dirty="0"/>
+                  <a:t>Frequency shifted</a:t>
+                </a:r>
+              </a:p>
+              <a:p>
+                <a:endParaRPr lang="en-IN" dirty="0"/>
+              </a:p>
+              <a:p>
+                <a:r>
+                  <a:rPr lang="en-IN" dirty="0"/>
+                  <a:t>With FTIR</a:t>
+                </a:r>
+              </a:p>
+              <a:p>
+                <a:endParaRPr lang="en-IN" dirty="0"/>
+              </a:p>
+              <a:p>
+                <a:r>
+                  <a:rPr lang="de-DE" dirty="0"/>
+                  <a:t>Takes </a:t>
+                </a:r>
+                <a:r>
+                  <a:rPr lang="de-DE" dirty="0" err="1"/>
+                  <a:t>about</a:t>
+                </a:r>
+                <a:r>
+                  <a:rPr lang="de-DE" dirty="0"/>
+                  <a:t> 211 </a:t>
+                </a:r>
+                <a:r>
+                  <a:rPr lang="de-DE" dirty="0" err="1"/>
+                  <a:t>mins</a:t>
+                </a:r>
+                <a:endParaRPr lang="de-DE" dirty="0"/>
+              </a:p>
+              <a:p>
+                <a:endParaRPr lang="de-DE" dirty="0"/>
+              </a:p>
+              <a:p>
+                <a:r>
+                  <a:rPr lang="de-DE" dirty="0"/>
+                  <a:t>25x25x25 </a:t>
+                </a:r>
+                <a:r>
+                  <a:rPr lang="de-DE" dirty="0" err="1"/>
+                  <a:t>crashes</a:t>
+                </a:r>
+                <a:r>
+                  <a:rPr lang="de-DE" dirty="0"/>
+                  <a:t> after ~300 min </a:t>
+                </a:r>
+              </a:p>
+              <a:p>
+                <a:endParaRPr lang="de-DE" dirty="0"/>
+              </a:p>
+              <a:p>
+                <a:r>
+                  <a:rPr lang="de-DE" dirty="0"/>
+                  <a:t>(</a:t>
+                </a:r>
+                <a:r>
+                  <a:rPr lang="de-DE" dirty="0" err="1"/>
+                  <a:t>OutOfMemoryError</a:t>
+                </a:r>
+                <a:r>
+                  <a:rPr lang="de-DE" dirty="0"/>
+                  <a:t>() )</a:t>
+                </a:r>
+                <a:endParaRPr lang="en-US" dirty="0"/>
+              </a:p>
+              <a:p>
+                <a:endParaRPr lang="en-IN" dirty="0"/>
+              </a:p>
             </p:txBody>
           </p:sp>
         </mc:Choice>
-        <mc:Fallback xmlns="">
+        <mc:Fallback>
           <p:sp>
             <p:nvSpPr>
               <p:cNvPr id="5" name="TextBox 4">
@@ -5498,7 +7317,7 @@
             <p:spPr>
               <a:xfrm>
                 <a:off x="149133" y="352697"/>
-                <a:ext cx="2241369" cy="923330"/>
+                <a:ext cx="2460717" cy="4247317"/>
               </a:xfrm>
               <a:prstGeom prst="rect">
                 <a:avLst/>
@@ -5506,7 +7325,1388 @@
               <a:blipFill>
                 <a:blip r:embed="rId3"/>
                 <a:stretch>
-                  <a:fillRect l="-2174" t="-3974" b="-9934"/>
+                  <a:fillRect l="-1980" t="-861"/>
+                </a:stretch>
+              </a:blipFill>
+            </p:spPr>
+            <p:txBody>
+              <a:bodyPr/>
+              <a:lstStyle/>
+              <a:p>
+                <a:r>
+                  <a:rPr lang="en-US">
+                    <a:noFill/>
+                  </a:rPr>
+                  <a:t> </a:t>
+                </a:r>
+              </a:p>
+            </p:txBody>
+          </p:sp>
+        </mc:Fallback>
+      </mc:AlternateContent>
+      <p:pic>
+        <p:nvPicPr>
+          <p:cNvPr id="4" name="Picture 3">
+            <a:extLst>
+              <a:ext uri="{FF2B5EF4-FFF2-40B4-BE49-F238E27FC236}">
+                <a16:creationId xmlns:a16="http://schemas.microsoft.com/office/drawing/2014/main" id="{564EB86F-2AC5-4C26-8AEF-452F66132390}"/>
+              </a:ext>
+            </a:extLst>
+          </p:cNvPr>
+          <p:cNvPicPr>
+            <a:picLocks noChangeAspect="1"/>
+          </p:cNvPicPr>
+          <p:nvPr/>
+        </p:nvPicPr>
+        <p:blipFill rotWithShape="1">
+          <a:blip r:embed="rId4">
+            <a:extLst>
+              <a:ext uri="{28A0092B-C50C-407E-A947-70E740481C1C}">
+                <a14:useLocalDpi xmlns:a14="http://schemas.microsoft.com/office/drawing/2010/main" val="0"/>
+              </a:ext>
+            </a:extLst>
+          </a:blip>
+          <a:srcRect l="2265" t="6044" r="1808" b="2823"/>
+          <a:stretch/>
+        </p:blipFill>
+        <p:spPr>
+          <a:xfrm>
+            <a:off x="3149600" y="701040"/>
+            <a:ext cx="7934960" cy="5252720"/>
+          </a:xfrm>
+          <a:prstGeom prst="rect">
+            <a:avLst/>
+          </a:prstGeom>
+        </p:spPr>
+      </p:pic>
+    </p:spTree>
+    <p:extLst>
+      <p:ext uri="{BB962C8B-B14F-4D97-AF65-F5344CB8AC3E}">
+        <p14:creationId xmlns:p14="http://schemas.microsoft.com/office/powerpoint/2010/main" val="3611821614"/>
+      </p:ext>
+    </p:extLst>
+  </p:cSld>
+  <p:clrMapOvr>
+    <a:masterClrMapping/>
+  </p:clrMapOvr>
+</p:sld>
+</file>
+
+<file path=ppt/slides/slide8.xml><?xml version="1.0" encoding="utf-8"?>
+<p:sld xmlns:a="http://schemas.openxmlformats.org/drawingml/2006/main" xmlns:r="http://schemas.openxmlformats.org/officeDocument/2006/relationships" xmlns:p="http://schemas.openxmlformats.org/presentationml/2006/main">
+  <p:cSld>
+    <p:spTree>
+      <p:nvGrpSpPr>
+        <p:cNvPr id="1" name=""/>
+        <p:cNvGrpSpPr/>
+        <p:nvPr/>
+      </p:nvGrpSpPr>
+      <p:grpSpPr>
+        <a:xfrm>
+          <a:off x="0" y="0"/>
+          <a:ext cx="0" cy="0"/>
+          <a:chOff x="0" y="0"/>
+          <a:chExt cx="0" cy="0"/>
+        </a:xfrm>
+      </p:grpSpPr>
+      <p:sp>
+        <p:nvSpPr>
+          <p:cNvPr id="5" name="TextBox 4">
+            <a:extLst>
+              <a:ext uri="{FF2B5EF4-FFF2-40B4-BE49-F238E27FC236}">
+                <a16:creationId xmlns:a16="http://schemas.microsoft.com/office/drawing/2014/main" id="{1918EE88-9342-467E-B5E8-69B2B065BBA6}"/>
+              </a:ext>
+            </a:extLst>
+          </p:cNvPr>
+          <p:cNvSpPr txBox="1"/>
+          <p:nvPr/>
+        </p:nvSpPr>
+        <p:spPr>
+          <a:xfrm>
+            <a:off x="149133" y="352697"/>
+            <a:ext cx="2241369" cy="3139321"/>
+          </a:xfrm>
+          <a:prstGeom prst="rect">
+            <a:avLst/>
+          </a:prstGeom>
+          <a:noFill/>
+        </p:spPr>
+        <p:txBody>
+          <a:bodyPr wrap="square" rtlCol="0">
+            <a:spAutoFit/>
+          </a:bodyPr>
+          <a:lstStyle/>
+          <a:p>
+            <a:r>
+              <a:rPr lang="en-US" dirty="0"/>
+              <a:t>Unit cells </a:t>
+            </a:r>
+            <a:r>
+              <a:rPr lang="de-DE" b="1" dirty="0"/>
+              <a:t>10x10x10</a:t>
+            </a:r>
+            <a:endParaRPr lang="en-IN" b="1" dirty="0"/>
+          </a:p>
+          <a:p>
+            <a:endParaRPr lang="en-US" dirty="0"/>
+          </a:p>
+          <a:p>
+            <a:r>
+              <a:rPr lang="en-US" dirty="0"/>
+              <a:t>R</a:t>
+            </a:r>
+            <a:r>
+              <a:rPr lang="en-IN" dirty="0" err="1"/>
+              <a:t>andom</a:t>
+            </a:r>
+            <a:r>
+              <a:rPr lang="en-IN" dirty="0"/>
+              <a:t> orientations</a:t>
+            </a:r>
+          </a:p>
+          <a:p>
+            <a:endParaRPr lang="en-IN" dirty="0"/>
+          </a:p>
+          <a:p>
+            <a:r>
+              <a:rPr lang="en-IN" dirty="0"/>
+              <a:t>Frequency shifted</a:t>
+            </a:r>
+          </a:p>
+          <a:p>
+            <a:endParaRPr lang="en-IN" dirty="0"/>
+          </a:p>
+          <a:p>
+            <a:r>
+              <a:rPr lang="en-IN" dirty="0"/>
+              <a:t>With FTIR</a:t>
+            </a:r>
+          </a:p>
+          <a:p>
+            <a:endParaRPr lang="en-IN" dirty="0"/>
+          </a:p>
+          <a:p>
+            <a:r>
+              <a:rPr lang="en-IN" dirty="0"/>
+              <a:t>With </a:t>
+            </a:r>
+            <a:r>
+              <a:rPr lang="en-IN" b="1" dirty="0"/>
+              <a:t>periodic boundary conditions in z</a:t>
+            </a:r>
+            <a:r>
+              <a:rPr lang="en-IN" dirty="0"/>
+              <a:t> at </a:t>
+            </a:r>
+            <a:r>
+              <a:rPr lang="el-GR" dirty="0"/>
+              <a:t>ν0 = 2138.0</a:t>
+            </a:r>
+            <a:endParaRPr lang="en-IN" dirty="0"/>
+          </a:p>
+        </p:txBody>
+      </p:sp>
+      <p:pic>
+        <p:nvPicPr>
+          <p:cNvPr id="3" name="Picture 2">
+            <a:extLst>
+              <a:ext uri="{FF2B5EF4-FFF2-40B4-BE49-F238E27FC236}">
+                <a16:creationId xmlns:a16="http://schemas.microsoft.com/office/drawing/2014/main" id="{33D0A187-008F-4852-948D-CE4FE73D30DA}"/>
+              </a:ext>
+            </a:extLst>
+          </p:cNvPr>
+          <p:cNvPicPr>
+            <a:picLocks noChangeAspect="1"/>
+          </p:cNvPicPr>
+          <p:nvPr/>
+        </p:nvPicPr>
+        <p:blipFill>
+          <a:blip r:embed="rId3">
+            <a:extLst>
+              <a:ext uri="{28A0092B-C50C-407E-A947-70E740481C1C}">
+                <a14:useLocalDpi xmlns:a14="http://schemas.microsoft.com/office/drawing/2010/main" val="0"/>
+              </a:ext>
+            </a:extLst>
+          </a:blip>
+          <a:stretch>
+            <a:fillRect/>
+          </a:stretch>
+        </p:blipFill>
+        <p:spPr>
+          <a:xfrm>
+            <a:off x="2622279" y="666364"/>
+            <a:ext cx="8430802" cy="5525271"/>
+          </a:xfrm>
+          <a:prstGeom prst="rect">
+            <a:avLst/>
+          </a:prstGeom>
+        </p:spPr>
+      </p:pic>
+    </p:spTree>
+    <p:extLst>
+      <p:ext uri="{BB962C8B-B14F-4D97-AF65-F5344CB8AC3E}">
+        <p14:creationId xmlns:p14="http://schemas.microsoft.com/office/powerpoint/2010/main" val="14039797"/>
+      </p:ext>
+    </p:extLst>
+  </p:cSld>
+  <p:clrMapOvr>
+    <a:masterClrMapping/>
+  </p:clrMapOvr>
+</p:sld>
+</file>
+
+<file path=ppt/slides/slide9.xml><?xml version="1.0" encoding="utf-8"?>
+<p:sld xmlns:a="http://schemas.openxmlformats.org/drawingml/2006/main" xmlns:r="http://schemas.openxmlformats.org/officeDocument/2006/relationships" xmlns:p="http://schemas.openxmlformats.org/presentationml/2006/main">
+  <p:cSld>
+    <p:spTree>
+      <p:nvGrpSpPr>
+        <p:cNvPr id="1" name=""/>
+        <p:cNvGrpSpPr/>
+        <p:nvPr/>
+      </p:nvGrpSpPr>
+      <p:grpSpPr>
+        <a:xfrm>
+          <a:off x="0" y="0"/>
+          <a:ext cx="0" cy="0"/>
+          <a:chOff x="0" y="0"/>
+          <a:chExt cx="0" cy="0"/>
+        </a:xfrm>
+      </p:grpSpPr>
+      <p:graphicFrame>
+        <p:nvGraphicFramePr>
+          <p:cNvPr id="2" name="Table 2">
+            <a:extLst>
+              <a:ext uri="{FF2B5EF4-FFF2-40B4-BE49-F238E27FC236}">
+                <a16:creationId xmlns:a16="http://schemas.microsoft.com/office/drawing/2014/main" id="{7962AFBC-8A73-4F7C-8ABA-480A423D7168}"/>
+              </a:ext>
+            </a:extLst>
+          </p:cNvPr>
+          <p:cNvGraphicFramePr>
+            <a:graphicFrameLocks noGrp="1"/>
+          </p:cNvGraphicFramePr>
+          <p:nvPr>
+            <p:extLst>
+              <p:ext uri="{D42A27DB-BD31-4B8C-83A1-F6EECF244321}">
+                <p14:modId xmlns:p14="http://schemas.microsoft.com/office/powerpoint/2010/main" val="3939602738"/>
+              </p:ext>
+            </p:extLst>
+          </p:nvPr>
+        </p:nvGraphicFramePr>
+        <p:xfrm>
+          <a:off x="2032000" y="197153"/>
+          <a:ext cx="9778998" cy="5904654"/>
+        </p:xfrm>
+        <a:graphic>
+          <a:graphicData uri="http://schemas.openxmlformats.org/drawingml/2006/table">
+            <a:tbl>
+              <a:tblPr firstRow="1" bandRow="1">
+                <a:tableStyleId>{5C22544A-7EE6-4342-B048-85BDC9FD1C3A}</a:tableStyleId>
+              </a:tblPr>
+              <a:tblGrid>
+                <a:gridCol w="1524785">
+                  <a:extLst>
+                    <a:ext uri="{9D8B030D-6E8A-4147-A177-3AD203B41FA5}">
+                      <a16:colId xmlns:a16="http://schemas.microsoft.com/office/drawing/2014/main" val="4204726471"/>
+                    </a:ext>
+                  </a:extLst>
+                </a:gridCol>
+                <a:gridCol w="1852662">
+                  <a:extLst>
+                    <a:ext uri="{9D8B030D-6E8A-4147-A177-3AD203B41FA5}">
+                      <a16:colId xmlns:a16="http://schemas.microsoft.com/office/drawing/2014/main" val="3903638488"/>
+                    </a:ext>
+                  </a:extLst>
+                </a:gridCol>
+                <a:gridCol w="1279673">
+                  <a:extLst>
+                    <a:ext uri="{9D8B030D-6E8A-4147-A177-3AD203B41FA5}">
+                      <a16:colId xmlns:a16="http://schemas.microsoft.com/office/drawing/2014/main" val="831239979"/>
+                    </a:ext>
+                  </a:extLst>
+                </a:gridCol>
+                <a:gridCol w="1862212">
+                  <a:extLst>
+                    <a:ext uri="{9D8B030D-6E8A-4147-A177-3AD203B41FA5}">
+                      <a16:colId xmlns:a16="http://schemas.microsoft.com/office/drawing/2014/main" val="3251779691"/>
+                    </a:ext>
+                  </a:extLst>
+                </a:gridCol>
+                <a:gridCol w="1482354">
+                  <a:extLst>
+                    <a:ext uri="{9D8B030D-6E8A-4147-A177-3AD203B41FA5}">
+                      <a16:colId xmlns:a16="http://schemas.microsoft.com/office/drawing/2014/main" val="1876126318"/>
+                    </a:ext>
+                  </a:extLst>
+                </a:gridCol>
+                <a:gridCol w="1777312">
+                  <a:extLst>
+                    <a:ext uri="{9D8B030D-6E8A-4147-A177-3AD203B41FA5}">
+                      <a16:colId xmlns:a16="http://schemas.microsoft.com/office/drawing/2014/main" val="2625175770"/>
+                    </a:ext>
+                  </a:extLst>
+                </a:gridCol>
+              </a:tblGrid>
+              <a:tr h="370840">
+                <a:tc>
+                  <a:txBody>
+                    <a:bodyPr/>
+                    <a:lstStyle/>
+                    <a:p>
+                      <a:r>
+                        <a:rPr lang="de-DE" dirty="0" err="1"/>
+                        <a:t>Incident</a:t>
+                      </a:r>
+                      <a:r>
+                        <a:rPr lang="de-DE" dirty="0"/>
+                        <a:t> angle</a:t>
+                      </a:r>
+                    </a:p>
+                  </a:txBody>
+                  <a:tcPr/>
+                </a:tc>
+                <a:tc>
+                  <a:txBody>
+                    <a:bodyPr/>
+                    <a:lstStyle/>
+                    <a:p>
+                      <a:endParaRPr lang="en-US" dirty="0"/>
+                    </a:p>
+                  </a:txBody>
+                  <a:tcPr/>
+                </a:tc>
+                <a:tc>
+                  <a:txBody>
+                    <a:bodyPr/>
+                    <a:lstStyle/>
+                    <a:p>
+                      <a:r>
+                        <a:rPr lang="de-DE" dirty="0"/>
+                        <a:t>µ</a:t>
+                      </a:r>
+                      <a:r>
+                        <a:rPr lang="el-GR" dirty="0"/>
+                        <a:t>01</a:t>
+                      </a:r>
+                      <a:r>
+                        <a:rPr lang="de-DE" dirty="0"/>
+                        <a:t> @ 45°</a:t>
+                      </a:r>
+                      <a:endParaRPr lang="en-US" dirty="0"/>
+                    </a:p>
+                  </a:txBody>
+                  <a:tcPr/>
+                </a:tc>
+                <a:tc>
+                  <a:txBody>
+                    <a:bodyPr/>
+                    <a:lstStyle/>
+                    <a:p>
+                      <a:endParaRPr lang="en-US" dirty="0"/>
+                    </a:p>
+                  </a:txBody>
+                  <a:tcPr/>
+                </a:tc>
+                <a:tc>
+                  <a:txBody>
+                    <a:bodyPr/>
+                    <a:lstStyle/>
+                    <a:p>
+                      <a:r>
+                        <a:rPr lang="el-GR" dirty="0"/>
+                        <a:t>α </a:t>
+                      </a:r>
+                      <a:r>
+                        <a:rPr lang="de-DE" dirty="0"/>
+                        <a:t>@ 45,0.105</a:t>
+                      </a:r>
+                      <a:endParaRPr lang="en-US" dirty="0"/>
+                    </a:p>
+                  </a:txBody>
+                  <a:tcPr/>
+                </a:tc>
+                <a:tc>
+                  <a:txBody>
+                    <a:bodyPr/>
+                    <a:lstStyle/>
+                    <a:p>
+                      <a:endParaRPr lang="en-US" dirty="0"/>
+                    </a:p>
+                  </a:txBody>
+                  <a:tcPr/>
+                </a:tc>
+                <a:extLst>
+                  <a:ext uri="{0D108BD9-81ED-4DB2-BD59-A6C34878D82A}">
+                    <a16:rowId xmlns:a16="http://schemas.microsoft.com/office/drawing/2014/main" val="12721329"/>
+                  </a:ext>
+                </a:extLst>
+              </a:tr>
+              <a:tr h="1538394">
+                <a:tc>
+                  <a:txBody>
+                    <a:bodyPr/>
+                    <a:lstStyle/>
+                    <a:p>
+                      <a:r>
+                        <a:rPr lang="de-DE" dirty="0"/>
+                        <a:t>30</a:t>
+                      </a:r>
+                    </a:p>
+                  </a:txBody>
+                  <a:tcPr/>
+                </a:tc>
+                <a:tc>
+                  <a:txBody>
+                    <a:bodyPr/>
+                    <a:lstStyle/>
+                    <a:p>
+                      <a:endParaRPr lang="en-US" dirty="0"/>
+                    </a:p>
+                  </a:txBody>
+                  <a:tcPr/>
+                </a:tc>
+                <a:tc>
+                  <a:txBody>
+                    <a:bodyPr/>
+                    <a:lstStyle/>
+                    <a:p>
+                      <a:r>
+                        <a:rPr lang="de-DE" dirty="0"/>
+                        <a:t>0.08</a:t>
+                      </a:r>
+                      <a:endParaRPr lang="en-US" dirty="0"/>
+                    </a:p>
+                  </a:txBody>
+                  <a:tcPr/>
+                </a:tc>
+                <a:tc>
+                  <a:txBody>
+                    <a:bodyPr/>
+                    <a:lstStyle/>
+                    <a:p>
+                      <a:endParaRPr lang="en-US" dirty="0"/>
+                    </a:p>
+                  </a:txBody>
+                  <a:tcPr/>
+                </a:tc>
+                <a:tc>
+                  <a:txBody>
+                    <a:bodyPr/>
+                    <a:lstStyle/>
+                    <a:p>
+                      <a:r>
+                        <a:rPr lang="de-DE" b="1" dirty="0"/>
+                        <a:t>0</a:t>
+                      </a:r>
+                      <a:endParaRPr lang="en-US" b="1" dirty="0"/>
+                    </a:p>
+                  </a:txBody>
+                  <a:tcPr/>
+                </a:tc>
+                <a:tc>
+                  <a:txBody>
+                    <a:bodyPr/>
+                    <a:lstStyle/>
+                    <a:p>
+                      <a:endParaRPr lang="en-US" dirty="0"/>
+                    </a:p>
+                  </a:txBody>
+                  <a:tcPr/>
+                </a:tc>
+                <a:extLst>
+                  <a:ext uri="{0D108BD9-81ED-4DB2-BD59-A6C34878D82A}">
+                    <a16:rowId xmlns:a16="http://schemas.microsoft.com/office/drawing/2014/main" val="2890694068"/>
+                  </a:ext>
+                </a:extLst>
+              </a:tr>
+              <a:tr h="1435100">
+                <a:tc>
+                  <a:txBody>
+                    <a:bodyPr/>
+                    <a:lstStyle/>
+                    <a:p>
+                      <a:r>
+                        <a:rPr lang="de-DE" b="1" dirty="0"/>
+                        <a:t>45</a:t>
+                      </a:r>
+                      <a:r>
+                        <a:rPr lang="de-DE" dirty="0"/>
+                        <a:t> </a:t>
+                      </a:r>
+                      <a:endParaRPr lang="en-US" dirty="0"/>
+                    </a:p>
+                  </a:txBody>
+                  <a:tcPr/>
+                </a:tc>
+                <a:tc>
+                  <a:txBody>
+                    <a:bodyPr/>
+                    <a:lstStyle/>
+                    <a:p>
+                      <a:r>
+                        <a:rPr lang="de-DE" dirty="0"/>
+                        <a:t>  </a:t>
+                      </a:r>
+                      <a:endParaRPr lang="en-US" dirty="0"/>
+                    </a:p>
+                  </a:txBody>
+                  <a:tcPr/>
+                </a:tc>
+                <a:tc>
+                  <a:txBody>
+                    <a:bodyPr/>
+                    <a:lstStyle/>
+                    <a:p>
+                      <a:pPr marL="0" marR="0" lvl="0" indent="0" algn="l" defTabSz="914400" rtl="0" eaLnBrk="1" fontAlgn="auto" latinLnBrk="0" hangingPunct="1">
+                        <a:lnSpc>
+                          <a:spcPct val="100000"/>
+                        </a:lnSpc>
+                        <a:spcBef>
+                          <a:spcPts val="0"/>
+                        </a:spcBef>
+                        <a:spcAft>
+                          <a:spcPts val="0"/>
+                        </a:spcAft>
+                        <a:buClrTx/>
+                        <a:buSzTx/>
+                        <a:buFontTx/>
+                        <a:buNone/>
+                        <a:tabLst/>
+                        <a:defRPr/>
+                      </a:pPr>
+                      <a:r>
+                        <a:rPr lang="en-US" sz="1800" b="1" kern="1200" dirty="0">
+                          <a:solidFill>
+                            <a:schemeClr val="dk1"/>
+                          </a:solidFill>
+                          <a:effectLst/>
+                          <a:latin typeface="+mn-lt"/>
+                          <a:ea typeface="+mn-ea"/>
+                          <a:cs typeface="+mn-cs"/>
+                        </a:rPr>
+                        <a:t>0.105</a:t>
+                      </a:r>
+                    </a:p>
+                    <a:p>
+                      <a:endParaRPr lang="en-US" dirty="0"/>
+                    </a:p>
+                  </a:txBody>
+                  <a:tcPr/>
+                </a:tc>
+                <a:tc>
+                  <a:txBody>
+                    <a:bodyPr/>
+                    <a:lstStyle/>
+                    <a:p>
+                      <a:endParaRPr lang="en-US"/>
+                    </a:p>
+                  </a:txBody>
+                  <a:tcPr/>
+                </a:tc>
+                <a:tc>
+                  <a:txBody>
+                    <a:bodyPr/>
+                    <a:lstStyle/>
+                    <a:p>
+                      <a:r>
+                        <a:rPr lang="de-DE" dirty="0"/>
+                        <a:t>30</a:t>
+                      </a:r>
+                      <a:endParaRPr lang="en-US" dirty="0"/>
+                    </a:p>
+                  </a:txBody>
+                  <a:tcPr/>
+                </a:tc>
+                <a:tc>
+                  <a:txBody>
+                    <a:bodyPr/>
+                    <a:lstStyle/>
+                    <a:p>
+                      <a:endParaRPr lang="en-US" dirty="0"/>
+                    </a:p>
+                  </a:txBody>
+                  <a:tcPr/>
+                </a:tc>
+                <a:extLst>
+                  <a:ext uri="{0D108BD9-81ED-4DB2-BD59-A6C34878D82A}">
+                    <a16:rowId xmlns:a16="http://schemas.microsoft.com/office/drawing/2014/main" val="2973891925"/>
+                  </a:ext>
+                </a:extLst>
+              </a:tr>
+              <a:tr h="1447800">
+                <a:tc>
+                  <a:txBody>
+                    <a:bodyPr/>
+                    <a:lstStyle/>
+                    <a:p>
+                      <a:r>
+                        <a:rPr lang="de-DE" dirty="0"/>
+                        <a:t>60</a:t>
+                      </a:r>
+                      <a:endParaRPr lang="en-US" dirty="0"/>
+                    </a:p>
+                  </a:txBody>
+                  <a:tcPr/>
+                </a:tc>
+                <a:tc>
+                  <a:txBody>
+                    <a:bodyPr/>
+                    <a:lstStyle/>
+                    <a:p>
+                      <a:endParaRPr lang="en-US" dirty="0"/>
+                    </a:p>
+                  </a:txBody>
+                  <a:tcPr/>
+                </a:tc>
+                <a:tc>
+                  <a:txBody>
+                    <a:bodyPr/>
+                    <a:lstStyle/>
+                    <a:p>
+                      <a:r>
+                        <a:rPr lang="de-DE" dirty="0"/>
+                        <a:t>0.13</a:t>
+                      </a:r>
+                      <a:endParaRPr lang="en-US" dirty="0"/>
+                    </a:p>
+                  </a:txBody>
+                  <a:tcPr/>
+                </a:tc>
+                <a:tc>
+                  <a:txBody>
+                    <a:bodyPr/>
+                    <a:lstStyle/>
+                    <a:p>
+                      <a:endParaRPr lang="en-US" dirty="0"/>
+                    </a:p>
+                  </a:txBody>
+                  <a:tcPr/>
+                </a:tc>
+                <a:tc>
+                  <a:txBody>
+                    <a:bodyPr/>
+                    <a:lstStyle/>
+                    <a:p>
+                      <a:r>
+                        <a:rPr lang="de-DE" dirty="0"/>
+                        <a:t>60</a:t>
+                      </a:r>
+                      <a:endParaRPr lang="en-US" dirty="0"/>
+                    </a:p>
+                  </a:txBody>
+                  <a:tcPr/>
+                </a:tc>
+                <a:tc>
+                  <a:txBody>
+                    <a:bodyPr/>
+                    <a:lstStyle/>
+                    <a:p>
+                      <a:endParaRPr lang="en-US" dirty="0"/>
+                    </a:p>
+                  </a:txBody>
+                  <a:tcPr/>
+                </a:tc>
+                <a:extLst>
+                  <a:ext uri="{0D108BD9-81ED-4DB2-BD59-A6C34878D82A}">
+                    <a16:rowId xmlns:a16="http://schemas.microsoft.com/office/drawing/2014/main" val="1821877328"/>
+                  </a:ext>
+                </a:extLst>
+              </a:tr>
+              <a:tr h="370840">
+                <a:tc>
+                  <a:txBody>
+                    <a:bodyPr/>
+                    <a:lstStyle/>
+                    <a:p>
+                      <a:endParaRPr lang="en-US" dirty="0"/>
+                    </a:p>
+                  </a:txBody>
+                  <a:tcPr/>
+                </a:tc>
+                <a:tc>
+                  <a:txBody>
+                    <a:bodyPr/>
+                    <a:lstStyle/>
+                    <a:p>
+                      <a:endParaRPr lang="en-US"/>
+                    </a:p>
+                  </a:txBody>
+                  <a:tcPr/>
+                </a:tc>
+                <a:tc>
+                  <a:txBody>
+                    <a:bodyPr/>
+                    <a:lstStyle/>
+                    <a:p>
+                      <a:endParaRPr lang="en-US" dirty="0"/>
+                    </a:p>
+                  </a:txBody>
+                  <a:tcPr/>
+                </a:tc>
+                <a:tc>
+                  <a:txBody>
+                    <a:bodyPr/>
+                    <a:lstStyle/>
+                    <a:p>
+                      <a:endParaRPr lang="en-US"/>
+                    </a:p>
+                  </a:txBody>
+                  <a:tcPr/>
+                </a:tc>
+                <a:tc>
+                  <a:txBody>
+                    <a:bodyPr/>
+                    <a:lstStyle/>
+                    <a:p>
+                      <a:r>
+                        <a:rPr lang="de-DE" dirty="0"/>
+                        <a:t>90</a:t>
+                      </a:r>
+                      <a:endParaRPr lang="en-US" dirty="0"/>
+                    </a:p>
+                  </a:txBody>
+                  <a:tcPr/>
+                </a:tc>
+                <a:tc>
+                  <a:txBody>
+                    <a:bodyPr/>
+                    <a:lstStyle/>
+                    <a:p>
+                      <a:endParaRPr lang="en-US" dirty="0"/>
+                    </a:p>
+                  </a:txBody>
+                  <a:tcPr/>
+                </a:tc>
+                <a:extLst>
+                  <a:ext uri="{0D108BD9-81ED-4DB2-BD59-A6C34878D82A}">
+                    <a16:rowId xmlns:a16="http://schemas.microsoft.com/office/drawing/2014/main" val="604584913"/>
+                  </a:ext>
+                </a:extLst>
+              </a:tr>
+              <a:tr h="370840">
+                <a:tc>
+                  <a:txBody>
+                    <a:bodyPr/>
+                    <a:lstStyle/>
+                    <a:p>
+                      <a:endParaRPr lang="en-US" dirty="0"/>
+                    </a:p>
+                  </a:txBody>
+                  <a:tcPr/>
+                </a:tc>
+                <a:tc>
+                  <a:txBody>
+                    <a:bodyPr/>
+                    <a:lstStyle/>
+                    <a:p>
+                      <a:endParaRPr lang="en-US"/>
+                    </a:p>
+                  </a:txBody>
+                  <a:tcPr/>
+                </a:tc>
+                <a:tc>
+                  <a:txBody>
+                    <a:bodyPr/>
+                    <a:lstStyle/>
+                    <a:p>
+                      <a:endParaRPr lang="en-US" dirty="0"/>
+                    </a:p>
+                  </a:txBody>
+                  <a:tcPr/>
+                </a:tc>
+                <a:tc>
+                  <a:txBody>
+                    <a:bodyPr/>
+                    <a:lstStyle/>
+                    <a:p>
+                      <a:endParaRPr lang="en-US"/>
+                    </a:p>
+                  </a:txBody>
+                  <a:tcPr/>
+                </a:tc>
+                <a:tc>
+                  <a:txBody>
+                    <a:bodyPr/>
+                    <a:lstStyle/>
+                    <a:p>
+                      <a:endParaRPr lang="en-US" dirty="0"/>
+                    </a:p>
+                  </a:txBody>
+                  <a:tcPr/>
+                </a:tc>
+                <a:tc>
+                  <a:txBody>
+                    <a:bodyPr/>
+                    <a:lstStyle/>
+                    <a:p>
+                      <a:endParaRPr lang="en-US" dirty="0"/>
+                    </a:p>
+                  </a:txBody>
+                  <a:tcPr/>
+                </a:tc>
+                <a:extLst>
+                  <a:ext uri="{0D108BD9-81ED-4DB2-BD59-A6C34878D82A}">
+                    <a16:rowId xmlns:a16="http://schemas.microsoft.com/office/drawing/2014/main" val="1553493888"/>
+                  </a:ext>
+                </a:extLst>
+              </a:tr>
+              <a:tr h="370840">
+                <a:tc>
+                  <a:txBody>
+                    <a:bodyPr/>
+                    <a:lstStyle/>
+                    <a:p>
+                      <a:endParaRPr lang="en-US" dirty="0"/>
+                    </a:p>
+                  </a:txBody>
+                  <a:tcPr/>
+                </a:tc>
+                <a:tc>
+                  <a:txBody>
+                    <a:bodyPr/>
+                    <a:lstStyle/>
+                    <a:p>
+                      <a:endParaRPr lang="en-US"/>
+                    </a:p>
+                  </a:txBody>
+                  <a:tcPr/>
+                </a:tc>
+                <a:tc>
+                  <a:txBody>
+                    <a:bodyPr/>
+                    <a:lstStyle/>
+                    <a:p>
+                      <a:endParaRPr lang="en-US" dirty="0"/>
+                    </a:p>
+                  </a:txBody>
+                  <a:tcPr/>
+                </a:tc>
+                <a:tc>
+                  <a:txBody>
+                    <a:bodyPr/>
+                    <a:lstStyle/>
+                    <a:p>
+                      <a:endParaRPr lang="en-US"/>
+                    </a:p>
+                  </a:txBody>
+                  <a:tcPr/>
+                </a:tc>
+                <a:tc>
+                  <a:txBody>
+                    <a:bodyPr/>
+                    <a:lstStyle/>
+                    <a:p>
+                      <a:endParaRPr lang="en-US" dirty="0"/>
+                    </a:p>
+                  </a:txBody>
+                  <a:tcPr/>
+                </a:tc>
+                <a:tc>
+                  <a:txBody>
+                    <a:bodyPr/>
+                    <a:lstStyle/>
+                    <a:p>
+                      <a:endParaRPr lang="en-US" dirty="0"/>
+                    </a:p>
+                  </a:txBody>
+                  <a:tcPr/>
+                </a:tc>
+                <a:extLst>
+                  <a:ext uri="{0D108BD9-81ED-4DB2-BD59-A6C34878D82A}">
+                    <a16:rowId xmlns:a16="http://schemas.microsoft.com/office/drawing/2014/main" val="773931318"/>
+                  </a:ext>
+                </a:extLst>
+              </a:tr>
+            </a:tbl>
+          </a:graphicData>
+        </a:graphic>
+      </p:graphicFrame>
+      <p:sp>
+        <p:nvSpPr>
+          <p:cNvPr id="3" name="TextBox 2">
+            <a:extLst>
+              <a:ext uri="{FF2B5EF4-FFF2-40B4-BE49-F238E27FC236}">
+                <a16:creationId xmlns:a16="http://schemas.microsoft.com/office/drawing/2014/main" id="{D2D19CD9-2BFE-4B1B-9401-122F254F2F48}"/>
+              </a:ext>
+            </a:extLst>
+          </p:cNvPr>
+          <p:cNvSpPr txBox="1"/>
+          <p:nvPr/>
+        </p:nvSpPr>
+        <p:spPr>
+          <a:xfrm>
+            <a:off x="304800" y="180340"/>
+            <a:ext cx="1899920" cy="923330"/>
+          </a:xfrm>
+          <a:prstGeom prst="rect">
+            <a:avLst/>
+          </a:prstGeom>
+          <a:noFill/>
+        </p:spPr>
+        <p:txBody>
+          <a:bodyPr wrap="square" rtlCol="0">
+            <a:spAutoFit/>
+          </a:bodyPr>
+          <a:lstStyle/>
+          <a:p>
+            <a:r>
+              <a:rPr lang="de-DE" dirty="0" err="1"/>
+              <a:t>For</a:t>
+            </a:r>
+            <a:r>
+              <a:rPr lang="de-DE" dirty="0"/>
+              <a:t> 10x10x10 </a:t>
+            </a:r>
+            <a:r>
+              <a:rPr lang="de-DE" dirty="0" err="1"/>
+              <a:t>crystal</a:t>
+            </a:r>
+            <a:r>
+              <a:rPr lang="de-DE" dirty="0"/>
+              <a:t>,</a:t>
+            </a:r>
+          </a:p>
+          <a:p>
+            <a:r>
+              <a:rPr lang="el-GR" dirty="0"/>
+              <a:t>ν0 = 2138.0</a:t>
+            </a:r>
+            <a:endParaRPr lang="en-US" dirty="0"/>
+          </a:p>
+        </p:txBody>
+      </p:sp>
+      <p:pic>
+        <p:nvPicPr>
+          <p:cNvPr id="14" name="Picture 13">
+            <a:extLst>
+              <a:ext uri="{FF2B5EF4-FFF2-40B4-BE49-F238E27FC236}">
+                <a16:creationId xmlns:a16="http://schemas.microsoft.com/office/drawing/2014/main" id="{D00E6BC8-26EC-45D2-806B-5D7697885A7B}"/>
+              </a:ext>
+            </a:extLst>
+          </p:cNvPr>
+          <p:cNvPicPr>
+            <a:picLocks noChangeAspect="1"/>
+          </p:cNvPicPr>
+          <p:nvPr/>
+        </p:nvPicPr>
+        <p:blipFill>
+          <a:blip r:embed="rId2"/>
+          <a:stretch>
+            <a:fillRect/>
+          </a:stretch>
+        </p:blipFill>
+        <p:spPr>
+          <a:xfrm>
+            <a:off x="3641529" y="2214229"/>
+            <a:ext cx="1711521" cy="1192321"/>
+          </a:xfrm>
+          <a:prstGeom prst="rect">
+            <a:avLst/>
+          </a:prstGeom>
+        </p:spPr>
+      </p:pic>
+      <p:pic>
+        <p:nvPicPr>
+          <p:cNvPr id="16" name="Picture 15">
+            <a:extLst>
+              <a:ext uri="{FF2B5EF4-FFF2-40B4-BE49-F238E27FC236}">
+                <a16:creationId xmlns:a16="http://schemas.microsoft.com/office/drawing/2014/main" id="{E0D5E128-F3D3-4B1A-8F85-4CBEAD8D2F9D}"/>
+              </a:ext>
+            </a:extLst>
+          </p:cNvPr>
+          <p:cNvPicPr>
+            <a:picLocks noChangeAspect="1"/>
+          </p:cNvPicPr>
+          <p:nvPr/>
+        </p:nvPicPr>
+        <p:blipFill>
+          <a:blip r:embed="rId3">
+            <a:extLst>
+              <a:ext uri="{28A0092B-C50C-407E-A947-70E740481C1C}">
+                <a14:useLocalDpi xmlns:a14="http://schemas.microsoft.com/office/drawing/2010/main" val="0"/>
+              </a:ext>
+            </a:extLst>
+          </a:blip>
+          <a:stretch>
+            <a:fillRect/>
+          </a:stretch>
+        </p:blipFill>
+        <p:spPr>
+          <a:xfrm>
+            <a:off x="3641529" y="750612"/>
+            <a:ext cx="1711520" cy="1193954"/>
+          </a:xfrm>
+          <a:prstGeom prst="rect">
+            <a:avLst/>
+          </a:prstGeom>
+        </p:spPr>
+      </p:pic>
+      <p:pic>
+        <p:nvPicPr>
+          <p:cNvPr id="18" name="Picture 17">
+            <a:extLst>
+              <a:ext uri="{FF2B5EF4-FFF2-40B4-BE49-F238E27FC236}">
+                <a16:creationId xmlns:a16="http://schemas.microsoft.com/office/drawing/2014/main" id="{13DB5669-FEE0-4F23-A1E9-C49B6BFF2683}"/>
+              </a:ext>
+            </a:extLst>
+          </p:cNvPr>
+          <p:cNvPicPr>
+            <a:picLocks noChangeAspect="1"/>
+          </p:cNvPicPr>
+          <p:nvPr/>
+        </p:nvPicPr>
+        <p:blipFill>
+          <a:blip r:embed="rId4">
+            <a:extLst>
+              <a:ext uri="{28A0092B-C50C-407E-A947-70E740481C1C}">
+                <a14:useLocalDpi xmlns:a14="http://schemas.microsoft.com/office/drawing/2010/main" val="0"/>
+              </a:ext>
+            </a:extLst>
+          </a:blip>
+          <a:stretch>
+            <a:fillRect/>
+          </a:stretch>
+        </p:blipFill>
+        <p:spPr>
+          <a:xfrm>
+            <a:off x="3641528" y="3676213"/>
+            <a:ext cx="1711520" cy="1193954"/>
+          </a:xfrm>
+          <a:prstGeom prst="rect">
+            <a:avLst/>
+          </a:prstGeom>
+        </p:spPr>
+      </p:pic>
+      <p:pic>
+        <p:nvPicPr>
+          <p:cNvPr id="19" name="Picture 18">
+            <a:extLst>
+              <a:ext uri="{FF2B5EF4-FFF2-40B4-BE49-F238E27FC236}">
+                <a16:creationId xmlns:a16="http://schemas.microsoft.com/office/drawing/2014/main" id="{A242B640-4856-4C09-A0FD-3CA25C4B4694}"/>
+              </a:ext>
+            </a:extLst>
+          </p:cNvPr>
+          <p:cNvPicPr>
+            <a:picLocks noChangeAspect="1"/>
+          </p:cNvPicPr>
+          <p:nvPr/>
+        </p:nvPicPr>
+        <p:blipFill>
+          <a:blip r:embed="rId2"/>
+          <a:stretch>
+            <a:fillRect/>
+          </a:stretch>
+        </p:blipFill>
+        <p:spPr>
+          <a:xfrm>
+            <a:off x="6762752" y="2214229"/>
+            <a:ext cx="1711521" cy="1192321"/>
+          </a:xfrm>
+          <a:prstGeom prst="rect">
+            <a:avLst/>
+          </a:prstGeom>
+        </p:spPr>
+      </p:pic>
+      <p:pic>
+        <p:nvPicPr>
+          <p:cNvPr id="21" name="Picture 20">
+            <a:extLst>
+              <a:ext uri="{FF2B5EF4-FFF2-40B4-BE49-F238E27FC236}">
+                <a16:creationId xmlns:a16="http://schemas.microsoft.com/office/drawing/2014/main" id="{3F40E265-619D-42F2-AC73-561A33CC4096}"/>
+              </a:ext>
+            </a:extLst>
+          </p:cNvPr>
+          <p:cNvPicPr>
+            <a:picLocks noChangeAspect="1"/>
+          </p:cNvPicPr>
+          <p:nvPr/>
+        </p:nvPicPr>
+        <p:blipFill>
+          <a:blip r:embed="rId5">
+            <a:extLst>
+              <a:ext uri="{28A0092B-C50C-407E-A947-70E740481C1C}">
+                <a14:useLocalDpi xmlns:a14="http://schemas.microsoft.com/office/drawing/2010/main" val="0"/>
+              </a:ext>
+            </a:extLst>
+          </a:blip>
+          <a:stretch>
+            <a:fillRect/>
+          </a:stretch>
+        </p:blipFill>
+        <p:spPr>
+          <a:xfrm>
+            <a:off x="6762753" y="750613"/>
+            <a:ext cx="1711520" cy="1193953"/>
+          </a:xfrm>
+          <a:prstGeom prst="rect">
+            <a:avLst/>
+          </a:prstGeom>
+        </p:spPr>
+      </p:pic>
+      <p:pic>
+        <p:nvPicPr>
+          <p:cNvPr id="23" name="Picture 22">
+            <a:extLst>
+              <a:ext uri="{FF2B5EF4-FFF2-40B4-BE49-F238E27FC236}">
+                <a16:creationId xmlns:a16="http://schemas.microsoft.com/office/drawing/2014/main" id="{64609F17-9DD6-4EFC-85EE-900EF6C94AA5}"/>
+              </a:ext>
+            </a:extLst>
+          </p:cNvPr>
+          <p:cNvPicPr>
+            <a:picLocks noChangeAspect="1"/>
+          </p:cNvPicPr>
+          <p:nvPr/>
+        </p:nvPicPr>
+        <p:blipFill>
+          <a:blip r:embed="rId6">
+            <a:extLst>
+              <a:ext uri="{28A0092B-C50C-407E-A947-70E740481C1C}">
+                <a14:useLocalDpi xmlns:a14="http://schemas.microsoft.com/office/drawing/2010/main" val="0"/>
+              </a:ext>
+            </a:extLst>
+          </a:blip>
+          <a:stretch>
+            <a:fillRect/>
+          </a:stretch>
+        </p:blipFill>
+        <p:spPr>
+          <a:xfrm>
+            <a:off x="6762752" y="3691564"/>
+            <a:ext cx="1709180" cy="1192321"/>
+          </a:xfrm>
+          <a:prstGeom prst="rect">
+            <a:avLst/>
+          </a:prstGeom>
+        </p:spPr>
+      </p:pic>
+      <p:pic>
+        <p:nvPicPr>
+          <p:cNvPr id="29" name="Picture 28">
+            <a:extLst>
+              <a:ext uri="{FF2B5EF4-FFF2-40B4-BE49-F238E27FC236}">
+                <a16:creationId xmlns:a16="http://schemas.microsoft.com/office/drawing/2014/main" id="{737FD9DC-5689-4A7A-9189-6CB7AA742601}"/>
+              </a:ext>
+            </a:extLst>
+          </p:cNvPr>
+          <p:cNvPicPr>
+            <a:picLocks noChangeAspect="1"/>
+          </p:cNvPicPr>
+          <p:nvPr/>
+        </p:nvPicPr>
+        <p:blipFill>
+          <a:blip r:embed="rId7">
+            <a:extLst>
+              <a:ext uri="{28A0092B-C50C-407E-A947-70E740481C1C}">
+                <a14:useLocalDpi xmlns:a14="http://schemas.microsoft.com/office/drawing/2010/main" val="0"/>
+              </a:ext>
+            </a:extLst>
+          </a:blip>
+          <a:stretch>
+            <a:fillRect/>
+          </a:stretch>
+        </p:blipFill>
+        <p:spPr>
+          <a:xfrm>
+            <a:off x="10063718" y="752245"/>
+            <a:ext cx="1709180" cy="1192321"/>
+          </a:xfrm>
+          <a:prstGeom prst="rect">
+            <a:avLst/>
+          </a:prstGeom>
+        </p:spPr>
+      </p:pic>
+      <p:pic>
+        <p:nvPicPr>
+          <p:cNvPr id="33" name="Picture 32">
+            <a:extLst>
+              <a:ext uri="{FF2B5EF4-FFF2-40B4-BE49-F238E27FC236}">
+                <a16:creationId xmlns:a16="http://schemas.microsoft.com/office/drawing/2014/main" id="{F29B43B1-1FD9-4FB5-8E83-6CF1EB26226E}"/>
+              </a:ext>
+            </a:extLst>
+          </p:cNvPr>
+          <p:cNvPicPr>
+            <a:picLocks noChangeAspect="1"/>
+          </p:cNvPicPr>
+          <p:nvPr/>
+        </p:nvPicPr>
+        <p:blipFill>
+          <a:blip r:embed="rId8">
+            <a:extLst>
+              <a:ext uri="{28A0092B-C50C-407E-A947-70E740481C1C}">
+                <a14:useLocalDpi xmlns:a14="http://schemas.microsoft.com/office/drawing/2010/main" val="0"/>
+              </a:ext>
+            </a:extLst>
+          </a:blip>
+          <a:stretch>
+            <a:fillRect/>
+          </a:stretch>
+        </p:blipFill>
+        <p:spPr>
+          <a:xfrm>
+            <a:off x="10063718" y="2214229"/>
+            <a:ext cx="1709180" cy="1192321"/>
+          </a:xfrm>
+          <a:prstGeom prst="rect">
+            <a:avLst/>
+          </a:prstGeom>
+        </p:spPr>
+      </p:pic>
+      <p:pic>
+        <p:nvPicPr>
+          <p:cNvPr id="37" name="Picture 36">
+            <a:extLst>
+              <a:ext uri="{FF2B5EF4-FFF2-40B4-BE49-F238E27FC236}">
+                <a16:creationId xmlns:a16="http://schemas.microsoft.com/office/drawing/2014/main" id="{0FCB0DFD-48E6-4F34-899F-7FED2E969AF8}"/>
+              </a:ext>
+            </a:extLst>
+          </p:cNvPr>
+          <p:cNvPicPr>
+            <a:picLocks noChangeAspect="1"/>
+          </p:cNvPicPr>
+          <p:nvPr/>
+        </p:nvPicPr>
+        <p:blipFill>
+          <a:blip r:embed="rId9">
+            <a:extLst>
+              <a:ext uri="{28A0092B-C50C-407E-A947-70E740481C1C}">
+                <a14:useLocalDpi xmlns:a14="http://schemas.microsoft.com/office/drawing/2010/main" val="0"/>
+              </a:ext>
+            </a:extLst>
+          </a:blip>
+          <a:stretch>
+            <a:fillRect/>
+          </a:stretch>
+        </p:blipFill>
+        <p:spPr>
+          <a:xfrm>
+            <a:off x="10061379" y="3691564"/>
+            <a:ext cx="1709180" cy="1192321"/>
+          </a:xfrm>
+          <a:prstGeom prst="rect">
+            <a:avLst/>
+          </a:prstGeom>
+        </p:spPr>
+      </p:pic>
+      <p:pic>
+        <p:nvPicPr>
+          <p:cNvPr id="39" name="Picture 38">
+            <a:extLst>
+              <a:ext uri="{FF2B5EF4-FFF2-40B4-BE49-F238E27FC236}">
+                <a16:creationId xmlns:a16="http://schemas.microsoft.com/office/drawing/2014/main" id="{D376920F-6513-4336-BCC1-7D6B872A781B}"/>
+              </a:ext>
+            </a:extLst>
+          </p:cNvPr>
+          <p:cNvPicPr>
+            <a:picLocks noChangeAspect="1"/>
+          </p:cNvPicPr>
+          <p:nvPr/>
+        </p:nvPicPr>
+        <p:blipFill>
+          <a:blip r:embed="rId10">
+            <a:extLst>
+              <a:ext uri="{28A0092B-C50C-407E-A947-70E740481C1C}">
+                <a14:useLocalDpi xmlns:a14="http://schemas.microsoft.com/office/drawing/2010/main" val="0"/>
+              </a:ext>
+            </a:extLst>
+          </a:blip>
+          <a:stretch>
+            <a:fillRect/>
+          </a:stretch>
+        </p:blipFill>
+        <p:spPr>
+          <a:xfrm>
+            <a:off x="10061378" y="5005785"/>
+            <a:ext cx="1709181" cy="1192321"/>
+          </a:xfrm>
+          <a:prstGeom prst="rect">
+            <a:avLst/>
+          </a:prstGeom>
+        </p:spPr>
+      </p:pic>
+      <mc:AlternateContent xmlns:mc="http://schemas.openxmlformats.org/markup-compatibility/2006">
+        <mc:Choice xmlns:a14="http://schemas.microsoft.com/office/drawing/2010/main" Requires="a14">
+          <p:sp>
+            <p:nvSpPr>
+              <p:cNvPr id="41" name="TextBox 40">
+                <a:extLst>
+                  <a:ext uri="{FF2B5EF4-FFF2-40B4-BE49-F238E27FC236}">
+                    <a16:creationId xmlns:a16="http://schemas.microsoft.com/office/drawing/2014/main" id="{88BB03CE-35E6-4800-877F-FC293445A98A}"/>
+                  </a:ext>
+                </a:extLst>
+              </p:cNvPr>
+              <p:cNvSpPr txBox="1"/>
+              <p:nvPr/>
+            </p:nvSpPr>
+            <p:spPr>
+              <a:xfrm>
+                <a:off x="238125" y="6394461"/>
+                <a:ext cx="9214446" cy="646331"/>
+              </a:xfrm>
+              <a:prstGeom prst="rect">
+                <a:avLst/>
+              </a:prstGeom>
+              <a:noFill/>
+            </p:spPr>
+            <p:txBody>
+              <a:bodyPr wrap="none" rtlCol="0">
+                <a:spAutoFit/>
+              </a:bodyPr>
+              <a:lstStyle/>
+              <a:p>
+                <a:r>
+                  <a:rPr lang="de-DE" dirty="0"/>
+                  <a:t>Choose Theta = 50°, </a:t>
+                </a:r>
+                <a14:m>
+                  <m:oMath xmlns:m="http://schemas.openxmlformats.org/officeDocument/2006/math">
+                    <m:r>
+                      <a:rPr lang="de-DE" b="0" i="1" smtClean="0">
+                        <a:latin typeface="Cambria Math" panose="02040503050406030204" pitchFamily="18" charset="0"/>
+                      </a:rPr>
+                      <m:t>𝛼</m:t>
+                    </m:r>
+                  </m:oMath>
+                </a14:m>
+                <a:r>
+                  <a:rPr lang="en-US" dirty="0"/>
+                  <a:t>=0 and µ01 increased to 0.195 (0.105 before) to match measured spectra</a:t>
+                </a:r>
+              </a:p>
+              <a:p>
+                <a:r>
+                  <a:rPr lang="en-US" dirty="0"/>
+                  <a:t> </a:t>
+                </a:r>
+              </a:p>
+            </p:txBody>
+          </p:sp>
+        </mc:Choice>
+        <mc:Fallback>
+          <p:sp>
+            <p:nvSpPr>
+              <p:cNvPr id="41" name="TextBox 40">
+                <a:extLst>
+                  <a:ext uri="{FF2B5EF4-FFF2-40B4-BE49-F238E27FC236}">
+                    <a16:creationId xmlns:a16="http://schemas.microsoft.com/office/drawing/2014/main" id="{88BB03CE-35E6-4800-877F-FC293445A98A}"/>
+                  </a:ext>
+                </a:extLst>
+              </p:cNvPr>
+              <p:cNvSpPr txBox="1">
+                <a:spLocks noRot="1" noChangeAspect="1" noMove="1" noResize="1" noEditPoints="1" noAdjustHandles="1" noChangeArrowheads="1" noChangeShapeType="1" noTextEdit="1"/>
+              </p:cNvSpPr>
+              <p:nvPr/>
+            </p:nvSpPr>
+            <p:spPr>
+              <a:xfrm>
+                <a:off x="238125" y="6394461"/>
+                <a:ext cx="9214446" cy="646331"/>
+              </a:xfrm>
+              <a:prstGeom prst="rect">
+                <a:avLst/>
+              </a:prstGeom>
+              <a:blipFill>
+                <a:blip r:embed="rId11"/>
+                <a:stretch>
+                  <a:fillRect l="-529" t="-5660"/>
                 </a:stretch>
               </a:blipFill>
             </p:spPr>
@@ -5528,7 +8728,7 @@
     </p:spTree>
     <p:extLst>
       <p:ext uri="{BB962C8B-B14F-4D97-AF65-F5344CB8AC3E}">
-        <p14:creationId xmlns:p14="http://schemas.microsoft.com/office/powerpoint/2010/main" val="1878570997"/>
+        <p14:creationId xmlns:p14="http://schemas.microsoft.com/office/powerpoint/2010/main" val="1224414736"/>
       </p:ext>
     </p:extLst>
   </p:cSld>

</xml_diff>

<commit_message>
Need more memory for computation. optimal incident angle found and 24x24y15 slab optimum for splitting
</commit_message>
<xml_diff>
--- a/exciton_CO.pptx
+++ b/exciton_CO.pptx
@@ -5,7 +5,7 @@
     <p:sldMasterId id="2147483648" r:id="rId1"/>
   </p:sldMasterIdLst>
   <p:notesMasterIdLst>
-    <p:notesMasterId r:id="rId16"/>
+    <p:notesMasterId r:id="rId25"/>
   </p:notesMasterIdLst>
   <p:sldIdLst>
     <p:sldId id="256" r:id="rId2"/>
@@ -22,6 +22,15 @@
     <p:sldId id="268" r:id="rId13"/>
     <p:sldId id="269" r:id="rId14"/>
     <p:sldId id="270" r:id="rId15"/>
+    <p:sldId id="271" r:id="rId16"/>
+    <p:sldId id="272" r:id="rId17"/>
+    <p:sldId id="273" r:id="rId18"/>
+    <p:sldId id="274" r:id="rId19"/>
+    <p:sldId id="275" r:id="rId20"/>
+    <p:sldId id="276" r:id="rId21"/>
+    <p:sldId id="277" r:id="rId22"/>
+    <p:sldId id="278" r:id="rId23"/>
+    <p:sldId id="279" r:id="rId24"/>
   </p:sldIdLst>
   <p:sldSz cx="12192000" cy="6858000"/>
   <p:notesSz cx="6858000" cy="9144000"/>
@@ -221,7 +230,7 @@
           <a:p>
             <a:fld id="{DB214083-9EE7-4E8F-81A4-DA52BC10460F}" type="datetimeFigureOut">
               <a:rPr lang="en-US" smtClean="0"/>
-              <a:t>12/5/2024</a:t>
+              <a:t>12/6/2024</a:t>
             </a:fld>
             <a:endParaRPr lang="en-US"/>
           </a:p>
@@ -880,6 +889,752 @@
 </p:notes>
 </file>
 
+<file path=ppt/notesSlides/notesSlide13.xml><?xml version="1.0" encoding="utf-8"?>
+<p:notes xmlns:a="http://schemas.openxmlformats.org/drawingml/2006/main" xmlns:r="http://schemas.openxmlformats.org/officeDocument/2006/relationships" xmlns:p="http://schemas.openxmlformats.org/presentationml/2006/main">
+  <p:cSld>
+    <p:spTree>
+      <p:nvGrpSpPr>
+        <p:cNvPr id="1" name=""/>
+        <p:cNvGrpSpPr/>
+        <p:nvPr/>
+      </p:nvGrpSpPr>
+      <p:grpSpPr>
+        <a:xfrm>
+          <a:off x="0" y="0"/>
+          <a:ext cx="0" cy="0"/>
+          <a:chOff x="0" y="0"/>
+          <a:chExt cx="0" cy="0"/>
+        </a:xfrm>
+      </p:grpSpPr>
+      <p:sp>
+        <p:nvSpPr>
+          <p:cNvPr id="2" name="Slide Image Placeholder 1"/>
+          <p:cNvSpPr>
+            <a:spLocks noGrp="1" noRot="1" noChangeAspect="1"/>
+          </p:cNvSpPr>
+          <p:nvPr>
+            <p:ph type="sldImg"/>
+          </p:nvPr>
+        </p:nvSpPr>
+        <p:spPr/>
+      </p:sp>
+      <p:sp>
+        <p:nvSpPr>
+          <p:cNvPr id="3" name="Notes Placeholder 2"/>
+          <p:cNvSpPr>
+            <a:spLocks noGrp="1"/>
+          </p:cNvSpPr>
+          <p:nvPr>
+            <p:ph type="body" idx="1"/>
+          </p:nvPr>
+        </p:nvSpPr>
+        <p:spPr/>
+        <p:txBody>
+          <a:bodyPr/>
+          <a:lstStyle/>
+          <a:p>
+            <a:r>
+              <a:rPr lang="de-DE" dirty="0"/>
+              <a:t>~7 </a:t>
+            </a:r>
+            <a:r>
+              <a:rPr lang="de-DE" dirty="0" err="1"/>
+              <a:t>mins</a:t>
+            </a:r>
+            <a:r>
+              <a:rPr lang="de-DE" dirty="0"/>
+              <a:t> </a:t>
+            </a:r>
+            <a:endParaRPr lang="en-US" dirty="0"/>
+          </a:p>
+        </p:txBody>
+      </p:sp>
+      <p:sp>
+        <p:nvSpPr>
+          <p:cNvPr id="4" name="Slide Number Placeholder 3"/>
+          <p:cNvSpPr>
+            <a:spLocks noGrp="1"/>
+          </p:cNvSpPr>
+          <p:nvPr>
+            <p:ph type="sldNum" sz="quarter" idx="5"/>
+          </p:nvPr>
+        </p:nvSpPr>
+        <p:spPr/>
+        <p:txBody>
+          <a:bodyPr/>
+          <a:lstStyle/>
+          <a:p>
+            <a:fld id="{C3ADA3BE-8651-44EF-90D8-D9C485CA2681}" type="slidenum">
+              <a:rPr lang="en-US" smtClean="0"/>
+              <a:t>15</a:t>
+            </a:fld>
+            <a:endParaRPr lang="en-US"/>
+          </a:p>
+        </p:txBody>
+      </p:sp>
+    </p:spTree>
+    <p:extLst>
+      <p:ext uri="{BB962C8B-B14F-4D97-AF65-F5344CB8AC3E}">
+        <p14:creationId xmlns:p14="http://schemas.microsoft.com/office/powerpoint/2010/main" val="1958734381"/>
+      </p:ext>
+    </p:extLst>
+  </p:cSld>
+  <p:clrMapOvr>
+    <a:masterClrMapping/>
+  </p:clrMapOvr>
+</p:notes>
+</file>
+
+<file path=ppt/notesSlides/notesSlide14.xml><?xml version="1.0" encoding="utf-8"?>
+<p:notes xmlns:a="http://schemas.openxmlformats.org/drawingml/2006/main" xmlns:r="http://schemas.openxmlformats.org/officeDocument/2006/relationships" xmlns:p="http://schemas.openxmlformats.org/presentationml/2006/main">
+  <p:cSld>
+    <p:spTree>
+      <p:nvGrpSpPr>
+        <p:cNvPr id="1" name=""/>
+        <p:cNvGrpSpPr/>
+        <p:nvPr/>
+      </p:nvGrpSpPr>
+      <p:grpSpPr>
+        <a:xfrm>
+          <a:off x="0" y="0"/>
+          <a:ext cx="0" cy="0"/>
+          <a:chOff x="0" y="0"/>
+          <a:chExt cx="0" cy="0"/>
+        </a:xfrm>
+      </p:grpSpPr>
+      <p:sp>
+        <p:nvSpPr>
+          <p:cNvPr id="2" name="Slide Image Placeholder 1"/>
+          <p:cNvSpPr>
+            <a:spLocks noGrp="1" noRot="1" noChangeAspect="1"/>
+          </p:cNvSpPr>
+          <p:nvPr>
+            <p:ph type="sldImg"/>
+          </p:nvPr>
+        </p:nvSpPr>
+        <p:spPr/>
+      </p:sp>
+      <p:sp>
+        <p:nvSpPr>
+          <p:cNvPr id="3" name="Notes Placeholder 2"/>
+          <p:cNvSpPr>
+            <a:spLocks noGrp="1"/>
+          </p:cNvSpPr>
+          <p:nvPr>
+            <p:ph type="body" idx="1"/>
+          </p:nvPr>
+        </p:nvSpPr>
+        <p:spPr/>
+        <p:txBody>
+          <a:bodyPr/>
+          <a:lstStyle/>
+          <a:p>
+            <a:r>
+              <a:rPr lang="de-DE" dirty="0"/>
+              <a:t>~20 </a:t>
+            </a:r>
+            <a:r>
+              <a:rPr lang="de-DE" dirty="0" err="1"/>
+              <a:t>mins</a:t>
+            </a:r>
+            <a:r>
+              <a:rPr lang="de-DE" dirty="0"/>
+              <a:t> </a:t>
+            </a:r>
+            <a:endParaRPr lang="en-US" dirty="0"/>
+          </a:p>
+        </p:txBody>
+      </p:sp>
+      <p:sp>
+        <p:nvSpPr>
+          <p:cNvPr id="4" name="Slide Number Placeholder 3"/>
+          <p:cNvSpPr>
+            <a:spLocks noGrp="1"/>
+          </p:cNvSpPr>
+          <p:nvPr>
+            <p:ph type="sldNum" sz="quarter" idx="5"/>
+          </p:nvPr>
+        </p:nvSpPr>
+        <p:spPr/>
+        <p:txBody>
+          <a:bodyPr/>
+          <a:lstStyle/>
+          <a:p>
+            <a:fld id="{C3ADA3BE-8651-44EF-90D8-D9C485CA2681}" type="slidenum">
+              <a:rPr lang="en-US" smtClean="0"/>
+              <a:t>16</a:t>
+            </a:fld>
+            <a:endParaRPr lang="en-US"/>
+          </a:p>
+        </p:txBody>
+      </p:sp>
+    </p:spTree>
+    <p:extLst>
+      <p:ext uri="{BB962C8B-B14F-4D97-AF65-F5344CB8AC3E}">
+        <p14:creationId xmlns:p14="http://schemas.microsoft.com/office/powerpoint/2010/main" val="3080463306"/>
+      </p:ext>
+    </p:extLst>
+  </p:cSld>
+  <p:clrMapOvr>
+    <a:masterClrMapping/>
+  </p:clrMapOvr>
+</p:notes>
+</file>
+
+<file path=ppt/notesSlides/notesSlide15.xml><?xml version="1.0" encoding="utf-8"?>
+<p:notes xmlns:a="http://schemas.openxmlformats.org/drawingml/2006/main" xmlns:r="http://schemas.openxmlformats.org/officeDocument/2006/relationships" xmlns:p="http://schemas.openxmlformats.org/presentationml/2006/main">
+  <p:cSld>
+    <p:spTree>
+      <p:nvGrpSpPr>
+        <p:cNvPr id="1" name=""/>
+        <p:cNvGrpSpPr/>
+        <p:nvPr/>
+      </p:nvGrpSpPr>
+      <p:grpSpPr>
+        <a:xfrm>
+          <a:off x="0" y="0"/>
+          <a:ext cx="0" cy="0"/>
+          <a:chOff x="0" y="0"/>
+          <a:chExt cx="0" cy="0"/>
+        </a:xfrm>
+      </p:grpSpPr>
+      <p:sp>
+        <p:nvSpPr>
+          <p:cNvPr id="2" name="Slide Image Placeholder 1"/>
+          <p:cNvSpPr>
+            <a:spLocks noGrp="1" noRot="1" noChangeAspect="1"/>
+          </p:cNvSpPr>
+          <p:nvPr>
+            <p:ph type="sldImg"/>
+          </p:nvPr>
+        </p:nvSpPr>
+        <p:spPr/>
+      </p:sp>
+      <p:sp>
+        <p:nvSpPr>
+          <p:cNvPr id="3" name="Notes Placeholder 2"/>
+          <p:cNvSpPr>
+            <a:spLocks noGrp="1"/>
+          </p:cNvSpPr>
+          <p:nvPr>
+            <p:ph type="body" idx="1"/>
+          </p:nvPr>
+        </p:nvSpPr>
+        <p:spPr/>
+        <p:txBody>
+          <a:bodyPr/>
+          <a:lstStyle/>
+          <a:p>
+            <a:r>
+              <a:rPr lang="de-DE" dirty="0"/>
+              <a:t>~43 </a:t>
+            </a:r>
+            <a:r>
+              <a:rPr lang="de-DE" dirty="0" err="1"/>
+              <a:t>mins</a:t>
+            </a:r>
+            <a:r>
+              <a:rPr lang="de-DE" dirty="0"/>
+              <a:t> </a:t>
+            </a:r>
+            <a:endParaRPr lang="en-US" dirty="0"/>
+          </a:p>
+        </p:txBody>
+      </p:sp>
+      <p:sp>
+        <p:nvSpPr>
+          <p:cNvPr id="4" name="Slide Number Placeholder 3"/>
+          <p:cNvSpPr>
+            <a:spLocks noGrp="1"/>
+          </p:cNvSpPr>
+          <p:nvPr>
+            <p:ph type="sldNum" sz="quarter" idx="5"/>
+          </p:nvPr>
+        </p:nvSpPr>
+        <p:spPr/>
+        <p:txBody>
+          <a:bodyPr/>
+          <a:lstStyle/>
+          <a:p>
+            <a:fld id="{C3ADA3BE-8651-44EF-90D8-D9C485CA2681}" type="slidenum">
+              <a:rPr lang="en-US" smtClean="0"/>
+              <a:t>17</a:t>
+            </a:fld>
+            <a:endParaRPr lang="en-US"/>
+          </a:p>
+        </p:txBody>
+      </p:sp>
+    </p:spTree>
+    <p:extLst>
+      <p:ext uri="{BB962C8B-B14F-4D97-AF65-F5344CB8AC3E}">
+        <p14:creationId xmlns:p14="http://schemas.microsoft.com/office/powerpoint/2010/main" val="2994600679"/>
+      </p:ext>
+    </p:extLst>
+  </p:cSld>
+  <p:clrMapOvr>
+    <a:masterClrMapping/>
+  </p:clrMapOvr>
+</p:notes>
+</file>
+
+<file path=ppt/notesSlides/notesSlide16.xml><?xml version="1.0" encoding="utf-8"?>
+<p:notes xmlns:a="http://schemas.openxmlformats.org/drawingml/2006/main" xmlns:r="http://schemas.openxmlformats.org/officeDocument/2006/relationships" xmlns:p="http://schemas.openxmlformats.org/presentationml/2006/main">
+  <p:cSld>
+    <p:spTree>
+      <p:nvGrpSpPr>
+        <p:cNvPr id="1" name=""/>
+        <p:cNvGrpSpPr/>
+        <p:nvPr/>
+      </p:nvGrpSpPr>
+      <p:grpSpPr>
+        <a:xfrm>
+          <a:off x="0" y="0"/>
+          <a:ext cx="0" cy="0"/>
+          <a:chOff x="0" y="0"/>
+          <a:chExt cx="0" cy="0"/>
+        </a:xfrm>
+      </p:grpSpPr>
+      <p:sp>
+        <p:nvSpPr>
+          <p:cNvPr id="2" name="Slide Image Placeholder 1"/>
+          <p:cNvSpPr>
+            <a:spLocks noGrp="1" noRot="1" noChangeAspect="1"/>
+          </p:cNvSpPr>
+          <p:nvPr>
+            <p:ph type="sldImg"/>
+          </p:nvPr>
+        </p:nvSpPr>
+        <p:spPr/>
+      </p:sp>
+      <p:sp>
+        <p:nvSpPr>
+          <p:cNvPr id="3" name="Notes Placeholder 2"/>
+          <p:cNvSpPr>
+            <a:spLocks noGrp="1"/>
+          </p:cNvSpPr>
+          <p:nvPr>
+            <p:ph type="body" idx="1"/>
+          </p:nvPr>
+        </p:nvSpPr>
+        <p:spPr/>
+        <p:txBody>
+          <a:bodyPr/>
+          <a:lstStyle/>
+          <a:p>
+            <a:r>
+              <a:rPr lang="de-DE" dirty="0"/>
+              <a:t>~45 </a:t>
+            </a:r>
+            <a:r>
+              <a:rPr lang="de-DE" dirty="0" err="1"/>
+              <a:t>mins</a:t>
+            </a:r>
+            <a:r>
+              <a:rPr lang="de-DE" dirty="0"/>
+              <a:t> </a:t>
+            </a:r>
+            <a:endParaRPr lang="en-US" dirty="0"/>
+          </a:p>
+        </p:txBody>
+      </p:sp>
+      <p:sp>
+        <p:nvSpPr>
+          <p:cNvPr id="4" name="Slide Number Placeholder 3"/>
+          <p:cNvSpPr>
+            <a:spLocks noGrp="1"/>
+          </p:cNvSpPr>
+          <p:nvPr>
+            <p:ph type="sldNum" sz="quarter" idx="5"/>
+          </p:nvPr>
+        </p:nvSpPr>
+        <p:spPr/>
+        <p:txBody>
+          <a:bodyPr/>
+          <a:lstStyle/>
+          <a:p>
+            <a:fld id="{C3ADA3BE-8651-44EF-90D8-D9C485CA2681}" type="slidenum">
+              <a:rPr lang="en-US" smtClean="0"/>
+              <a:t>18</a:t>
+            </a:fld>
+            <a:endParaRPr lang="en-US"/>
+          </a:p>
+        </p:txBody>
+      </p:sp>
+    </p:spTree>
+    <p:extLst>
+      <p:ext uri="{BB962C8B-B14F-4D97-AF65-F5344CB8AC3E}">
+        <p14:creationId xmlns:p14="http://schemas.microsoft.com/office/powerpoint/2010/main" val="2740820281"/>
+      </p:ext>
+    </p:extLst>
+  </p:cSld>
+  <p:clrMapOvr>
+    <a:masterClrMapping/>
+  </p:clrMapOvr>
+</p:notes>
+</file>
+
+<file path=ppt/notesSlides/notesSlide17.xml><?xml version="1.0" encoding="utf-8"?>
+<p:notes xmlns:a="http://schemas.openxmlformats.org/drawingml/2006/main" xmlns:r="http://schemas.openxmlformats.org/officeDocument/2006/relationships" xmlns:p="http://schemas.openxmlformats.org/presentationml/2006/main">
+  <p:cSld>
+    <p:spTree>
+      <p:nvGrpSpPr>
+        <p:cNvPr id="1" name=""/>
+        <p:cNvGrpSpPr/>
+        <p:nvPr/>
+      </p:nvGrpSpPr>
+      <p:grpSpPr>
+        <a:xfrm>
+          <a:off x="0" y="0"/>
+          <a:ext cx="0" cy="0"/>
+          <a:chOff x="0" y="0"/>
+          <a:chExt cx="0" cy="0"/>
+        </a:xfrm>
+      </p:grpSpPr>
+      <p:sp>
+        <p:nvSpPr>
+          <p:cNvPr id="2" name="Slide Image Placeholder 1"/>
+          <p:cNvSpPr>
+            <a:spLocks noGrp="1" noRot="1" noChangeAspect="1"/>
+          </p:cNvSpPr>
+          <p:nvPr>
+            <p:ph type="sldImg"/>
+          </p:nvPr>
+        </p:nvSpPr>
+        <p:spPr/>
+      </p:sp>
+      <p:sp>
+        <p:nvSpPr>
+          <p:cNvPr id="3" name="Notes Placeholder 2"/>
+          <p:cNvSpPr>
+            <a:spLocks noGrp="1"/>
+          </p:cNvSpPr>
+          <p:nvPr>
+            <p:ph type="body" idx="1"/>
+          </p:nvPr>
+        </p:nvSpPr>
+        <p:spPr/>
+        <p:txBody>
+          <a:bodyPr/>
+          <a:lstStyle/>
+          <a:p>
+            <a:r>
+              <a:rPr lang="de-DE" dirty="0"/>
+              <a:t>~38 </a:t>
+            </a:r>
+            <a:r>
+              <a:rPr lang="de-DE" dirty="0" err="1"/>
+              <a:t>mins</a:t>
+            </a:r>
+            <a:r>
+              <a:rPr lang="de-DE" dirty="0"/>
+              <a:t> </a:t>
+            </a:r>
+          </a:p>
+          <a:p>
+            <a:endParaRPr lang="de-DE" dirty="0"/>
+          </a:p>
+          <a:p>
+            <a:pPr marL="0" marR="0" lvl="0" indent="0" algn="l" defTabSz="914400" rtl="0" eaLnBrk="1" fontAlgn="auto" latinLnBrk="0" hangingPunct="1">
+              <a:lnSpc>
+                <a:spcPct val="100000"/>
+              </a:lnSpc>
+              <a:spcBef>
+                <a:spcPts val="0"/>
+              </a:spcBef>
+              <a:spcAft>
+                <a:spcPts val="0"/>
+              </a:spcAft>
+              <a:buClrTx/>
+              <a:buSzTx/>
+              <a:buFontTx/>
+              <a:buNone/>
+              <a:tabLst/>
+              <a:defRPr/>
+            </a:pPr>
+            <a:r>
+              <a:rPr lang="de-DE" dirty="0"/>
+              <a:t>Best </a:t>
+            </a:r>
+            <a:r>
+              <a:rPr lang="de-DE" dirty="0" err="1"/>
+              <a:t>would</a:t>
+            </a:r>
+            <a:r>
+              <a:rPr lang="de-DE" dirty="0"/>
+              <a:t> </a:t>
+            </a:r>
+            <a:r>
+              <a:rPr lang="de-DE" dirty="0" err="1"/>
+              <a:t>be</a:t>
+            </a:r>
+            <a:r>
+              <a:rPr lang="de-DE" dirty="0"/>
+              <a:t> </a:t>
+            </a:r>
+            <a:r>
+              <a:rPr lang="de-DE" dirty="0" err="1"/>
+              <a:t>somehting</a:t>
+            </a:r>
+            <a:r>
+              <a:rPr lang="de-DE" dirty="0"/>
+              <a:t> like 15.5 -&gt; </a:t>
+            </a:r>
+            <a:r>
+              <a:rPr lang="de-DE" dirty="0" err="1"/>
+              <a:t>only</a:t>
+            </a:r>
+            <a:r>
+              <a:rPr lang="de-DE" dirty="0"/>
+              <a:t> </a:t>
+            </a:r>
+            <a:r>
+              <a:rPr lang="de-DE" dirty="0" err="1"/>
+              <a:t>integers</a:t>
+            </a:r>
+            <a:r>
+              <a:rPr lang="de-DE" dirty="0"/>
+              <a:t> possible -&gt; 48x48x30 </a:t>
+            </a:r>
+            <a:r>
+              <a:rPr lang="de-DE" dirty="0" err="1"/>
+              <a:t>is</a:t>
+            </a:r>
+            <a:r>
+              <a:rPr lang="de-DE" dirty="0"/>
+              <a:t> </a:t>
+            </a:r>
+            <a:r>
+              <a:rPr lang="de-DE" dirty="0" err="1"/>
+              <a:t>good</a:t>
+            </a:r>
+            <a:r>
+              <a:rPr lang="de-DE" dirty="0"/>
+              <a:t> but </a:t>
+            </a:r>
+            <a:r>
+              <a:rPr lang="de-DE" dirty="0" err="1"/>
+              <a:t>computationally</a:t>
+            </a:r>
+            <a:r>
+              <a:rPr lang="de-DE" dirty="0"/>
+              <a:t> </a:t>
+            </a:r>
+            <a:r>
+              <a:rPr lang="de-DE" dirty="0" err="1"/>
+              <a:t>too</a:t>
+            </a:r>
+            <a:r>
+              <a:rPr lang="de-DE" dirty="0"/>
+              <a:t> expansive.</a:t>
+            </a:r>
+            <a:endParaRPr lang="en-US" dirty="0"/>
+          </a:p>
+        </p:txBody>
+      </p:sp>
+      <p:sp>
+        <p:nvSpPr>
+          <p:cNvPr id="4" name="Slide Number Placeholder 3"/>
+          <p:cNvSpPr>
+            <a:spLocks noGrp="1"/>
+          </p:cNvSpPr>
+          <p:nvPr>
+            <p:ph type="sldNum" sz="quarter" idx="5"/>
+          </p:nvPr>
+        </p:nvSpPr>
+        <p:spPr/>
+        <p:txBody>
+          <a:bodyPr/>
+          <a:lstStyle/>
+          <a:p>
+            <a:fld id="{C3ADA3BE-8651-44EF-90D8-D9C485CA2681}" type="slidenum">
+              <a:rPr lang="en-US" smtClean="0"/>
+              <a:t>19</a:t>
+            </a:fld>
+            <a:endParaRPr lang="en-US"/>
+          </a:p>
+        </p:txBody>
+      </p:sp>
+    </p:spTree>
+    <p:extLst>
+      <p:ext uri="{BB962C8B-B14F-4D97-AF65-F5344CB8AC3E}">
+        <p14:creationId xmlns:p14="http://schemas.microsoft.com/office/powerpoint/2010/main" val="98727384"/>
+      </p:ext>
+    </p:extLst>
+  </p:cSld>
+  <p:clrMapOvr>
+    <a:masterClrMapping/>
+  </p:clrMapOvr>
+</p:notes>
+</file>
+
+<file path=ppt/notesSlides/notesSlide18.xml><?xml version="1.0" encoding="utf-8"?>
+<p:notes xmlns:a="http://schemas.openxmlformats.org/drawingml/2006/main" xmlns:r="http://schemas.openxmlformats.org/officeDocument/2006/relationships" xmlns:p="http://schemas.openxmlformats.org/presentationml/2006/main">
+  <p:cSld>
+    <p:spTree>
+      <p:nvGrpSpPr>
+        <p:cNvPr id="1" name=""/>
+        <p:cNvGrpSpPr/>
+        <p:nvPr/>
+      </p:nvGrpSpPr>
+      <p:grpSpPr>
+        <a:xfrm>
+          <a:off x="0" y="0"/>
+          <a:ext cx="0" cy="0"/>
+          <a:chOff x="0" y="0"/>
+          <a:chExt cx="0" cy="0"/>
+        </a:xfrm>
+      </p:grpSpPr>
+      <p:sp>
+        <p:nvSpPr>
+          <p:cNvPr id="2" name="Slide Image Placeholder 1"/>
+          <p:cNvSpPr>
+            <a:spLocks noGrp="1" noRot="1" noChangeAspect="1"/>
+          </p:cNvSpPr>
+          <p:nvPr>
+            <p:ph type="sldImg"/>
+          </p:nvPr>
+        </p:nvSpPr>
+        <p:spPr/>
+      </p:sp>
+      <p:sp>
+        <p:nvSpPr>
+          <p:cNvPr id="3" name="Notes Placeholder 2"/>
+          <p:cNvSpPr>
+            <a:spLocks noGrp="1"/>
+          </p:cNvSpPr>
+          <p:nvPr>
+            <p:ph type="body" idx="1"/>
+          </p:nvPr>
+        </p:nvSpPr>
+        <p:spPr/>
+        <p:txBody>
+          <a:bodyPr/>
+          <a:lstStyle/>
+          <a:p>
+            <a:endParaRPr lang="en-US" dirty="0"/>
+          </a:p>
+        </p:txBody>
+      </p:sp>
+      <p:sp>
+        <p:nvSpPr>
+          <p:cNvPr id="4" name="Slide Number Placeholder 3"/>
+          <p:cNvSpPr>
+            <a:spLocks noGrp="1"/>
+          </p:cNvSpPr>
+          <p:nvPr>
+            <p:ph type="sldNum" sz="quarter" idx="5"/>
+          </p:nvPr>
+        </p:nvSpPr>
+        <p:spPr/>
+        <p:txBody>
+          <a:bodyPr/>
+          <a:lstStyle/>
+          <a:p>
+            <a:fld id="{C3ADA3BE-8651-44EF-90D8-D9C485CA2681}" type="slidenum">
+              <a:rPr lang="en-US" smtClean="0"/>
+              <a:t>20</a:t>
+            </a:fld>
+            <a:endParaRPr lang="en-US"/>
+          </a:p>
+        </p:txBody>
+      </p:sp>
+    </p:spTree>
+    <p:extLst>
+      <p:ext uri="{BB962C8B-B14F-4D97-AF65-F5344CB8AC3E}">
+        <p14:creationId xmlns:p14="http://schemas.microsoft.com/office/powerpoint/2010/main" val="3110902176"/>
+      </p:ext>
+    </p:extLst>
+  </p:cSld>
+  <p:clrMapOvr>
+    <a:masterClrMapping/>
+  </p:clrMapOvr>
+</p:notes>
+</file>
+
+<file path=ppt/notesSlides/notesSlide19.xml><?xml version="1.0" encoding="utf-8"?>
+<p:notes xmlns:a="http://schemas.openxmlformats.org/drawingml/2006/main" xmlns:r="http://schemas.openxmlformats.org/officeDocument/2006/relationships" xmlns:p="http://schemas.openxmlformats.org/presentationml/2006/main">
+  <p:cSld>
+    <p:spTree>
+      <p:nvGrpSpPr>
+        <p:cNvPr id="1" name=""/>
+        <p:cNvGrpSpPr/>
+        <p:nvPr/>
+      </p:nvGrpSpPr>
+      <p:grpSpPr>
+        <a:xfrm>
+          <a:off x="0" y="0"/>
+          <a:ext cx="0" cy="0"/>
+          <a:chOff x="0" y="0"/>
+          <a:chExt cx="0" cy="0"/>
+        </a:xfrm>
+      </p:grpSpPr>
+      <p:sp>
+        <p:nvSpPr>
+          <p:cNvPr id="2" name="Slide Image Placeholder 1"/>
+          <p:cNvSpPr>
+            <a:spLocks noGrp="1" noRot="1" noChangeAspect="1"/>
+          </p:cNvSpPr>
+          <p:nvPr>
+            <p:ph type="sldImg"/>
+          </p:nvPr>
+        </p:nvSpPr>
+        <p:spPr/>
+      </p:sp>
+      <p:sp>
+        <p:nvSpPr>
+          <p:cNvPr id="3" name="Notes Placeholder 2"/>
+          <p:cNvSpPr>
+            <a:spLocks noGrp="1"/>
+          </p:cNvSpPr>
+          <p:nvPr>
+            <p:ph type="body" idx="1"/>
+          </p:nvPr>
+        </p:nvSpPr>
+        <p:spPr/>
+        <p:txBody>
+          <a:bodyPr/>
+          <a:lstStyle/>
+          <a:p>
+            <a:endParaRPr lang="en-US" dirty="0"/>
+          </a:p>
+        </p:txBody>
+      </p:sp>
+      <p:sp>
+        <p:nvSpPr>
+          <p:cNvPr id="4" name="Slide Number Placeholder 3"/>
+          <p:cNvSpPr>
+            <a:spLocks noGrp="1"/>
+          </p:cNvSpPr>
+          <p:nvPr>
+            <p:ph type="sldNum" sz="quarter" idx="5"/>
+          </p:nvPr>
+        </p:nvSpPr>
+        <p:spPr/>
+        <p:txBody>
+          <a:bodyPr/>
+          <a:lstStyle/>
+          <a:p>
+            <a:fld id="{C3ADA3BE-8651-44EF-90D8-D9C485CA2681}" type="slidenum">
+              <a:rPr lang="en-US" smtClean="0"/>
+              <a:t>21</a:t>
+            </a:fld>
+            <a:endParaRPr lang="en-US"/>
+          </a:p>
+        </p:txBody>
+      </p:sp>
+    </p:spTree>
+    <p:extLst>
+      <p:ext uri="{BB962C8B-B14F-4D97-AF65-F5344CB8AC3E}">
+        <p14:creationId xmlns:p14="http://schemas.microsoft.com/office/powerpoint/2010/main" val="1001239190"/>
+      </p:ext>
+    </p:extLst>
+  </p:cSld>
+  <p:clrMapOvr>
+    <a:masterClrMapping/>
+  </p:clrMapOvr>
+</p:notes>
+</file>
+
 <file path=ppt/notesSlides/notesSlide2.xml><?xml version="1.0" encoding="utf-8"?>
 <p:notes xmlns:a="http://schemas.openxmlformats.org/drawingml/2006/main" xmlns:r="http://schemas.openxmlformats.org/officeDocument/2006/relationships" xmlns:p="http://schemas.openxmlformats.org/presentationml/2006/main">
   <p:cSld>
@@ -971,6 +1726,174 @@
     <p:extLst>
       <p:ext uri="{BB962C8B-B14F-4D97-AF65-F5344CB8AC3E}">
         <p14:creationId xmlns:p14="http://schemas.microsoft.com/office/powerpoint/2010/main" val="1156489575"/>
+      </p:ext>
+    </p:extLst>
+  </p:cSld>
+  <p:clrMapOvr>
+    <a:masterClrMapping/>
+  </p:clrMapOvr>
+</p:notes>
+</file>
+
+<file path=ppt/notesSlides/notesSlide20.xml><?xml version="1.0" encoding="utf-8"?>
+<p:notes xmlns:a="http://schemas.openxmlformats.org/drawingml/2006/main" xmlns:r="http://schemas.openxmlformats.org/officeDocument/2006/relationships" xmlns:p="http://schemas.openxmlformats.org/presentationml/2006/main">
+  <p:cSld>
+    <p:spTree>
+      <p:nvGrpSpPr>
+        <p:cNvPr id="1" name=""/>
+        <p:cNvGrpSpPr/>
+        <p:nvPr/>
+      </p:nvGrpSpPr>
+      <p:grpSpPr>
+        <a:xfrm>
+          <a:off x="0" y="0"/>
+          <a:ext cx="0" cy="0"/>
+          <a:chOff x="0" y="0"/>
+          <a:chExt cx="0" cy="0"/>
+        </a:xfrm>
+      </p:grpSpPr>
+      <p:sp>
+        <p:nvSpPr>
+          <p:cNvPr id="2" name="Slide Image Placeholder 1"/>
+          <p:cNvSpPr>
+            <a:spLocks noGrp="1" noRot="1" noChangeAspect="1"/>
+          </p:cNvSpPr>
+          <p:nvPr>
+            <p:ph type="sldImg"/>
+          </p:nvPr>
+        </p:nvSpPr>
+        <p:spPr/>
+      </p:sp>
+      <p:sp>
+        <p:nvSpPr>
+          <p:cNvPr id="3" name="Notes Placeholder 2"/>
+          <p:cNvSpPr>
+            <a:spLocks noGrp="1"/>
+          </p:cNvSpPr>
+          <p:nvPr>
+            <p:ph type="body" idx="1"/>
+          </p:nvPr>
+        </p:nvSpPr>
+        <p:spPr/>
+        <p:txBody>
+          <a:bodyPr/>
+          <a:lstStyle/>
+          <a:p>
+            <a:endParaRPr lang="en-US" dirty="0"/>
+          </a:p>
+        </p:txBody>
+      </p:sp>
+      <p:sp>
+        <p:nvSpPr>
+          <p:cNvPr id="4" name="Slide Number Placeholder 3"/>
+          <p:cNvSpPr>
+            <a:spLocks noGrp="1"/>
+          </p:cNvSpPr>
+          <p:nvPr>
+            <p:ph type="sldNum" sz="quarter" idx="5"/>
+          </p:nvPr>
+        </p:nvSpPr>
+        <p:spPr/>
+        <p:txBody>
+          <a:bodyPr/>
+          <a:lstStyle/>
+          <a:p>
+            <a:fld id="{C3ADA3BE-8651-44EF-90D8-D9C485CA2681}" type="slidenum">
+              <a:rPr lang="en-US" smtClean="0"/>
+              <a:t>22</a:t>
+            </a:fld>
+            <a:endParaRPr lang="en-US"/>
+          </a:p>
+        </p:txBody>
+      </p:sp>
+    </p:spTree>
+    <p:extLst>
+      <p:ext uri="{BB962C8B-B14F-4D97-AF65-F5344CB8AC3E}">
+        <p14:creationId xmlns:p14="http://schemas.microsoft.com/office/powerpoint/2010/main" val="3209189081"/>
+      </p:ext>
+    </p:extLst>
+  </p:cSld>
+  <p:clrMapOvr>
+    <a:masterClrMapping/>
+  </p:clrMapOvr>
+</p:notes>
+</file>
+
+<file path=ppt/notesSlides/notesSlide21.xml><?xml version="1.0" encoding="utf-8"?>
+<p:notes xmlns:a="http://schemas.openxmlformats.org/drawingml/2006/main" xmlns:r="http://schemas.openxmlformats.org/officeDocument/2006/relationships" xmlns:p="http://schemas.openxmlformats.org/presentationml/2006/main">
+  <p:cSld>
+    <p:spTree>
+      <p:nvGrpSpPr>
+        <p:cNvPr id="1" name=""/>
+        <p:cNvGrpSpPr/>
+        <p:nvPr/>
+      </p:nvGrpSpPr>
+      <p:grpSpPr>
+        <a:xfrm>
+          <a:off x="0" y="0"/>
+          <a:ext cx="0" cy="0"/>
+          <a:chOff x="0" y="0"/>
+          <a:chExt cx="0" cy="0"/>
+        </a:xfrm>
+      </p:grpSpPr>
+      <p:sp>
+        <p:nvSpPr>
+          <p:cNvPr id="2" name="Slide Image Placeholder 1"/>
+          <p:cNvSpPr>
+            <a:spLocks noGrp="1" noRot="1" noChangeAspect="1"/>
+          </p:cNvSpPr>
+          <p:nvPr>
+            <p:ph type="sldImg"/>
+          </p:nvPr>
+        </p:nvSpPr>
+        <p:spPr/>
+      </p:sp>
+      <p:sp>
+        <p:nvSpPr>
+          <p:cNvPr id="3" name="Notes Placeholder 2"/>
+          <p:cNvSpPr>
+            <a:spLocks noGrp="1"/>
+          </p:cNvSpPr>
+          <p:nvPr>
+            <p:ph type="body" idx="1"/>
+          </p:nvPr>
+        </p:nvSpPr>
+        <p:spPr/>
+        <p:txBody>
+          <a:bodyPr/>
+          <a:lstStyle/>
+          <a:p>
+            <a:endParaRPr lang="en-US" dirty="0"/>
+          </a:p>
+        </p:txBody>
+      </p:sp>
+      <p:sp>
+        <p:nvSpPr>
+          <p:cNvPr id="4" name="Slide Number Placeholder 3"/>
+          <p:cNvSpPr>
+            <a:spLocks noGrp="1"/>
+          </p:cNvSpPr>
+          <p:nvPr>
+            <p:ph type="sldNum" sz="quarter" idx="5"/>
+          </p:nvPr>
+        </p:nvSpPr>
+        <p:spPr/>
+        <p:txBody>
+          <a:bodyPr/>
+          <a:lstStyle/>
+          <a:p>
+            <a:fld id="{C3ADA3BE-8651-44EF-90D8-D9C485CA2681}" type="slidenum">
+              <a:rPr lang="en-US" smtClean="0"/>
+              <a:t>23</a:t>
+            </a:fld>
+            <a:endParaRPr lang="en-US"/>
+          </a:p>
+        </p:txBody>
+      </p:sp>
+    </p:spTree>
+    <p:extLst>
+      <p:ext uri="{BB962C8B-B14F-4D97-AF65-F5344CB8AC3E}">
+        <p14:creationId xmlns:p14="http://schemas.microsoft.com/office/powerpoint/2010/main" val="2969047450"/>
       </p:ext>
     </p:extLst>
   </p:cSld>
@@ -1843,7 +2766,7 @@
           <a:p>
             <a:fld id="{D2EC6751-3BEE-4E9B-B2EE-26D93AD5FB0C}" type="datetimeFigureOut">
               <a:rPr lang="en-IN" smtClean="0"/>
-              <a:t>05-12-2024</a:t>
+              <a:t>06-12-2024</a:t>
             </a:fld>
             <a:endParaRPr lang="en-IN"/>
           </a:p>
@@ -2043,7 +2966,7 @@
           <a:p>
             <a:fld id="{D2EC6751-3BEE-4E9B-B2EE-26D93AD5FB0C}" type="datetimeFigureOut">
               <a:rPr lang="en-IN" smtClean="0"/>
-              <a:t>05-12-2024</a:t>
+              <a:t>06-12-2024</a:t>
             </a:fld>
             <a:endParaRPr lang="en-IN"/>
           </a:p>
@@ -2253,7 +3176,7 @@
           <a:p>
             <a:fld id="{D2EC6751-3BEE-4E9B-B2EE-26D93AD5FB0C}" type="datetimeFigureOut">
               <a:rPr lang="en-IN" smtClean="0"/>
-              <a:t>05-12-2024</a:t>
+              <a:t>06-12-2024</a:t>
             </a:fld>
             <a:endParaRPr lang="en-IN"/>
           </a:p>
@@ -2453,7 +3376,7 @@
           <a:p>
             <a:fld id="{D2EC6751-3BEE-4E9B-B2EE-26D93AD5FB0C}" type="datetimeFigureOut">
               <a:rPr lang="en-IN" smtClean="0"/>
-              <a:t>05-12-2024</a:t>
+              <a:t>06-12-2024</a:t>
             </a:fld>
             <a:endParaRPr lang="en-IN"/>
           </a:p>
@@ -2729,7 +3652,7 @@
           <a:p>
             <a:fld id="{D2EC6751-3BEE-4E9B-B2EE-26D93AD5FB0C}" type="datetimeFigureOut">
               <a:rPr lang="en-IN" smtClean="0"/>
-              <a:t>05-12-2024</a:t>
+              <a:t>06-12-2024</a:t>
             </a:fld>
             <a:endParaRPr lang="en-IN"/>
           </a:p>
@@ -2997,7 +3920,7 @@
           <a:p>
             <a:fld id="{D2EC6751-3BEE-4E9B-B2EE-26D93AD5FB0C}" type="datetimeFigureOut">
               <a:rPr lang="en-IN" smtClean="0"/>
-              <a:t>05-12-2024</a:t>
+              <a:t>06-12-2024</a:t>
             </a:fld>
             <a:endParaRPr lang="en-IN"/>
           </a:p>
@@ -3412,7 +4335,7 @@
           <a:p>
             <a:fld id="{D2EC6751-3BEE-4E9B-B2EE-26D93AD5FB0C}" type="datetimeFigureOut">
               <a:rPr lang="en-IN" smtClean="0"/>
-              <a:t>05-12-2024</a:t>
+              <a:t>06-12-2024</a:t>
             </a:fld>
             <a:endParaRPr lang="en-IN"/>
           </a:p>
@@ -3554,7 +4477,7 @@
           <a:p>
             <a:fld id="{D2EC6751-3BEE-4E9B-B2EE-26D93AD5FB0C}" type="datetimeFigureOut">
               <a:rPr lang="en-IN" smtClean="0"/>
-              <a:t>05-12-2024</a:t>
+              <a:t>06-12-2024</a:t>
             </a:fld>
             <a:endParaRPr lang="en-IN"/>
           </a:p>
@@ -3667,7 +4590,7 @@
           <a:p>
             <a:fld id="{D2EC6751-3BEE-4E9B-B2EE-26D93AD5FB0C}" type="datetimeFigureOut">
               <a:rPr lang="en-IN" smtClean="0"/>
-              <a:t>05-12-2024</a:t>
+              <a:t>06-12-2024</a:t>
             </a:fld>
             <a:endParaRPr lang="en-IN"/>
           </a:p>
@@ -3980,7 +4903,7 @@
           <a:p>
             <a:fld id="{D2EC6751-3BEE-4E9B-B2EE-26D93AD5FB0C}" type="datetimeFigureOut">
               <a:rPr lang="en-IN" smtClean="0"/>
-              <a:t>05-12-2024</a:t>
+              <a:t>06-12-2024</a:t>
             </a:fld>
             <a:endParaRPr lang="en-IN"/>
           </a:p>
@@ -4269,7 +5192,7 @@
           <a:p>
             <a:fld id="{D2EC6751-3BEE-4E9B-B2EE-26D93AD5FB0C}" type="datetimeFigureOut">
               <a:rPr lang="en-IN" smtClean="0"/>
-              <a:t>05-12-2024</a:t>
+              <a:t>06-12-2024</a:t>
             </a:fld>
             <a:endParaRPr lang="en-IN"/>
           </a:p>
@@ -4512,7 +5435,7 @@
           <a:p>
             <a:fld id="{D2EC6751-3BEE-4E9B-B2EE-26D93AD5FB0C}" type="datetimeFigureOut">
               <a:rPr lang="en-IN" smtClean="0"/>
-              <a:t>05-12-2024</a:t>
+              <a:t>06-12-2024</a:t>
             </a:fld>
             <a:endParaRPr lang="en-IN"/>
           </a:p>
@@ -5009,8 +5932,8 @@
           <a:chExt cx="0" cy="0"/>
         </a:xfrm>
       </p:grpSpPr>
-      <mc:AlternateContent xmlns:mc="http://schemas.openxmlformats.org/markup-compatibility/2006">
-        <mc:Choice xmlns:a14="http://schemas.microsoft.com/office/drawing/2010/main" Requires="a14">
+      <mc:AlternateContent xmlns:mc="http://schemas.openxmlformats.org/markup-compatibility/2006" xmlns:a14="http://schemas.microsoft.com/office/drawing/2010/main">
+        <mc:Choice Requires="a14">
           <p:sp>
             <p:nvSpPr>
               <p:cNvPr id="2" name="TextBox 1">
@@ -5087,7 +6010,7 @@
             </p:txBody>
           </p:sp>
         </mc:Choice>
-        <mc:Fallback>
+        <mc:Fallback xmlns="">
           <p:sp>
             <p:nvSpPr>
               <p:cNvPr id="2" name="TextBox 1">
@@ -5314,8 +6237,8 @@
           <a:chExt cx="0" cy="0"/>
         </a:xfrm>
       </p:grpSpPr>
-      <mc:AlternateContent xmlns:mc="http://schemas.openxmlformats.org/markup-compatibility/2006">
-        <mc:Choice xmlns:a14="http://schemas.microsoft.com/office/drawing/2010/main" Requires="a14">
+      <mc:AlternateContent xmlns:mc="http://schemas.openxmlformats.org/markup-compatibility/2006" xmlns:a14="http://schemas.microsoft.com/office/drawing/2010/main">
+        <mc:Choice Requires="a14">
           <p:sp>
             <p:nvSpPr>
               <p:cNvPr id="5" name="TextBox 4">
@@ -5412,7 +6335,7 @@
             </p:txBody>
           </p:sp>
         </mc:Choice>
-        <mc:Fallback>
+        <mc:Fallback xmlns="">
           <p:sp>
             <p:nvSpPr>
               <p:cNvPr id="5" name="TextBox 4">
@@ -5523,8 +6446,8 @@
           <a:chExt cx="0" cy="0"/>
         </a:xfrm>
       </p:grpSpPr>
-      <mc:AlternateContent xmlns:mc="http://schemas.openxmlformats.org/markup-compatibility/2006">
-        <mc:Choice xmlns:a14="http://schemas.microsoft.com/office/drawing/2010/main" Requires="a14">
+      <mc:AlternateContent xmlns:mc="http://schemas.openxmlformats.org/markup-compatibility/2006" xmlns:a14="http://schemas.microsoft.com/office/drawing/2010/main">
+        <mc:Choice Requires="a14">
           <p:sp>
             <p:nvSpPr>
               <p:cNvPr id="5" name="TextBox 4">
@@ -5621,7 +6544,7 @@
             </p:txBody>
           </p:sp>
         </mc:Choice>
-        <mc:Fallback>
+        <mc:Fallback xmlns="">
           <p:sp>
             <p:nvSpPr>
               <p:cNvPr id="5" name="TextBox 4">
@@ -5731,8 +6654,8 @@
           <a:chExt cx="0" cy="0"/>
         </a:xfrm>
       </p:grpSpPr>
-      <mc:AlternateContent xmlns:mc="http://schemas.openxmlformats.org/markup-compatibility/2006">
-        <mc:Choice xmlns:a14="http://schemas.microsoft.com/office/drawing/2010/main" Requires="a14">
+      <mc:AlternateContent xmlns:mc="http://schemas.openxmlformats.org/markup-compatibility/2006" xmlns:a14="http://schemas.microsoft.com/office/drawing/2010/main">
+        <mc:Choice Requires="a14">
           <p:sp>
             <p:nvSpPr>
               <p:cNvPr id="5" name="TextBox 4">
@@ -5829,7 +6752,7 @@
             </p:txBody>
           </p:sp>
         </mc:Choice>
-        <mc:Fallback>
+        <mc:Fallback xmlns="">
           <p:sp>
             <p:nvSpPr>
               <p:cNvPr id="5" name="TextBox 4">
@@ -5939,8 +6862,8 @@
           <a:chExt cx="0" cy="0"/>
         </a:xfrm>
       </p:grpSpPr>
-      <mc:AlternateContent xmlns:mc="http://schemas.openxmlformats.org/markup-compatibility/2006">
-        <mc:Choice xmlns:a14="http://schemas.microsoft.com/office/drawing/2010/main" Requires="a14">
+      <mc:AlternateContent xmlns:mc="http://schemas.openxmlformats.org/markup-compatibility/2006" xmlns:a14="http://schemas.microsoft.com/office/drawing/2010/main">
+        <mc:Choice Requires="a14">
           <p:sp>
             <p:nvSpPr>
               <p:cNvPr id="5" name="TextBox 4">
@@ -6037,7 +6960,7 @@
             </p:txBody>
           </p:sp>
         </mc:Choice>
-        <mc:Fallback>
+        <mc:Fallback xmlns="">
           <p:sp>
             <p:nvSpPr>
               <p:cNvPr id="5" name="TextBox 4">
@@ -6130,6 +7053,1152 @@
 </p:sld>
 </file>
 
+<file path=ppt/slides/slide15.xml><?xml version="1.0" encoding="utf-8"?>
+<p:sld xmlns:a="http://schemas.openxmlformats.org/drawingml/2006/main" xmlns:r="http://schemas.openxmlformats.org/officeDocument/2006/relationships" xmlns:p="http://schemas.openxmlformats.org/presentationml/2006/main">
+  <p:cSld>
+    <p:spTree>
+      <p:nvGrpSpPr>
+        <p:cNvPr id="1" name=""/>
+        <p:cNvGrpSpPr/>
+        <p:nvPr/>
+      </p:nvGrpSpPr>
+      <p:grpSpPr>
+        <a:xfrm>
+          <a:off x="0" y="0"/>
+          <a:ext cx="0" cy="0"/>
+          <a:chOff x="0" y="0"/>
+          <a:chExt cx="0" cy="0"/>
+        </a:xfrm>
+      </p:grpSpPr>
+      <mc:AlternateContent xmlns:mc="http://schemas.openxmlformats.org/markup-compatibility/2006">
+        <mc:Choice xmlns:a14="http://schemas.microsoft.com/office/drawing/2010/main" Requires="a14">
+          <p:sp>
+            <p:nvSpPr>
+              <p:cNvPr id="2" name="TextBox 1">
+                <a:extLst>
+                  <a:ext uri="{FF2B5EF4-FFF2-40B4-BE49-F238E27FC236}">
+                    <a16:creationId xmlns:a16="http://schemas.microsoft.com/office/drawing/2014/main" id="{68E945A7-064A-44D2-B79A-48E50FCB50A2}"/>
+                  </a:ext>
+                </a:extLst>
+              </p:cNvPr>
+              <p:cNvSpPr txBox="1"/>
+              <p:nvPr/>
+            </p:nvSpPr>
+            <p:spPr>
+              <a:xfrm>
+                <a:off x="149133" y="352697"/>
+                <a:ext cx="2241369" cy="3139321"/>
+              </a:xfrm>
+              <a:prstGeom prst="rect">
+                <a:avLst/>
+              </a:prstGeom>
+              <a:noFill/>
+            </p:spPr>
+            <p:txBody>
+              <a:bodyPr wrap="square" rtlCol="0">
+                <a:spAutoFit/>
+              </a:bodyPr>
+              <a:lstStyle/>
+              <a:p>
+                <a:r>
+                  <a:rPr lang="en-US" b="1" dirty="0"/>
+                  <a:t>Build slab with different sizes in z:</a:t>
+                </a:r>
+              </a:p>
+              <a:p>
+                <a:endParaRPr lang="en-US" dirty="0"/>
+              </a:p>
+              <a:p>
+                <a:r>
+                  <a:rPr lang="en-US" dirty="0"/>
+                  <a:t>Unit cells </a:t>
+                </a:r>
+                <a:r>
+                  <a:rPr lang="de-DE" dirty="0"/>
+                  <a:t>24x24x</a:t>
+                </a:r>
+                <a:r>
+                  <a:rPr lang="de-DE" b="1" dirty="0"/>
+                  <a:t>8</a:t>
+                </a:r>
+                <a:endParaRPr lang="en-US" b="1" dirty="0"/>
+              </a:p>
+              <a:p>
+                <a:r>
+                  <a:rPr lang="en-US" dirty="0"/>
+                  <a:t>R</a:t>
+                </a:r>
+                <a:r>
+                  <a:rPr lang="en-IN" dirty="0" err="1"/>
+                  <a:t>andom</a:t>
+                </a:r>
+                <a:r>
+                  <a:rPr lang="en-IN" dirty="0"/>
+                  <a:t> orientations</a:t>
+                </a:r>
+              </a:p>
+              <a:p>
+                <a:endParaRPr lang="en-IN" dirty="0"/>
+              </a:p>
+              <a:p>
+                <a:r>
+                  <a:rPr lang="en-IN" dirty="0"/>
+                  <a:t>Frequency shifted (</a:t>
+                </a:r>
+                <a:r>
+                  <a:rPr lang="el-GR" dirty="0"/>
+                  <a:t>ν0 = 2138.0</a:t>
+                </a:r>
+                <a:r>
+                  <a:rPr lang="en-IN" dirty="0"/>
+                  <a:t>)</a:t>
+                </a:r>
+              </a:p>
+              <a:p>
+                <a:endParaRPr lang="en-IN" dirty="0"/>
+              </a:p>
+              <a:p>
+                <a:r>
+                  <a:rPr lang="de-DE" dirty="0"/>
+                  <a:t>Theta = 50°, </a:t>
+                </a:r>
+                <a14:m>
+                  <m:oMath xmlns:m="http://schemas.openxmlformats.org/officeDocument/2006/math">
+                    <m:r>
+                      <a:rPr lang="de-DE" b="0" i="1" smtClean="0">
+                        <a:latin typeface="Cambria Math" panose="02040503050406030204" pitchFamily="18" charset="0"/>
+                      </a:rPr>
+                      <m:t>𝛼</m:t>
+                    </m:r>
+                  </m:oMath>
+                </a14:m>
+                <a:r>
+                  <a:rPr lang="en-US" dirty="0"/>
+                  <a:t>=0 and µ01 = 0.105</a:t>
+                </a:r>
+                <a:endParaRPr lang="en-IN" dirty="0"/>
+              </a:p>
+            </p:txBody>
+          </p:sp>
+        </mc:Choice>
+        <mc:Fallback>
+          <p:sp>
+            <p:nvSpPr>
+              <p:cNvPr id="2" name="TextBox 1">
+                <a:extLst>
+                  <a:ext uri="{FF2B5EF4-FFF2-40B4-BE49-F238E27FC236}">
+                    <a16:creationId xmlns:a16="http://schemas.microsoft.com/office/drawing/2014/main" id="{68E945A7-064A-44D2-B79A-48E50FCB50A2}"/>
+                  </a:ext>
+                </a:extLst>
+              </p:cNvPr>
+              <p:cNvSpPr txBox="1">
+                <a:spLocks noRot="1" noChangeAspect="1" noMove="1" noResize="1" noEditPoints="1" noAdjustHandles="1" noChangeArrowheads="1" noChangeShapeType="1" noTextEdit="1"/>
+              </p:cNvSpPr>
+              <p:nvPr/>
+            </p:nvSpPr>
+            <p:spPr>
+              <a:xfrm>
+                <a:off x="149133" y="352697"/>
+                <a:ext cx="2241369" cy="3139321"/>
+              </a:xfrm>
+              <a:prstGeom prst="rect">
+                <a:avLst/>
+              </a:prstGeom>
+              <a:blipFill>
+                <a:blip r:embed="rId3"/>
+                <a:stretch>
+                  <a:fillRect l="-2174" t="-1165" r="-2446" b="-2136"/>
+                </a:stretch>
+              </a:blipFill>
+            </p:spPr>
+            <p:txBody>
+              <a:bodyPr/>
+              <a:lstStyle/>
+              <a:p>
+                <a:r>
+                  <a:rPr lang="en-US">
+                    <a:noFill/>
+                  </a:rPr>
+                  <a:t> </a:t>
+                </a:r>
+              </a:p>
+            </p:txBody>
+          </p:sp>
+        </mc:Fallback>
+      </mc:AlternateContent>
+      <p:pic>
+        <p:nvPicPr>
+          <p:cNvPr id="6" name="Picture 5">
+            <a:extLst>
+              <a:ext uri="{FF2B5EF4-FFF2-40B4-BE49-F238E27FC236}">
+                <a16:creationId xmlns:a16="http://schemas.microsoft.com/office/drawing/2014/main" id="{4BB7E91A-5135-4274-9AD4-A502AAF58FDE}"/>
+              </a:ext>
+            </a:extLst>
+          </p:cNvPr>
+          <p:cNvPicPr>
+            <a:picLocks noChangeAspect="1"/>
+          </p:cNvPicPr>
+          <p:nvPr/>
+        </p:nvPicPr>
+        <p:blipFill>
+          <a:blip r:embed="rId4">
+            <a:extLst>
+              <a:ext uri="{28A0092B-C50C-407E-A947-70E740481C1C}">
+                <a14:useLocalDpi xmlns:a14="http://schemas.microsoft.com/office/drawing/2010/main" val="0"/>
+              </a:ext>
+            </a:extLst>
+          </a:blip>
+          <a:stretch>
+            <a:fillRect/>
+          </a:stretch>
+        </p:blipFill>
+        <p:spPr>
+          <a:xfrm>
+            <a:off x="3052694" y="536166"/>
+            <a:ext cx="8726118" cy="6087325"/>
+          </a:xfrm>
+          <a:prstGeom prst="rect">
+            <a:avLst/>
+          </a:prstGeom>
+        </p:spPr>
+      </p:pic>
+    </p:spTree>
+    <p:extLst>
+      <p:ext uri="{BB962C8B-B14F-4D97-AF65-F5344CB8AC3E}">
+        <p14:creationId xmlns:p14="http://schemas.microsoft.com/office/powerpoint/2010/main" val="2330706991"/>
+      </p:ext>
+    </p:extLst>
+  </p:cSld>
+  <p:clrMapOvr>
+    <a:masterClrMapping/>
+  </p:clrMapOvr>
+</p:sld>
+</file>
+
+<file path=ppt/slides/slide16.xml><?xml version="1.0" encoding="utf-8"?>
+<p:sld xmlns:a="http://schemas.openxmlformats.org/drawingml/2006/main" xmlns:r="http://schemas.openxmlformats.org/officeDocument/2006/relationships" xmlns:p="http://schemas.openxmlformats.org/presentationml/2006/main">
+  <p:cSld>
+    <p:spTree>
+      <p:nvGrpSpPr>
+        <p:cNvPr id="1" name=""/>
+        <p:cNvGrpSpPr/>
+        <p:nvPr/>
+      </p:nvGrpSpPr>
+      <p:grpSpPr>
+        <a:xfrm>
+          <a:off x="0" y="0"/>
+          <a:ext cx="0" cy="0"/>
+          <a:chOff x="0" y="0"/>
+          <a:chExt cx="0" cy="0"/>
+        </a:xfrm>
+      </p:grpSpPr>
+      <mc:AlternateContent xmlns:mc="http://schemas.openxmlformats.org/markup-compatibility/2006">
+        <mc:Choice xmlns:a14="http://schemas.microsoft.com/office/drawing/2010/main" Requires="a14">
+          <p:sp>
+            <p:nvSpPr>
+              <p:cNvPr id="2" name="TextBox 1">
+                <a:extLst>
+                  <a:ext uri="{FF2B5EF4-FFF2-40B4-BE49-F238E27FC236}">
+                    <a16:creationId xmlns:a16="http://schemas.microsoft.com/office/drawing/2014/main" id="{68E945A7-064A-44D2-B79A-48E50FCB50A2}"/>
+                  </a:ext>
+                </a:extLst>
+              </p:cNvPr>
+              <p:cNvSpPr txBox="1"/>
+              <p:nvPr/>
+            </p:nvSpPr>
+            <p:spPr>
+              <a:xfrm>
+                <a:off x="149133" y="352697"/>
+                <a:ext cx="2241369" cy="3139321"/>
+              </a:xfrm>
+              <a:prstGeom prst="rect">
+                <a:avLst/>
+              </a:prstGeom>
+              <a:noFill/>
+            </p:spPr>
+            <p:txBody>
+              <a:bodyPr wrap="square" rtlCol="0">
+                <a:spAutoFit/>
+              </a:bodyPr>
+              <a:lstStyle/>
+              <a:p>
+                <a:r>
+                  <a:rPr lang="en-US" b="1" dirty="0"/>
+                  <a:t>Build slab with different sizes in z:</a:t>
+                </a:r>
+              </a:p>
+              <a:p>
+                <a:endParaRPr lang="en-US" dirty="0"/>
+              </a:p>
+              <a:p>
+                <a:r>
+                  <a:rPr lang="en-US" dirty="0"/>
+                  <a:t>Unit cells </a:t>
+                </a:r>
+                <a:r>
+                  <a:rPr lang="de-DE" dirty="0"/>
+                  <a:t>24x24x</a:t>
+                </a:r>
+                <a:r>
+                  <a:rPr lang="de-DE" b="1" dirty="0"/>
+                  <a:t>12</a:t>
+                </a:r>
+                <a:endParaRPr lang="en-US" b="1" dirty="0"/>
+              </a:p>
+              <a:p>
+                <a:r>
+                  <a:rPr lang="en-US" dirty="0"/>
+                  <a:t>R</a:t>
+                </a:r>
+                <a:r>
+                  <a:rPr lang="en-IN" dirty="0" err="1"/>
+                  <a:t>andom</a:t>
+                </a:r>
+                <a:r>
+                  <a:rPr lang="en-IN" dirty="0"/>
+                  <a:t> orientations</a:t>
+                </a:r>
+              </a:p>
+              <a:p>
+                <a:endParaRPr lang="en-IN" dirty="0"/>
+              </a:p>
+              <a:p>
+                <a:r>
+                  <a:rPr lang="en-IN" dirty="0"/>
+                  <a:t>Frequency shifted (</a:t>
+                </a:r>
+                <a:r>
+                  <a:rPr lang="el-GR" dirty="0"/>
+                  <a:t>ν0 = 2138.0</a:t>
+                </a:r>
+                <a:r>
+                  <a:rPr lang="en-IN" dirty="0"/>
+                  <a:t>)</a:t>
+                </a:r>
+              </a:p>
+              <a:p>
+                <a:endParaRPr lang="en-IN" dirty="0"/>
+              </a:p>
+              <a:p>
+                <a:r>
+                  <a:rPr lang="de-DE" dirty="0"/>
+                  <a:t>Theta = 45°, </a:t>
+                </a:r>
+                <a14:m>
+                  <m:oMath xmlns:m="http://schemas.openxmlformats.org/officeDocument/2006/math">
+                    <m:r>
+                      <a:rPr lang="de-DE" b="0" i="1" smtClean="0">
+                        <a:latin typeface="Cambria Math" panose="02040503050406030204" pitchFamily="18" charset="0"/>
+                      </a:rPr>
+                      <m:t>𝛼</m:t>
+                    </m:r>
+                  </m:oMath>
+                </a14:m>
+                <a:r>
+                  <a:rPr lang="en-US" dirty="0"/>
+                  <a:t>=0 and µ01 = 0.105</a:t>
+                </a:r>
+                <a:endParaRPr lang="en-IN" dirty="0"/>
+              </a:p>
+            </p:txBody>
+          </p:sp>
+        </mc:Choice>
+        <mc:Fallback>
+          <p:sp>
+            <p:nvSpPr>
+              <p:cNvPr id="2" name="TextBox 1">
+                <a:extLst>
+                  <a:ext uri="{FF2B5EF4-FFF2-40B4-BE49-F238E27FC236}">
+                    <a16:creationId xmlns:a16="http://schemas.microsoft.com/office/drawing/2014/main" id="{68E945A7-064A-44D2-B79A-48E50FCB50A2}"/>
+                  </a:ext>
+                </a:extLst>
+              </p:cNvPr>
+              <p:cNvSpPr txBox="1">
+                <a:spLocks noRot="1" noChangeAspect="1" noMove="1" noResize="1" noEditPoints="1" noAdjustHandles="1" noChangeArrowheads="1" noChangeShapeType="1" noTextEdit="1"/>
+              </p:cNvSpPr>
+              <p:nvPr/>
+            </p:nvSpPr>
+            <p:spPr>
+              <a:xfrm>
+                <a:off x="149133" y="352697"/>
+                <a:ext cx="2241369" cy="3139321"/>
+              </a:xfrm>
+              <a:prstGeom prst="rect">
+                <a:avLst/>
+              </a:prstGeom>
+              <a:blipFill>
+                <a:blip r:embed="rId3"/>
+                <a:stretch>
+                  <a:fillRect l="-2174" t="-1165" r="-2446" b="-2136"/>
+                </a:stretch>
+              </a:blipFill>
+            </p:spPr>
+            <p:txBody>
+              <a:bodyPr/>
+              <a:lstStyle/>
+              <a:p>
+                <a:r>
+                  <a:rPr lang="en-US">
+                    <a:noFill/>
+                  </a:rPr>
+                  <a:t> </a:t>
+                </a:r>
+              </a:p>
+            </p:txBody>
+          </p:sp>
+        </mc:Fallback>
+      </mc:AlternateContent>
+      <p:pic>
+        <p:nvPicPr>
+          <p:cNvPr id="6" name="Picture 5">
+            <a:extLst>
+              <a:ext uri="{FF2B5EF4-FFF2-40B4-BE49-F238E27FC236}">
+                <a16:creationId xmlns:a16="http://schemas.microsoft.com/office/drawing/2014/main" id="{4BB7E91A-5135-4274-9AD4-A502AAF58FDE}"/>
+              </a:ext>
+            </a:extLst>
+          </p:cNvPr>
+          <p:cNvPicPr>
+            <a:picLocks noChangeAspect="1"/>
+          </p:cNvPicPr>
+          <p:nvPr/>
+        </p:nvPicPr>
+        <p:blipFill>
+          <a:blip r:embed="rId4">
+            <a:extLst>
+              <a:ext uri="{28A0092B-C50C-407E-A947-70E740481C1C}">
+                <a14:useLocalDpi xmlns:a14="http://schemas.microsoft.com/office/drawing/2010/main" val="0"/>
+              </a:ext>
+            </a:extLst>
+          </a:blip>
+          <a:srcRect/>
+          <a:stretch/>
+        </p:blipFill>
+        <p:spPr>
+          <a:xfrm>
+            <a:off x="3052865" y="536166"/>
+            <a:ext cx="8725775" cy="6087325"/>
+          </a:xfrm>
+          <a:prstGeom prst="rect">
+            <a:avLst/>
+          </a:prstGeom>
+        </p:spPr>
+      </p:pic>
+    </p:spTree>
+    <p:extLst>
+      <p:ext uri="{BB962C8B-B14F-4D97-AF65-F5344CB8AC3E}">
+        <p14:creationId xmlns:p14="http://schemas.microsoft.com/office/powerpoint/2010/main" val="942949437"/>
+      </p:ext>
+    </p:extLst>
+  </p:cSld>
+  <p:clrMapOvr>
+    <a:masterClrMapping/>
+  </p:clrMapOvr>
+</p:sld>
+</file>
+
+<file path=ppt/slides/slide17.xml><?xml version="1.0" encoding="utf-8"?>
+<p:sld xmlns:a="http://schemas.openxmlformats.org/drawingml/2006/main" xmlns:r="http://schemas.openxmlformats.org/officeDocument/2006/relationships" xmlns:p="http://schemas.openxmlformats.org/presentationml/2006/main">
+  <p:cSld>
+    <p:spTree>
+      <p:nvGrpSpPr>
+        <p:cNvPr id="1" name=""/>
+        <p:cNvGrpSpPr/>
+        <p:nvPr/>
+      </p:nvGrpSpPr>
+      <p:grpSpPr>
+        <a:xfrm>
+          <a:off x="0" y="0"/>
+          <a:ext cx="0" cy="0"/>
+          <a:chOff x="0" y="0"/>
+          <a:chExt cx="0" cy="0"/>
+        </a:xfrm>
+      </p:grpSpPr>
+      <mc:AlternateContent xmlns:mc="http://schemas.openxmlformats.org/markup-compatibility/2006">
+        <mc:Choice xmlns:a14="http://schemas.microsoft.com/office/drawing/2010/main" Requires="a14">
+          <p:sp>
+            <p:nvSpPr>
+              <p:cNvPr id="2" name="TextBox 1">
+                <a:extLst>
+                  <a:ext uri="{FF2B5EF4-FFF2-40B4-BE49-F238E27FC236}">
+                    <a16:creationId xmlns:a16="http://schemas.microsoft.com/office/drawing/2014/main" id="{68E945A7-064A-44D2-B79A-48E50FCB50A2}"/>
+                  </a:ext>
+                </a:extLst>
+              </p:cNvPr>
+              <p:cNvSpPr txBox="1"/>
+              <p:nvPr/>
+            </p:nvSpPr>
+            <p:spPr>
+              <a:xfrm>
+                <a:off x="149133" y="352697"/>
+                <a:ext cx="2241369" cy="3139321"/>
+              </a:xfrm>
+              <a:prstGeom prst="rect">
+                <a:avLst/>
+              </a:prstGeom>
+              <a:noFill/>
+            </p:spPr>
+            <p:txBody>
+              <a:bodyPr wrap="square" rtlCol="0">
+                <a:spAutoFit/>
+              </a:bodyPr>
+              <a:lstStyle/>
+              <a:p>
+                <a:r>
+                  <a:rPr lang="en-US" b="1" dirty="0"/>
+                  <a:t>Build slab with different sizes in z:</a:t>
+                </a:r>
+              </a:p>
+              <a:p>
+                <a:endParaRPr lang="en-US" dirty="0"/>
+              </a:p>
+              <a:p>
+                <a:r>
+                  <a:rPr lang="en-US" dirty="0"/>
+                  <a:t>Unit cells </a:t>
+                </a:r>
+                <a:r>
+                  <a:rPr lang="de-DE" dirty="0"/>
+                  <a:t>24x24x</a:t>
+                </a:r>
+                <a:r>
+                  <a:rPr lang="de-DE" b="1" dirty="0"/>
+                  <a:t>16</a:t>
+                </a:r>
+                <a:endParaRPr lang="en-US" b="1" dirty="0"/>
+              </a:p>
+              <a:p>
+                <a:r>
+                  <a:rPr lang="en-US" dirty="0"/>
+                  <a:t>R</a:t>
+                </a:r>
+                <a:r>
+                  <a:rPr lang="en-IN" dirty="0" err="1"/>
+                  <a:t>andom</a:t>
+                </a:r>
+                <a:r>
+                  <a:rPr lang="en-IN" dirty="0"/>
+                  <a:t> orientations</a:t>
+                </a:r>
+              </a:p>
+              <a:p>
+                <a:endParaRPr lang="en-IN" dirty="0"/>
+              </a:p>
+              <a:p>
+                <a:r>
+                  <a:rPr lang="en-IN" dirty="0"/>
+                  <a:t>Frequency shifted (</a:t>
+                </a:r>
+                <a:r>
+                  <a:rPr lang="el-GR" dirty="0"/>
+                  <a:t>ν0 = 213</a:t>
+                </a:r>
+                <a:r>
+                  <a:rPr lang="de-DE" dirty="0"/>
+                  <a:t>7</a:t>
+                </a:r>
+                <a:r>
+                  <a:rPr lang="el-GR" dirty="0"/>
+                  <a:t>.</a:t>
+                </a:r>
+                <a:r>
+                  <a:rPr lang="de-DE" dirty="0"/>
+                  <a:t>4</a:t>
+                </a:r>
+                <a:r>
+                  <a:rPr lang="en-IN" dirty="0"/>
+                  <a:t>)</a:t>
+                </a:r>
+              </a:p>
+              <a:p>
+                <a:endParaRPr lang="en-IN" dirty="0"/>
+              </a:p>
+              <a:p>
+                <a:r>
+                  <a:rPr lang="de-DE" dirty="0"/>
+                  <a:t>Theta = 45°, </a:t>
+                </a:r>
+                <a14:m>
+                  <m:oMath xmlns:m="http://schemas.openxmlformats.org/officeDocument/2006/math">
+                    <m:r>
+                      <a:rPr lang="de-DE" b="0" i="1" smtClean="0">
+                        <a:latin typeface="Cambria Math" panose="02040503050406030204" pitchFamily="18" charset="0"/>
+                      </a:rPr>
+                      <m:t>𝛼</m:t>
+                    </m:r>
+                  </m:oMath>
+                </a14:m>
+                <a:r>
+                  <a:rPr lang="en-US" dirty="0"/>
+                  <a:t>=0 and µ01 = 0.105</a:t>
+                </a:r>
+                <a:endParaRPr lang="en-IN" dirty="0"/>
+              </a:p>
+            </p:txBody>
+          </p:sp>
+        </mc:Choice>
+        <mc:Fallback>
+          <p:sp>
+            <p:nvSpPr>
+              <p:cNvPr id="2" name="TextBox 1">
+                <a:extLst>
+                  <a:ext uri="{FF2B5EF4-FFF2-40B4-BE49-F238E27FC236}">
+                    <a16:creationId xmlns:a16="http://schemas.microsoft.com/office/drawing/2014/main" id="{68E945A7-064A-44D2-B79A-48E50FCB50A2}"/>
+                  </a:ext>
+                </a:extLst>
+              </p:cNvPr>
+              <p:cNvSpPr txBox="1">
+                <a:spLocks noRot="1" noChangeAspect="1" noMove="1" noResize="1" noEditPoints="1" noAdjustHandles="1" noChangeArrowheads="1" noChangeShapeType="1" noTextEdit="1"/>
+              </p:cNvSpPr>
+              <p:nvPr/>
+            </p:nvSpPr>
+            <p:spPr>
+              <a:xfrm>
+                <a:off x="149133" y="352697"/>
+                <a:ext cx="2241369" cy="3139321"/>
+              </a:xfrm>
+              <a:prstGeom prst="rect">
+                <a:avLst/>
+              </a:prstGeom>
+              <a:blipFill>
+                <a:blip r:embed="rId3"/>
+                <a:stretch>
+                  <a:fillRect l="-2174" t="-1165" r="-2446" b="-2136"/>
+                </a:stretch>
+              </a:blipFill>
+            </p:spPr>
+            <p:txBody>
+              <a:bodyPr/>
+              <a:lstStyle/>
+              <a:p>
+                <a:r>
+                  <a:rPr lang="en-US">
+                    <a:noFill/>
+                  </a:rPr>
+                  <a:t> </a:t>
+                </a:r>
+              </a:p>
+            </p:txBody>
+          </p:sp>
+        </mc:Fallback>
+      </mc:AlternateContent>
+      <p:pic>
+        <p:nvPicPr>
+          <p:cNvPr id="6" name="Picture 5">
+            <a:extLst>
+              <a:ext uri="{FF2B5EF4-FFF2-40B4-BE49-F238E27FC236}">
+                <a16:creationId xmlns:a16="http://schemas.microsoft.com/office/drawing/2014/main" id="{4BB7E91A-5135-4274-9AD4-A502AAF58FDE}"/>
+              </a:ext>
+            </a:extLst>
+          </p:cNvPr>
+          <p:cNvPicPr>
+            <a:picLocks noChangeAspect="1"/>
+          </p:cNvPicPr>
+          <p:nvPr/>
+        </p:nvPicPr>
+        <p:blipFill>
+          <a:blip r:embed="rId4">
+            <a:extLst>
+              <a:ext uri="{28A0092B-C50C-407E-A947-70E740481C1C}">
+                <a14:useLocalDpi xmlns:a14="http://schemas.microsoft.com/office/drawing/2010/main" val="0"/>
+              </a:ext>
+            </a:extLst>
+          </a:blip>
+          <a:srcRect/>
+          <a:stretch/>
+        </p:blipFill>
+        <p:spPr>
+          <a:xfrm>
+            <a:off x="3052865" y="536166"/>
+            <a:ext cx="8725775" cy="6087324"/>
+          </a:xfrm>
+          <a:prstGeom prst="rect">
+            <a:avLst/>
+          </a:prstGeom>
+        </p:spPr>
+      </p:pic>
+    </p:spTree>
+    <p:extLst>
+      <p:ext uri="{BB962C8B-B14F-4D97-AF65-F5344CB8AC3E}">
+        <p14:creationId xmlns:p14="http://schemas.microsoft.com/office/powerpoint/2010/main" val="1531446661"/>
+      </p:ext>
+    </p:extLst>
+  </p:cSld>
+  <p:clrMapOvr>
+    <a:masterClrMapping/>
+  </p:clrMapOvr>
+</p:sld>
+</file>
+
+<file path=ppt/slides/slide18.xml><?xml version="1.0" encoding="utf-8"?>
+<p:sld xmlns:a="http://schemas.openxmlformats.org/drawingml/2006/main" xmlns:r="http://schemas.openxmlformats.org/officeDocument/2006/relationships" xmlns:p="http://schemas.openxmlformats.org/presentationml/2006/main">
+  <p:cSld>
+    <p:spTree>
+      <p:nvGrpSpPr>
+        <p:cNvPr id="1" name=""/>
+        <p:cNvGrpSpPr/>
+        <p:nvPr/>
+      </p:nvGrpSpPr>
+      <p:grpSpPr>
+        <a:xfrm>
+          <a:off x="0" y="0"/>
+          <a:ext cx="0" cy="0"/>
+          <a:chOff x="0" y="0"/>
+          <a:chExt cx="0" cy="0"/>
+        </a:xfrm>
+      </p:grpSpPr>
+      <mc:AlternateContent xmlns:mc="http://schemas.openxmlformats.org/markup-compatibility/2006">
+        <mc:Choice xmlns:a14="http://schemas.microsoft.com/office/drawing/2010/main" Requires="a14">
+          <p:sp>
+            <p:nvSpPr>
+              <p:cNvPr id="2" name="TextBox 1">
+                <a:extLst>
+                  <a:ext uri="{FF2B5EF4-FFF2-40B4-BE49-F238E27FC236}">
+                    <a16:creationId xmlns:a16="http://schemas.microsoft.com/office/drawing/2014/main" id="{68E945A7-064A-44D2-B79A-48E50FCB50A2}"/>
+                  </a:ext>
+                </a:extLst>
+              </p:cNvPr>
+              <p:cNvSpPr txBox="1"/>
+              <p:nvPr/>
+            </p:nvSpPr>
+            <p:spPr>
+              <a:xfrm>
+                <a:off x="149133" y="352697"/>
+                <a:ext cx="2241369" cy="3139321"/>
+              </a:xfrm>
+              <a:prstGeom prst="rect">
+                <a:avLst/>
+              </a:prstGeom>
+              <a:noFill/>
+            </p:spPr>
+            <p:txBody>
+              <a:bodyPr wrap="square" rtlCol="0">
+                <a:spAutoFit/>
+              </a:bodyPr>
+              <a:lstStyle/>
+              <a:p>
+                <a:r>
+                  <a:rPr lang="en-US" b="1" dirty="0"/>
+                  <a:t>Build slab with different sizes in z:</a:t>
+                </a:r>
+              </a:p>
+              <a:p>
+                <a:endParaRPr lang="en-US" dirty="0"/>
+              </a:p>
+              <a:p>
+                <a:r>
+                  <a:rPr lang="en-US" dirty="0"/>
+                  <a:t>Unit cells </a:t>
+                </a:r>
+                <a:r>
+                  <a:rPr lang="de-DE" dirty="0"/>
+                  <a:t>24x24x</a:t>
+                </a:r>
+                <a:r>
+                  <a:rPr lang="de-DE" b="1" dirty="0"/>
+                  <a:t>16</a:t>
+                </a:r>
+                <a:endParaRPr lang="en-US" b="1" dirty="0"/>
+              </a:p>
+              <a:p>
+                <a:r>
+                  <a:rPr lang="en-US" dirty="0"/>
+                  <a:t>R</a:t>
+                </a:r>
+                <a:r>
+                  <a:rPr lang="en-IN" dirty="0" err="1"/>
+                  <a:t>andom</a:t>
+                </a:r>
+                <a:r>
+                  <a:rPr lang="en-IN" dirty="0"/>
+                  <a:t> orientations</a:t>
+                </a:r>
+              </a:p>
+              <a:p>
+                <a:endParaRPr lang="en-IN" dirty="0"/>
+              </a:p>
+              <a:p>
+                <a:r>
+                  <a:rPr lang="en-IN" dirty="0"/>
+                  <a:t>Frequency shifted (</a:t>
+                </a:r>
+                <a:r>
+                  <a:rPr lang="el-GR" dirty="0"/>
+                  <a:t>ν0 = 213</a:t>
+                </a:r>
+                <a:r>
+                  <a:rPr lang="de-DE" dirty="0"/>
+                  <a:t>7</a:t>
+                </a:r>
+                <a:r>
+                  <a:rPr lang="el-GR" dirty="0"/>
+                  <a:t>.</a:t>
+                </a:r>
+                <a:r>
+                  <a:rPr lang="de-DE" dirty="0"/>
+                  <a:t>4</a:t>
+                </a:r>
+                <a:r>
+                  <a:rPr lang="en-IN" dirty="0"/>
+                  <a:t>)</a:t>
+                </a:r>
+              </a:p>
+              <a:p>
+                <a:endParaRPr lang="en-IN" dirty="0"/>
+              </a:p>
+              <a:p>
+                <a:r>
+                  <a:rPr lang="de-DE" dirty="0"/>
+                  <a:t>Theta = </a:t>
+                </a:r>
+                <a:r>
+                  <a:rPr lang="de-DE" b="1" dirty="0"/>
+                  <a:t>42</a:t>
+                </a:r>
+                <a:r>
+                  <a:rPr lang="de-DE" dirty="0"/>
+                  <a:t>°, </a:t>
+                </a:r>
+                <a14:m>
+                  <m:oMath xmlns:m="http://schemas.openxmlformats.org/officeDocument/2006/math">
+                    <m:r>
+                      <a:rPr lang="de-DE" b="0" i="1" smtClean="0">
+                        <a:latin typeface="Cambria Math" panose="02040503050406030204" pitchFamily="18" charset="0"/>
+                      </a:rPr>
+                      <m:t>𝛼</m:t>
+                    </m:r>
+                  </m:oMath>
+                </a14:m>
+                <a:r>
+                  <a:rPr lang="en-US" dirty="0"/>
+                  <a:t>=0 and µ01 = 0.105</a:t>
+                </a:r>
+                <a:endParaRPr lang="en-IN" dirty="0"/>
+              </a:p>
+            </p:txBody>
+          </p:sp>
+        </mc:Choice>
+        <mc:Fallback>
+          <p:sp>
+            <p:nvSpPr>
+              <p:cNvPr id="2" name="TextBox 1">
+                <a:extLst>
+                  <a:ext uri="{FF2B5EF4-FFF2-40B4-BE49-F238E27FC236}">
+                    <a16:creationId xmlns:a16="http://schemas.microsoft.com/office/drawing/2014/main" id="{68E945A7-064A-44D2-B79A-48E50FCB50A2}"/>
+                  </a:ext>
+                </a:extLst>
+              </p:cNvPr>
+              <p:cNvSpPr txBox="1">
+                <a:spLocks noRot="1" noChangeAspect="1" noMove="1" noResize="1" noEditPoints="1" noAdjustHandles="1" noChangeArrowheads="1" noChangeShapeType="1" noTextEdit="1"/>
+              </p:cNvSpPr>
+              <p:nvPr/>
+            </p:nvSpPr>
+            <p:spPr>
+              <a:xfrm>
+                <a:off x="149133" y="352697"/>
+                <a:ext cx="2241369" cy="3139321"/>
+              </a:xfrm>
+              <a:prstGeom prst="rect">
+                <a:avLst/>
+              </a:prstGeom>
+              <a:blipFill>
+                <a:blip r:embed="rId3"/>
+                <a:stretch>
+                  <a:fillRect l="-2174" t="-1165" r="-2446" b="-2136"/>
+                </a:stretch>
+              </a:blipFill>
+            </p:spPr>
+            <p:txBody>
+              <a:bodyPr/>
+              <a:lstStyle/>
+              <a:p>
+                <a:r>
+                  <a:rPr lang="en-US">
+                    <a:noFill/>
+                  </a:rPr>
+                  <a:t> </a:t>
+                </a:r>
+              </a:p>
+            </p:txBody>
+          </p:sp>
+        </mc:Fallback>
+      </mc:AlternateContent>
+      <p:pic>
+        <p:nvPicPr>
+          <p:cNvPr id="6" name="Picture 5">
+            <a:extLst>
+              <a:ext uri="{FF2B5EF4-FFF2-40B4-BE49-F238E27FC236}">
+                <a16:creationId xmlns:a16="http://schemas.microsoft.com/office/drawing/2014/main" id="{4BB7E91A-5135-4274-9AD4-A502AAF58FDE}"/>
+              </a:ext>
+            </a:extLst>
+          </p:cNvPr>
+          <p:cNvPicPr>
+            <a:picLocks noChangeAspect="1"/>
+          </p:cNvPicPr>
+          <p:nvPr/>
+        </p:nvPicPr>
+        <p:blipFill>
+          <a:blip r:embed="rId4">
+            <a:extLst>
+              <a:ext uri="{28A0092B-C50C-407E-A947-70E740481C1C}">
+                <a14:useLocalDpi xmlns:a14="http://schemas.microsoft.com/office/drawing/2010/main" val="0"/>
+              </a:ext>
+            </a:extLst>
+          </a:blip>
+          <a:srcRect/>
+          <a:stretch/>
+        </p:blipFill>
+        <p:spPr>
+          <a:xfrm>
+            <a:off x="3052866" y="536166"/>
+            <a:ext cx="8725773" cy="6087324"/>
+          </a:xfrm>
+          <a:prstGeom prst="rect">
+            <a:avLst/>
+          </a:prstGeom>
+        </p:spPr>
+      </p:pic>
+    </p:spTree>
+    <p:extLst>
+      <p:ext uri="{BB962C8B-B14F-4D97-AF65-F5344CB8AC3E}">
+        <p14:creationId xmlns:p14="http://schemas.microsoft.com/office/powerpoint/2010/main" val="329346897"/>
+      </p:ext>
+    </p:extLst>
+  </p:cSld>
+  <p:clrMapOvr>
+    <a:masterClrMapping/>
+  </p:clrMapOvr>
+</p:sld>
+</file>
+
+<file path=ppt/slides/slide19.xml><?xml version="1.0" encoding="utf-8"?>
+<p:sld xmlns:a="http://schemas.openxmlformats.org/drawingml/2006/main" xmlns:r="http://schemas.openxmlformats.org/officeDocument/2006/relationships" xmlns:p="http://schemas.openxmlformats.org/presentationml/2006/main">
+  <p:cSld>
+    <p:spTree>
+      <p:nvGrpSpPr>
+        <p:cNvPr id="1" name=""/>
+        <p:cNvGrpSpPr/>
+        <p:nvPr/>
+      </p:nvGrpSpPr>
+      <p:grpSpPr>
+        <a:xfrm>
+          <a:off x="0" y="0"/>
+          <a:ext cx="0" cy="0"/>
+          <a:chOff x="0" y="0"/>
+          <a:chExt cx="0" cy="0"/>
+        </a:xfrm>
+      </p:grpSpPr>
+      <mc:AlternateContent xmlns:mc="http://schemas.openxmlformats.org/markup-compatibility/2006">
+        <mc:Choice xmlns:a14="http://schemas.microsoft.com/office/drawing/2010/main" Requires="a14">
+          <p:sp>
+            <p:nvSpPr>
+              <p:cNvPr id="2" name="TextBox 1">
+                <a:extLst>
+                  <a:ext uri="{FF2B5EF4-FFF2-40B4-BE49-F238E27FC236}">
+                    <a16:creationId xmlns:a16="http://schemas.microsoft.com/office/drawing/2014/main" id="{68E945A7-064A-44D2-B79A-48E50FCB50A2}"/>
+                  </a:ext>
+                </a:extLst>
+              </p:cNvPr>
+              <p:cNvSpPr txBox="1"/>
+              <p:nvPr/>
+            </p:nvSpPr>
+            <p:spPr>
+              <a:xfrm>
+                <a:off x="149133" y="352697"/>
+                <a:ext cx="2241369" cy="3139321"/>
+              </a:xfrm>
+              <a:prstGeom prst="rect">
+                <a:avLst/>
+              </a:prstGeom>
+              <a:noFill/>
+            </p:spPr>
+            <p:txBody>
+              <a:bodyPr wrap="square" rtlCol="0">
+                <a:spAutoFit/>
+              </a:bodyPr>
+              <a:lstStyle/>
+              <a:p>
+                <a:r>
+                  <a:rPr lang="en-US" b="1" dirty="0"/>
+                  <a:t>Build slab with different sizes in z:</a:t>
+                </a:r>
+              </a:p>
+              <a:p>
+                <a:endParaRPr lang="en-US" dirty="0"/>
+              </a:p>
+              <a:p>
+                <a:r>
+                  <a:rPr lang="en-US" dirty="0"/>
+                  <a:t>Unit cells </a:t>
+                </a:r>
+                <a:r>
+                  <a:rPr lang="de-DE" dirty="0"/>
+                  <a:t>24x24x</a:t>
+                </a:r>
+                <a:r>
+                  <a:rPr lang="de-DE" b="1" dirty="0"/>
+                  <a:t>15</a:t>
+                </a:r>
+                <a:endParaRPr lang="en-US" b="1" dirty="0"/>
+              </a:p>
+              <a:p>
+                <a:r>
+                  <a:rPr lang="en-US" dirty="0"/>
+                  <a:t>R</a:t>
+                </a:r>
+                <a:r>
+                  <a:rPr lang="en-IN" dirty="0" err="1"/>
+                  <a:t>andom</a:t>
+                </a:r>
+                <a:r>
+                  <a:rPr lang="en-IN" dirty="0"/>
+                  <a:t> orientations</a:t>
+                </a:r>
+              </a:p>
+              <a:p>
+                <a:endParaRPr lang="en-IN" dirty="0"/>
+              </a:p>
+              <a:p>
+                <a:r>
+                  <a:rPr lang="en-IN" dirty="0"/>
+                  <a:t>Frequency shifted (</a:t>
+                </a:r>
+                <a:r>
+                  <a:rPr lang="el-GR" dirty="0"/>
+                  <a:t>ν0 = 2136.97</a:t>
+                </a:r>
+                <a:r>
+                  <a:rPr lang="en-IN" dirty="0"/>
+                  <a:t>)</a:t>
+                </a:r>
+              </a:p>
+              <a:p>
+                <a:endParaRPr lang="en-IN" dirty="0"/>
+              </a:p>
+              <a:p>
+                <a:r>
+                  <a:rPr lang="de-DE" dirty="0"/>
+                  <a:t>Theta = </a:t>
+                </a:r>
+                <a:r>
+                  <a:rPr lang="de-DE" b="1" dirty="0"/>
+                  <a:t>41</a:t>
+                </a:r>
+                <a:r>
+                  <a:rPr lang="de-DE" dirty="0"/>
+                  <a:t>°, </a:t>
+                </a:r>
+                <a14:m>
+                  <m:oMath xmlns:m="http://schemas.openxmlformats.org/officeDocument/2006/math">
+                    <m:r>
+                      <a:rPr lang="de-DE" b="0" i="1" smtClean="0">
+                        <a:latin typeface="Cambria Math" panose="02040503050406030204" pitchFamily="18" charset="0"/>
+                      </a:rPr>
+                      <m:t>𝛼</m:t>
+                    </m:r>
+                  </m:oMath>
+                </a14:m>
+                <a:r>
+                  <a:rPr lang="en-US" dirty="0"/>
+                  <a:t>=0 and µ01 = 0.105</a:t>
+                </a:r>
+                <a:endParaRPr lang="en-IN" dirty="0"/>
+              </a:p>
+            </p:txBody>
+          </p:sp>
+        </mc:Choice>
+        <mc:Fallback>
+          <p:sp>
+            <p:nvSpPr>
+              <p:cNvPr id="2" name="TextBox 1">
+                <a:extLst>
+                  <a:ext uri="{FF2B5EF4-FFF2-40B4-BE49-F238E27FC236}">
+                    <a16:creationId xmlns:a16="http://schemas.microsoft.com/office/drawing/2014/main" id="{68E945A7-064A-44D2-B79A-48E50FCB50A2}"/>
+                  </a:ext>
+                </a:extLst>
+              </p:cNvPr>
+              <p:cNvSpPr txBox="1">
+                <a:spLocks noRot="1" noChangeAspect="1" noMove="1" noResize="1" noEditPoints="1" noAdjustHandles="1" noChangeArrowheads="1" noChangeShapeType="1" noTextEdit="1"/>
+              </p:cNvSpPr>
+              <p:nvPr/>
+            </p:nvSpPr>
+            <p:spPr>
+              <a:xfrm>
+                <a:off x="149133" y="352697"/>
+                <a:ext cx="2241369" cy="3139321"/>
+              </a:xfrm>
+              <a:prstGeom prst="rect">
+                <a:avLst/>
+              </a:prstGeom>
+              <a:blipFill>
+                <a:blip r:embed="rId3"/>
+                <a:stretch>
+                  <a:fillRect l="-2174" t="-1165" r="-2446" b="-2136"/>
+                </a:stretch>
+              </a:blipFill>
+            </p:spPr>
+            <p:txBody>
+              <a:bodyPr/>
+              <a:lstStyle/>
+              <a:p>
+                <a:r>
+                  <a:rPr lang="en-US">
+                    <a:noFill/>
+                  </a:rPr>
+                  <a:t> </a:t>
+                </a:r>
+              </a:p>
+            </p:txBody>
+          </p:sp>
+        </mc:Fallback>
+      </mc:AlternateContent>
+      <p:pic>
+        <p:nvPicPr>
+          <p:cNvPr id="6" name="Picture 5">
+            <a:extLst>
+              <a:ext uri="{FF2B5EF4-FFF2-40B4-BE49-F238E27FC236}">
+                <a16:creationId xmlns:a16="http://schemas.microsoft.com/office/drawing/2014/main" id="{4BB7E91A-5135-4274-9AD4-A502AAF58FDE}"/>
+              </a:ext>
+            </a:extLst>
+          </p:cNvPr>
+          <p:cNvPicPr>
+            <a:picLocks noChangeAspect="1"/>
+          </p:cNvPicPr>
+          <p:nvPr/>
+        </p:nvPicPr>
+        <p:blipFill>
+          <a:blip r:embed="rId4">
+            <a:extLst>
+              <a:ext uri="{28A0092B-C50C-407E-A947-70E740481C1C}">
+                <a14:useLocalDpi xmlns:a14="http://schemas.microsoft.com/office/drawing/2010/main" val="0"/>
+              </a:ext>
+            </a:extLst>
+          </a:blip>
+          <a:srcRect/>
+          <a:stretch/>
+        </p:blipFill>
+        <p:spPr>
+          <a:xfrm>
+            <a:off x="3052866" y="536166"/>
+            <a:ext cx="8725773" cy="6087323"/>
+          </a:xfrm>
+          <a:prstGeom prst="rect">
+            <a:avLst/>
+          </a:prstGeom>
+        </p:spPr>
+      </p:pic>
+    </p:spTree>
+    <p:extLst>
+      <p:ext uri="{BB962C8B-B14F-4D97-AF65-F5344CB8AC3E}">
+        <p14:creationId xmlns:p14="http://schemas.microsoft.com/office/powerpoint/2010/main" val="550048327"/>
+      </p:ext>
+    </p:extLst>
+  </p:cSld>
+  <p:clrMapOvr>
+    <a:masterClrMapping/>
+  </p:clrMapOvr>
+</p:sld>
+</file>
+
 <file path=ppt/slides/slide2.xml><?xml version="1.0" encoding="utf-8"?>
 <p:sld xmlns:a="http://schemas.openxmlformats.org/drawingml/2006/main" xmlns:r="http://schemas.openxmlformats.org/officeDocument/2006/relationships" xmlns:p="http://schemas.openxmlformats.org/presentationml/2006/main">
   <p:cSld>
@@ -6177,8 +8246,8 @@
           </a:prstGeom>
         </p:spPr>
       </p:pic>
-      <mc:AlternateContent xmlns:mc="http://schemas.openxmlformats.org/markup-compatibility/2006">
-        <mc:Choice xmlns:a14="http://schemas.microsoft.com/office/drawing/2010/main" Requires="a14">
+      <mc:AlternateContent xmlns:mc="http://schemas.openxmlformats.org/markup-compatibility/2006" xmlns:a14="http://schemas.microsoft.com/office/drawing/2010/main">
+        <mc:Choice Requires="a14">
           <p:sp>
             <p:nvSpPr>
               <p:cNvPr id="5" name="TextBox 4">
@@ -6264,7 +8333,7 @@
             </p:txBody>
           </p:sp>
         </mc:Choice>
-        <mc:Fallback>
+        <mc:Fallback xmlns="">
           <p:sp>
             <p:nvSpPr>
               <p:cNvPr id="5" name="TextBox 4">
@@ -6322,7 +8391,7 @@
 </p:sld>
 </file>
 
-<file path=ppt/slides/slide3.xml><?xml version="1.0" encoding="utf-8"?>
+<file path=ppt/slides/slide20.xml><?xml version="1.0" encoding="utf-8"?>
 <p:sld xmlns:a="http://schemas.openxmlformats.org/drawingml/2006/main" xmlns:r="http://schemas.openxmlformats.org/officeDocument/2006/relationships" xmlns:p="http://schemas.openxmlformats.org/presentationml/2006/main">
   <p:cSld>
     <p:spTree>
@@ -6341,6 +8410,927 @@
       </p:grpSpPr>
       <mc:AlternateContent xmlns:mc="http://schemas.openxmlformats.org/markup-compatibility/2006">
         <mc:Choice xmlns:a14="http://schemas.microsoft.com/office/drawing/2010/main" Requires="a14">
+          <p:sp>
+            <p:nvSpPr>
+              <p:cNvPr id="2" name="TextBox 1">
+                <a:extLst>
+                  <a:ext uri="{FF2B5EF4-FFF2-40B4-BE49-F238E27FC236}">
+                    <a16:creationId xmlns:a16="http://schemas.microsoft.com/office/drawing/2014/main" id="{68E945A7-064A-44D2-B79A-48E50FCB50A2}"/>
+                  </a:ext>
+                </a:extLst>
+              </p:cNvPr>
+              <p:cNvSpPr txBox="1"/>
+              <p:nvPr/>
+            </p:nvSpPr>
+            <p:spPr>
+              <a:xfrm>
+                <a:off x="149133" y="352697"/>
+                <a:ext cx="2241369" cy="3139321"/>
+              </a:xfrm>
+              <a:prstGeom prst="rect">
+                <a:avLst/>
+              </a:prstGeom>
+              <a:noFill/>
+            </p:spPr>
+            <p:txBody>
+              <a:bodyPr wrap="square" rtlCol="0">
+                <a:spAutoFit/>
+              </a:bodyPr>
+              <a:lstStyle/>
+              <a:p>
+                <a:r>
+                  <a:rPr lang="en-US" b="1" dirty="0"/>
+                  <a:t>Build slab with different sizes in z:</a:t>
+                </a:r>
+              </a:p>
+              <a:p>
+                <a:endParaRPr lang="en-US" dirty="0"/>
+              </a:p>
+              <a:p>
+                <a:r>
+                  <a:rPr lang="en-US" dirty="0"/>
+                  <a:t>Unit cells </a:t>
+                </a:r>
+                <a:r>
+                  <a:rPr lang="de-DE" dirty="0"/>
+                  <a:t>24x24x</a:t>
+                </a:r>
+                <a:r>
+                  <a:rPr lang="de-DE" b="1" dirty="0"/>
+                  <a:t>15</a:t>
+                </a:r>
+                <a:endParaRPr lang="en-US" b="1" dirty="0"/>
+              </a:p>
+              <a:p>
+                <a:r>
+                  <a:rPr lang="en-US" dirty="0"/>
+                  <a:t>R</a:t>
+                </a:r>
+                <a:r>
+                  <a:rPr lang="en-IN" dirty="0" err="1"/>
+                  <a:t>andom</a:t>
+                </a:r>
+                <a:r>
+                  <a:rPr lang="en-IN" dirty="0"/>
+                  <a:t> orientations</a:t>
+                </a:r>
+              </a:p>
+              <a:p>
+                <a:endParaRPr lang="en-IN" dirty="0"/>
+              </a:p>
+              <a:p>
+                <a:r>
+                  <a:rPr lang="en-IN" dirty="0"/>
+                  <a:t>Frequency shifted (</a:t>
+                </a:r>
+                <a:r>
+                  <a:rPr lang="el-GR" dirty="0"/>
+                  <a:t>ν0 = 2136.97</a:t>
+                </a:r>
+                <a:r>
+                  <a:rPr lang="en-IN" dirty="0"/>
+                  <a:t>)</a:t>
+                </a:r>
+              </a:p>
+              <a:p>
+                <a:endParaRPr lang="en-IN" dirty="0"/>
+              </a:p>
+              <a:p>
+                <a:r>
+                  <a:rPr lang="de-DE" dirty="0"/>
+                  <a:t>Theta = </a:t>
+                </a:r>
+                <a:r>
+                  <a:rPr lang="de-DE" b="1" dirty="0"/>
+                  <a:t>41.5</a:t>
+                </a:r>
+                <a:r>
+                  <a:rPr lang="de-DE" dirty="0"/>
+                  <a:t>°, </a:t>
+                </a:r>
+                <a14:m>
+                  <m:oMath xmlns:m="http://schemas.openxmlformats.org/officeDocument/2006/math">
+                    <m:r>
+                      <a:rPr lang="de-DE" b="0" i="1" smtClean="0">
+                        <a:latin typeface="Cambria Math" panose="02040503050406030204" pitchFamily="18" charset="0"/>
+                      </a:rPr>
+                      <m:t>𝛼</m:t>
+                    </m:r>
+                  </m:oMath>
+                </a14:m>
+                <a:r>
+                  <a:rPr lang="en-US" dirty="0"/>
+                  <a:t>=0 and µ01 = 0.105</a:t>
+                </a:r>
+                <a:endParaRPr lang="en-IN" dirty="0"/>
+              </a:p>
+            </p:txBody>
+          </p:sp>
+        </mc:Choice>
+        <mc:Fallback>
+          <p:sp>
+            <p:nvSpPr>
+              <p:cNvPr id="2" name="TextBox 1">
+                <a:extLst>
+                  <a:ext uri="{FF2B5EF4-FFF2-40B4-BE49-F238E27FC236}">
+                    <a16:creationId xmlns:a16="http://schemas.microsoft.com/office/drawing/2014/main" id="{68E945A7-064A-44D2-B79A-48E50FCB50A2}"/>
+                  </a:ext>
+                </a:extLst>
+              </p:cNvPr>
+              <p:cNvSpPr txBox="1">
+                <a:spLocks noRot="1" noChangeAspect="1" noMove="1" noResize="1" noEditPoints="1" noAdjustHandles="1" noChangeArrowheads="1" noChangeShapeType="1" noTextEdit="1"/>
+              </p:cNvSpPr>
+              <p:nvPr/>
+            </p:nvSpPr>
+            <p:spPr>
+              <a:xfrm>
+                <a:off x="149133" y="352697"/>
+                <a:ext cx="2241369" cy="3139321"/>
+              </a:xfrm>
+              <a:prstGeom prst="rect">
+                <a:avLst/>
+              </a:prstGeom>
+              <a:blipFill>
+                <a:blip r:embed="rId3"/>
+                <a:stretch>
+                  <a:fillRect l="-2174" t="-1165" r="-2446" b="-2136"/>
+                </a:stretch>
+              </a:blipFill>
+            </p:spPr>
+            <p:txBody>
+              <a:bodyPr/>
+              <a:lstStyle/>
+              <a:p>
+                <a:r>
+                  <a:rPr lang="en-US">
+                    <a:noFill/>
+                  </a:rPr>
+                  <a:t> </a:t>
+                </a:r>
+              </a:p>
+            </p:txBody>
+          </p:sp>
+        </mc:Fallback>
+      </mc:AlternateContent>
+      <p:pic>
+        <p:nvPicPr>
+          <p:cNvPr id="6" name="Picture 5">
+            <a:extLst>
+              <a:ext uri="{FF2B5EF4-FFF2-40B4-BE49-F238E27FC236}">
+                <a16:creationId xmlns:a16="http://schemas.microsoft.com/office/drawing/2014/main" id="{4BB7E91A-5135-4274-9AD4-A502AAF58FDE}"/>
+              </a:ext>
+            </a:extLst>
+          </p:cNvPr>
+          <p:cNvPicPr>
+            <a:picLocks noChangeAspect="1"/>
+          </p:cNvPicPr>
+          <p:nvPr/>
+        </p:nvPicPr>
+        <p:blipFill>
+          <a:blip r:embed="rId4">
+            <a:extLst>
+              <a:ext uri="{28A0092B-C50C-407E-A947-70E740481C1C}">
+                <a14:useLocalDpi xmlns:a14="http://schemas.microsoft.com/office/drawing/2010/main" val="0"/>
+              </a:ext>
+            </a:extLst>
+          </a:blip>
+          <a:srcRect/>
+          <a:stretch/>
+        </p:blipFill>
+        <p:spPr>
+          <a:xfrm>
+            <a:off x="3052866" y="538782"/>
+            <a:ext cx="8725773" cy="6082090"/>
+          </a:xfrm>
+          <a:prstGeom prst="rect">
+            <a:avLst/>
+          </a:prstGeom>
+        </p:spPr>
+      </p:pic>
+    </p:spTree>
+    <p:extLst>
+      <p:ext uri="{BB962C8B-B14F-4D97-AF65-F5344CB8AC3E}">
+        <p14:creationId xmlns:p14="http://schemas.microsoft.com/office/powerpoint/2010/main" val="3112157876"/>
+      </p:ext>
+    </p:extLst>
+  </p:cSld>
+  <p:clrMapOvr>
+    <a:masterClrMapping/>
+  </p:clrMapOvr>
+</p:sld>
+</file>
+
+<file path=ppt/slides/slide21.xml><?xml version="1.0" encoding="utf-8"?>
+<p:sld xmlns:a="http://schemas.openxmlformats.org/drawingml/2006/main" xmlns:r="http://schemas.openxmlformats.org/officeDocument/2006/relationships" xmlns:p="http://schemas.openxmlformats.org/presentationml/2006/main">
+  <p:cSld>
+    <p:spTree>
+      <p:nvGrpSpPr>
+        <p:cNvPr id="1" name=""/>
+        <p:cNvGrpSpPr/>
+        <p:nvPr/>
+      </p:nvGrpSpPr>
+      <p:grpSpPr>
+        <a:xfrm>
+          <a:off x="0" y="0"/>
+          <a:ext cx="0" cy="0"/>
+          <a:chOff x="0" y="0"/>
+          <a:chExt cx="0" cy="0"/>
+        </a:xfrm>
+      </p:grpSpPr>
+      <mc:AlternateContent xmlns:mc="http://schemas.openxmlformats.org/markup-compatibility/2006">
+        <mc:Choice xmlns:a14="http://schemas.microsoft.com/office/drawing/2010/main" Requires="a14">
+          <p:sp>
+            <p:nvSpPr>
+              <p:cNvPr id="2" name="TextBox 1">
+                <a:extLst>
+                  <a:ext uri="{FF2B5EF4-FFF2-40B4-BE49-F238E27FC236}">
+                    <a16:creationId xmlns:a16="http://schemas.microsoft.com/office/drawing/2014/main" id="{68E945A7-064A-44D2-B79A-48E50FCB50A2}"/>
+                  </a:ext>
+                </a:extLst>
+              </p:cNvPr>
+              <p:cNvSpPr txBox="1"/>
+              <p:nvPr/>
+            </p:nvSpPr>
+            <p:spPr>
+              <a:xfrm>
+                <a:off x="149133" y="352697"/>
+                <a:ext cx="2241369" cy="3139321"/>
+              </a:xfrm>
+              <a:prstGeom prst="rect">
+                <a:avLst/>
+              </a:prstGeom>
+              <a:noFill/>
+            </p:spPr>
+            <p:txBody>
+              <a:bodyPr wrap="square" rtlCol="0">
+                <a:spAutoFit/>
+              </a:bodyPr>
+              <a:lstStyle/>
+              <a:p>
+                <a:r>
+                  <a:rPr lang="en-US" b="1" dirty="0"/>
+                  <a:t>Build slab with different sizes in z:</a:t>
+                </a:r>
+              </a:p>
+              <a:p>
+                <a:endParaRPr lang="en-US" dirty="0"/>
+              </a:p>
+              <a:p>
+                <a:r>
+                  <a:rPr lang="en-US" dirty="0"/>
+                  <a:t>Unit cells </a:t>
+                </a:r>
+                <a:r>
+                  <a:rPr lang="de-DE" dirty="0"/>
+                  <a:t>24x24x</a:t>
+                </a:r>
+                <a:r>
+                  <a:rPr lang="de-DE" b="1" dirty="0"/>
+                  <a:t>15</a:t>
+                </a:r>
+                <a:endParaRPr lang="en-US" b="1" dirty="0"/>
+              </a:p>
+              <a:p>
+                <a:r>
+                  <a:rPr lang="en-US" dirty="0"/>
+                  <a:t>R</a:t>
+                </a:r>
+                <a:r>
+                  <a:rPr lang="en-IN" dirty="0" err="1"/>
+                  <a:t>andom</a:t>
+                </a:r>
+                <a:r>
+                  <a:rPr lang="en-IN" dirty="0"/>
+                  <a:t> orientations</a:t>
+                </a:r>
+              </a:p>
+              <a:p>
+                <a:endParaRPr lang="en-IN" dirty="0"/>
+              </a:p>
+              <a:p>
+                <a:r>
+                  <a:rPr lang="en-IN" dirty="0"/>
+                  <a:t>Frequency shifted (</a:t>
+                </a:r>
+                <a:r>
+                  <a:rPr lang="el-GR" dirty="0"/>
+                  <a:t>ν0 = 2136.97</a:t>
+                </a:r>
+                <a:r>
+                  <a:rPr lang="en-IN" dirty="0"/>
+                  <a:t>)</a:t>
+                </a:r>
+              </a:p>
+              <a:p>
+                <a:endParaRPr lang="en-IN" dirty="0"/>
+              </a:p>
+              <a:p>
+                <a:r>
+                  <a:rPr lang="de-DE" dirty="0"/>
+                  <a:t>Theta = </a:t>
+                </a:r>
+                <a:r>
+                  <a:rPr lang="de-DE" b="1" dirty="0"/>
+                  <a:t>42</a:t>
+                </a:r>
+                <a:r>
+                  <a:rPr lang="de-DE" dirty="0"/>
+                  <a:t>°, </a:t>
+                </a:r>
+                <a14:m>
+                  <m:oMath xmlns:m="http://schemas.openxmlformats.org/officeDocument/2006/math">
+                    <m:r>
+                      <a:rPr lang="de-DE" b="0" i="1" smtClean="0">
+                        <a:latin typeface="Cambria Math" panose="02040503050406030204" pitchFamily="18" charset="0"/>
+                      </a:rPr>
+                      <m:t>𝛼</m:t>
+                    </m:r>
+                  </m:oMath>
+                </a14:m>
+                <a:r>
+                  <a:rPr lang="en-US" dirty="0"/>
+                  <a:t>=0 and µ01 = 0.105</a:t>
+                </a:r>
+                <a:endParaRPr lang="en-IN" dirty="0"/>
+              </a:p>
+            </p:txBody>
+          </p:sp>
+        </mc:Choice>
+        <mc:Fallback>
+          <p:sp>
+            <p:nvSpPr>
+              <p:cNvPr id="2" name="TextBox 1">
+                <a:extLst>
+                  <a:ext uri="{FF2B5EF4-FFF2-40B4-BE49-F238E27FC236}">
+                    <a16:creationId xmlns:a16="http://schemas.microsoft.com/office/drawing/2014/main" id="{68E945A7-064A-44D2-B79A-48E50FCB50A2}"/>
+                  </a:ext>
+                </a:extLst>
+              </p:cNvPr>
+              <p:cNvSpPr txBox="1">
+                <a:spLocks noRot="1" noChangeAspect="1" noMove="1" noResize="1" noEditPoints="1" noAdjustHandles="1" noChangeArrowheads="1" noChangeShapeType="1" noTextEdit="1"/>
+              </p:cNvSpPr>
+              <p:nvPr/>
+            </p:nvSpPr>
+            <p:spPr>
+              <a:xfrm>
+                <a:off x="149133" y="352697"/>
+                <a:ext cx="2241369" cy="3139321"/>
+              </a:xfrm>
+              <a:prstGeom prst="rect">
+                <a:avLst/>
+              </a:prstGeom>
+              <a:blipFill>
+                <a:blip r:embed="rId3"/>
+                <a:stretch>
+                  <a:fillRect l="-2174" t="-1165" r="-2446" b="-2136"/>
+                </a:stretch>
+              </a:blipFill>
+            </p:spPr>
+            <p:txBody>
+              <a:bodyPr/>
+              <a:lstStyle/>
+              <a:p>
+                <a:r>
+                  <a:rPr lang="en-US">
+                    <a:noFill/>
+                  </a:rPr>
+                  <a:t> </a:t>
+                </a:r>
+              </a:p>
+            </p:txBody>
+          </p:sp>
+        </mc:Fallback>
+      </mc:AlternateContent>
+      <p:pic>
+        <p:nvPicPr>
+          <p:cNvPr id="7" name="Picture 6">
+            <a:extLst>
+              <a:ext uri="{FF2B5EF4-FFF2-40B4-BE49-F238E27FC236}">
+                <a16:creationId xmlns:a16="http://schemas.microsoft.com/office/drawing/2014/main" id="{CABFD287-D44C-411D-9667-E250086FCFE7}"/>
+              </a:ext>
+            </a:extLst>
+          </p:cNvPr>
+          <p:cNvPicPr>
+            <a:picLocks noChangeAspect="1"/>
+          </p:cNvPicPr>
+          <p:nvPr/>
+        </p:nvPicPr>
+        <p:blipFill>
+          <a:blip r:embed="rId4">
+            <a:extLst>
+              <a:ext uri="{28A0092B-C50C-407E-A947-70E740481C1C}">
+                <a14:useLocalDpi xmlns:a14="http://schemas.microsoft.com/office/drawing/2010/main" val="0"/>
+              </a:ext>
+            </a:extLst>
+          </a:blip>
+          <a:stretch>
+            <a:fillRect/>
+          </a:stretch>
+        </p:blipFill>
+        <p:spPr>
+          <a:xfrm>
+            <a:off x="2838192" y="383161"/>
+            <a:ext cx="8742450" cy="6091678"/>
+          </a:xfrm>
+          <a:prstGeom prst="rect">
+            <a:avLst/>
+          </a:prstGeom>
+        </p:spPr>
+      </p:pic>
+    </p:spTree>
+    <p:extLst>
+      <p:ext uri="{BB962C8B-B14F-4D97-AF65-F5344CB8AC3E}">
+        <p14:creationId xmlns:p14="http://schemas.microsoft.com/office/powerpoint/2010/main" val="1887348836"/>
+      </p:ext>
+    </p:extLst>
+  </p:cSld>
+  <p:clrMapOvr>
+    <a:masterClrMapping/>
+  </p:clrMapOvr>
+</p:sld>
+</file>
+
+<file path=ppt/slides/slide22.xml><?xml version="1.0" encoding="utf-8"?>
+<p:sld xmlns:a="http://schemas.openxmlformats.org/drawingml/2006/main" xmlns:r="http://schemas.openxmlformats.org/officeDocument/2006/relationships" xmlns:p="http://schemas.openxmlformats.org/presentationml/2006/main">
+  <p:cSld>
+    <p:spTree>
+      <p:nvGrpSpPr>
+        <p:cNvPr id="1" name=""/>
+        <p:cNvGrpSpPr/>
+        <p:nvPr/>
+      </p:nvGrpSpPr>
+      <p:grpSpPr>
+        <a:xfrm>
+          <a:off x="0" y="0"/>
+          <a:ext cx="0" cy="0"/>
+          <a:chOff x="0" y="0"/>
+          <a:chExt cx="0" cy="0"/>
+        </a:xfrm>
+      </p:grpSpPr>
+      <mc:AlternateContent xmlns:mc="http://schemas.openxmlformats.org/markup-compatibility/2006">
+        <mc:Choice xmlns:a14="http://schemas.microsoft.com/office/drawing/2010/main" Requires="a14">
+          <p:sp>
+            <p:nvSpPr>
+              <p:cNvPr id="2" name="TextBox 1">
+                <a:extLst>
+                  <a:ext uri="{FF2B5EF4-FFF2-40B4-BE49-F238E27FC236}">
+                    <a16:creationId xmlns:a16="http://schemas.microsoft.com/office/drawing/2014/main" id="{68E945A7-064A-44D2-B79A-48E50FCB50A2}"/>
+                  </a:ext>
+                </a:extLst>
+              </p:cNvPr>
+              <p:cNvSpPr txBox="1"/>
+              <p:nvPr/>
+            </p:nvSpPr>
+            <p:spPr>
+              <a:xfrm>
+                <a:off x="149133" y="352697"/>
+                <a:ext cx="2241369" cy="4247317"/>
+              </a:xfrm>
+              <a:prstGeom prst="rect">
+                <a:avLst/>
+              </a:prstGeom>
+              <a:noFill/>
+            </p:spPr>
+            <p:txBody>
+              <a:bodyPr wrap="square" rtlCol="0">
+                <a:spAutoFit/>
+              </a:bodyPr>
+              <a:lstStyle/>
+              <a:p>
+                <a:r>
+                  <a:rPr lang="en-US" b="1" dirty="0"/>
+                  <a:t>Build slab with different sizes in z:</a:t>
+                </a:r>
+              </a:p>
+              <a:p>
+                <a:endParaRPr lang="en-US" dirty="0"/>
+              </a:p>
+              <a:p>
+                <a:r>
+                  <a:rPr lang="en-US" dirty="0"/>
+                  <a:t>Unit cells </a:t>
+                </a:r>
+                <a:r>
+                  <a:rPr lang="de-DE" dirty="0"/>
+                  <a:t>24x24x</a:t>
+                </a:r>
+                <a:r>
+                  <a:rPr lang="de-DE" b="1" dirty="0"/>
+                  <a:t>15</a:t>
+                </a:r>
+                <a:endParaRPr lang="en-US" b="1" dirty="0"/>
+              </a:p>
+              <a:p>
+                <a:r>
+                  <a:rPr lang="en-US" dirty="0"/>
+                  <a:t>R</a:t>
+                </a:r>
+                <a:r>
+                  <a:rPr lang="en-IN" dirty="0" err="1"/>
+                  <a:t>andom</a:t>
+                </a:r>
+                <a:r>
+                  <a:rPr lang="en-IN" dirty="0"/>
+                  <a:t> orientations</a:t>
+                </a:r>
+              </a:p>
+              <a:p>
+                <a:endParaRPr lang="en-IN" dirty="0"/>
+              </a:p>
+              <a:p>
+                <a:r>
+                  <a:rPr lang="en-IN" dirty="0"/>
+                  <a:t>Frequency shifted (</a:t>
+                </a:r>
+                <a:r>
+                  <a:rPr lang="el-GR" dirty="0"/>
+                  <a:t>ν0 = </a:t>
+                </a:r>
+                <a:r>
+                  <a:rPr lang="el-GR" b="1" dirty="0"/>
+                  <a:t>21</a:t>
+                </a:r>
+                <a:r>
+                  <a:rPr lang="de-DE" b="1" dirty="0"/>
+                  <a:t>38.0</a:t>
+                </a:r>
+                <a:r>
+                  <a:rPr lang="en-IN" b="1" dirty="0"/>
+                  <a:t>), shifted afterwards by 1.03 cm-1 again. -&gt;f </a:t>
+                </a:r>
+                <a:r>
+                  <a:rPr lang="en-IN" b="1" dirty="0" err="1"/>
+                  <a:t>requencies</a:t>
+                </a:r>
+                <a:r>
+                  <a:rPr lang="en-IN" b="1" dirty="0"/>
+                  <a:t> can be shifted afterwards</a:t>
+                </a:r>
+              </a:p>
+              <a:p>
+                <a:endParaRPr lang="en-IN" dirty="0"/>
+              </a:p>
+              <a:p>
+                <a:r>
+                  <a:rPr lang="de-DE" dirty="0"/>
+                  <a:t>Theta = 42°, </a:t>
+                </a:r>
+                <a14:m>
+                  <m:oMath xmlns:m="http://schemas.openxmlformats.org/officeDocument/2006/math">
+                    <m:r>
+                      <a:rPr lang="de-DE" b="0" i="1" smtClean="0">
+                        <a:latin typeface="Cambria Math" panose="02040503050406030204" pitchFamily="18" charset="0"/>
+                      </a:rPr>
+                      <m:t>𝛼</m:t>
+                    </m:r>
+                  </m:oMath>
+                </a14:m>
+                <a:r>
+                  <a:rPr lang="en-US" dirty="0"/>
+                  <a:t>=0 and µ01 = 0.105</a:t>
+                </a:r>
+                <a:endParaRPr lang="en-IN" dirty="0"/>
+              </a:p>
+            </p:txBody>
+          </p:sp>
+        </mc:Choice>
+        <mc:Fallback>
+          <p:sp>
+            <p:nvSpPr>
+              <p:cNvPr id="2" name="TextBox 1">
+                <a:extLst>
+                  <a:ext uri="{FF2B5EF4-FFF2-40B4-BE49-F238E27FC236}">
+                    <a16:creationId xmlns:a16="http://schemas.microsoft.com/office/drawing/2014/main" id="{68E945A7-064A-44D2-B79A-48E50FCB50A2}"/>
+                  </a:ext>
+                </a:extLst>
+              </p:cNvPr>
+              <p:cNvSpPr txBox="1">
+                <a:spLocks noRot="1" noChangeAspect="1" noMove="1" noResize="1" noEditPoints="1" noAdjustHandles="1" noChangeArrowheads="1" noChangeShapeType="1" noTextEdit="1"/>
+              </p:cNvSpPr>
+              <p:nvPr/>
+            </p:nvSpPr>
+            <p:spPr>
+              <a:xfrm>
+                <a:off x="149133" y="352697"/>
+                <a:ext cx="2241369" cy="4247317"/>
+              </a:xfrm>
+              <a:prstGeom prst="rect">
+                <a:avLst/>
+              </a:prstGeom>
+              <a:blipFill>
+                <a:blip r:embed="rId3"/>
+                <a:stretch>
+                  <a:fillRect l="-2174" t="-861" r="-2446" b="-1291"/>
+                </a:stretch>
+              </a:blipFill>
+            </p:spPr>
+            <p:txBody>
+              <a:bodyPr/>
+              <a:lstStyle/>
+              <a:p>
+                <a:r>
+                  <a:rPr lang="en-US">
+                    <a:noFill/>
+                  </a:rPr>
+                  <a:t> </a:t>
+                </a:r>
+              </a:p>
+            </p:txBody>
+          </p:sp>
+        </mc:Fallback>
+      </mc:AlternateContent>
+      <p:pic>
+        <p:nvPicPr>
+          <p:cNvPr id="7" name="Picture 6">
+            <a:extLst>
+              <a:ext uri="{FF2B5EF4-FFF2-40B4-BE49-F238E27FC236}">
+                <a16:creationId xmlns:a16="http://schemas.microsoft.com/office/drawing/2014/main" id="{CABFD287-D44C-411D-9667-E250086FCFE7}"/>
+              </a:ext>
+            </a:extLst>
+          </p:cNvPr>
+          <p:cNvPicPr>
+            <a:picLocks noChangeAspect="1"/>
+          </p:cNvPicPr>
+          <p:nvPr/>
+        </p:nvPicPr>
+        <p:blipFill>
+          <a:blip r:embed="rId4">
+            <a:extLst>
+              <a:ext uri="{28A0092B-C50C-407E-A947-70E740481C1C}">
+                <a14:useLocalDpi xmlns:a14="http://schemas.microsoft.com/office/drawing/2010/main" val="0"/>
+              </a:ext>
+            </a:extLst>
+          </a:blip>
+          <a:srcRect/>
+          <a:stretch/>
+        </p:blipFill>
+        <p:spPr>
+          <a:xfrm>
+            <a:off x="2839653" y="383161"/>
+            <a:ext cx="8739528" cy="6091678"/>
+          </a:xfrm>
+          <a:prstGeom prst="rect">
+            <a:avLst/>
+          </a:prstGeom>
+        </p:spPr>
+      </p:pic>
+    </p:spTree>
+    <p:extLst>
+      <p:ext uri="{BB962C8B-B14F-4D97-AF65-F5344CB8AC3E}">
+        <p14:creationId xmlns:p14="http://schemas.microsoft.com/office/powerpoint/2010/main" val="3269282772"/>
+      </p:ext>
+    </p:extLst>
+  </p:cSld>
+  <p:clrMapOvr>
+    <a:masterClrMapping/>
+  </p:clrMapOvr>
+</p:sld>
+</file>
+
+<file path=ppt/slides/slide23.xml><?xml version="1.0" encoding="utf-8"?>
+<p:sld xmlns:a="http://schemas.openxmlformats.org/drawingml/2006/main" xmlns:r="http://schemas.openxmlformats.org/officeDocument/2006/relationships" xmlns:p="http://schemas.openxmlformats.org/presentationml/2006/main">
+  <p:cSld>
+    <p:spTree>
+      <p:nvGrpSpPr>
+        <p:cNvPr id="1" name=""/>
+        <p:cNvGrpSpPr/>
+        <p:nvPr/>
+      </p:nvGrpSpPr>
+      <p:grpSpPr>
+        <a:xfrm>
+          <a:off x="0" y="0"/>
+          <a:ext cx="0" cy="0"/>
+          <a:chOff x="0" y="0"/>
+          <a:chExt cx="0" cy="0"/>
+        </a:xfrm>
+      </p:grpSpPr>
+      <mc:AlternateContent xmlns:mc="http://schemas.openxmlformats.org/markup-compatibility/2006">
+        <mc:Choice xmlns:a14="http://schemas.microsoft.com/office/drawing/2010/main" Requires="a14">
+          <p:sp>
+            <p:nvSpPr>
+              <p:cNvPr id="2" name="TextBox 1">
+                <a:extLst>
+                  <a:ext uri="{FF2B5EF4-FFF2-40B4-BE49-F238E27FC236}">
+                    <a16:creationId xmlns:a16="http://schemas.microsoft.com/office/drawing/2014/main" id="{68E945A7-064A-44D2-B79A-48E50FCB50A2}"/>
+                  </a:ext>
+                </a:extLst>
+              </p:cNvPr>
+              <p:cNvSpPr txBox="1"/>
+              <p:nvPr/>
+            </p:nvSpPr>
+            <p:spPr>
+              <a:xfrm>
+                <a:off x="149133" y="352697"/>
+                <a:ext cx="2241369" cy="3139321"/>
+              </a:xfrm>
+              <a:prstGeom prst="rect">
+                <a:avLst/>
+              </a:prstGeom>
+              <a:noFill/>
+            </p:spPr>
+            <p:txBody>
+              <a:bodyPr wrap="square" rtlCol="0">
+                <a:spAutoFit/>
+              </a:bodyPr>
+              <a:lstStyle/>
+              <a:p>
+                <a:r>
+                  <a:rPr lang="en-US" b="1" dirty="0"/>
+                  <a:t>Build slab with different sizes in z:</a:t>
+                </a:r>
+              </a:p>
+              <a:p>
+                <a:endParaRPr lang="en-US" dirty="0"/>
+              </a:p>
+              <a:p>
+                <a:r>
+                  <a:rPr lang="en-US" dirty="0"/>
+                  <a:t>Unit cells </a:t>
+                </a:r>
+                <a:r>
+                  <a:rPr lang="de-DE" dirty="0"/>
+                  <a:t>24x24x15</a:t>
+                </a:r>
+                <a:endParaRPr lang="en-US" dirty="0"/>
+              </a:p>
+              <a:p>
+                <a:r>
+                  <a:rPr lang="en-US" dirty="0"/>
+                  <a:t>R</a:t>
+                </a:r>
+                <a:r>
+                  <a:rPr lang="en-IN" dirty="0" err="1"/>
+                  <a:t>andom</a:t>
+                </a:r>
+                <a:r>
+                  <a:rPr lang="en-IN" dirty="0"/>
+                  <a:t> orientations</a:t>
+                </a:r>
+              </a:p>
+              <a:p>
+                <a:endParaRPr lang="en-IN" dirty="0"/>
+              </a:p>
+              <a:p>
+                <a:r>
+                  <a:rPr lang="en-IN" dirty="0"/>
+                  <a:t>Frequency shifted (</a:t>
+                </a:r>
+                <a:r>
+                  <a:rPr lang="el-GR" dirty="0"/>
+                  <a:t>ν0 = 2136.97</a:t>
+                </a:r>
+                <a:r>
+                  <a:rPr lang="en-IN" dirty="0"/>
+                  <a:t>)</a:t>
+                </a:r>
+              </a:p>
+              <a:p>
+                <a:endParaRPr lang="en-IN" dirty="0"/>
+              </a:p>
+              <a:p>
+                <a:r>
+                  <a:rPr lang="de-DE" dirty="0"/>
+                  <a:t>Theta = </a:t>
+                </a:r>
+                <a:r>
+                  <a:rPr lang="de-DE" b="1" dirty="0"/>
+                  <a:t>43</a:t>
+                </a:r>
+                <a:r>
+                  <a:rPr lang="de-DE" dirty="0"/>
+                  <a:t>°, </a:t>
+                </a:r>
+                <a14:m>
+                  <m:oMath xmlns:m="http://schemas.openxmlformats.org/officeDocument/2006/math">
+                    <m:r>
+                      <a:rPr lang="de-DE" b="0" i="1" smtClean="0">
+                        <a:latin typeface="Cambria Math" panose="02040503050406030204" pitchFamily="18" charset="0"/>
+                      </a:rPr>
+                      <m:t>𝛼</m:t>
+                    </m:r>
+                  </m:oMath>
+                </a14:m>
+                <a:r>
+                  <a:rPr lang="en-US" dirty="0"/>
+                  <a:t>=0 and µ01 = 0.105</a:t>
+                </a:r>
+                <a:endParaRPr lang="en-IN" dirty="0"/>
+              </a:p>
+            </p:txBody>
+          </p:sp>
+        </mc:Choice>
+        <mc:Fallback>
+          <p:sp>
+            <p:nvSpPr>
+              <p:cNvPr id="2" name="TextBox 1">
+                <a:extLst>
+                  <a:ext uri="{FF2B5EF4-FFF2-40B4-BE49-F238E27FC236}">
+                    <a16:creationId xmlns:a16="http://schemas.microsoft.com/office/drawing/2014/main" id="{68E945A7-064A-44D2-B79A-48E50FCB50A2}"/>
+                  </a:ext>
+                </a:extLst>
+              </p:cNvPr>
+              <p:cNvSpPr txBox="1">
+                <a:spLocks noRot="1" noChangeAspect="1" noMove="1" noResize="1" noEditPoints="1" noAdjustHandles="1" noChangeArrowheads="1" noChangeShapeType="1" noTextEdit="1"/>
+              </p:cNvSpPr>
+              <p:nvPr/>
+            </p:nvSpPr>
+            <p:spPr>
+              <a:xfrm>
+                <a:off x="149133" y="352697"/>
+                <a:ext cx="2241369" cy="3139321"/>
+              </a:xfrm>
+              <a:prstGeom prst="rect">
+                <a:avLst/>
+              </a:prstGeom>
+              <a:blipFill>
+                <a:blip r:embed="rId3"/>
+                <a:stretch>
+                  <a:fillRect l="-2174" t="-1165" r="-2446" b="-2136"/>
+                </a:stretch>
+              </a:blipFill>
+            </p:spPr>
+            <p:txBody>
+              <a:bodyPr/>
+              <a:lstStyle/>
+              <a:p>
+                <a:r>
+                  <a:rPr lang="en-US">
+                    <a:noFill/>
+                  </a:rPr>
+                  <a:t> </a:t>
+                </a:r>
+              </a:p>
+            </p:txBody>
+          </p:sp>
+        </mc:Fallback>
+      </mc:AlternateContent>
+      <p:pic>
+        <p:nvPicPr>
+          <p:cNvPr id="7" name="Picture 6">
+            <a:extLst>
+              <a:ext uri="{FF2B5EF4-FFF2-40B4-BE49-F238E27FC236}">
+                <a16:creationId xmlns:a16="http://schemas.microsoft.com/office/drawing/2014/main" id="{CABFD287-D44C-411D-9667-E250086FCFE7}"/>
+              </a:ext>
+            </a:extLst>
+          </p:cNvPr>
+          <p:cNvPicPr>
+            <a:picLocks noChangeAspect="1"/>
+          </p:cNvPicPr>
+          <p:nvPr/>
+        </p:nvPicPr>
+        <p:blipFill>
+          <a:blip r:embed="rId4">
+            <a:extLst>
+              <a:ext uri="{28A0092B-C50C-407E-A947-70E740481C1C}">
+                <a14:useLocalDpi xmlns:a14="http://schemas.microsoft.com/office/drawing/2010/main" val="0"/>
+              </a:ext>
+            </a:extLst>
+          </a:blip>
+          <a:srcRect/>
+          <a:stretch/>
+        </p:blipFill>
+        <p:spPr>
+          <a:xfrm>
+            <a:off x="2839653" y="383161"/>
+            <a:ext cx="8739528" cy="6091678"/>
+          </a:xfrm>
+          <a:prstGeom prst="rect">
+            <a:avLst/>
+          </a:prstGeom>
+        </p:spPr>
+      </p:pic>
+    </p:spTree>
+    <p:extLst>
+      <p:ext uri="{BB962C8B-B14F-4D97-AF65-F5344CB8AC3E}">
+        <p14:creationId xmlns:p14="http://schemas.microsoft.com/office/powerpoint/2010/main" val="2990607521"/>
+      </p:ext>
+    </p:extLst>
+  </p:cSld>
+  <p:clrMapOvr>
+    <a:masterClrMapping/>
+  </p:clrMapOvr>
+</p:sld>
+</file>
+
+<file path=ppt/slides/slide3.xml><?xml version="1.0" encoding="utf-8"?>
+<p:sld xmlns:a="http://schemas.openxmlformats.org/drawingml/2006/main" xmlns:r="http://schemas.openxmlformats.org/officeDocument/2006/relationships" xmlns:p="http://schemas.openxmlformats.org/presentationml/2006/main">
+  <p:cSld>
+    <p:spTree>
+      <p:nvGrpSpPr>
+        <p:cNvPr id="1" name=""/>
+        <p:cNvGrpSpPr/>
+        <p:nvPr/>
+      </p:nvGrpSpPr>
+      <p:grpSpPr>
+        <a:xfrm>
+          <a:off x="0" y="0"/>
+          <a:ext cx="0" cy="0"/>
+          <a:chOff x="0" y="0"/>
+          <a:chExt cx="0" cy="0"/>
+        </a:xfrm>
+      </p:grpSpPr>
+      <mc:AlternateContent xmlns:mc="http://schemas.openxmlformats.org/markup-compatibility/2006" xmlns:a14="http://schemas.microsoft.com/office/drawing/2010/main">
+        <mc:Choice Requires="a14">
           <p:sp>
             <p:nvSpPr>
               <p:cNvPr id="5" name="TextBox 4">
@@ -6426,7 +9416,7 @@
             </p:txBody>
           </p:sp>
         </mc:Choice>
-        <mc:Fallback>
+        <mc:Fallback xmlns="">
           <p:sp>
             <p:nvSpPr>
               <p:cNvPr id="5" name="TextBox 4">
@@ -6531,8 +9521,8 @@
           <a:chExt cx="0" cy="0"/>
         </a:xfrm>
       </p:grpSpPr>
-      <mc:AlternateContent xmlns:mc="http://schemas.openxmlformats.org/markup-compatibility/2006">
-        <mc:Choice xmlns:a14="http://schemas.microsoft.com/office/drawing/2010/main" Requires="a14">
+      <mc:AlternateContent xmlns:mc="http://schemas.openxmlformats.org/markup-compatibility/2006" xmlns:a14="http://schemas.microsoft.com/office/drawing/2010/main">
+        <mc:Choice Requires="a14">
           <p:sp>
             <p:nvSpPr>
               <p:cNvPr id="5" name="TextBox 4">
@@ -6618,7 +9608,7 @@
             </p:txBody>
           </p:sp>
         </mc:Choice>
-        <mc:Fallback>
+        <mc:Fallback xmlns="">
           <p:sp>
             <p:nvSpPr>
               <p:cNvPr id="5" name="TextBox 4">
@@ -6729,8 +9719,8 @@
           <a:chExt cx="0" cy="0"/>
         </a:xfrm>
       </p:grpSpPr>
-      <mc:AlternateContent xmlns:mc="http://schemas.openxmlformats.org/markup-compatibility/2006">
-        <mc:Choice xmlns:a14="http://schemas.microsoft.com/office/drawing/2010/main" Requires="a14">
+      <mc:AlternateContent xmlns:mc="http://schemas.openxmlformats.org/markup-compatibility/2006" xmlns:a14="http://schemas.microsoft.com/office/drawing/2010/main">
+        <mc:Choice Requires="a14">
           <p:sp>
             <p:nvSpPr>
               <p:cNvPr id="5" name="TextBox 4">
@@ -6816,7 +9806,7 @@
             </p:txBody>
           </p:sp>
         </mc:Choice>
-        <mc:Fallback>
+        <mc:Fallback xmlns="">
           <p:sp>
             <p:nvSpPr>
               <p:cNvPr id="5" name="TextBox 4">
@@ -6927,8 +9917,8 @@
           <a:chExt cx="0" cy="0"/>
         </a:xfrm>
       </p:grpSpPr>
-      <mc:AlternateContent xmlns:mc="http://schemas.openxmlformats.org/markup-compatibility/2006">
-        <mc:Choice xmlns:a14="http://schemas.microsoft.com/office/drawing/2010/main" Requires="a14">
+      <mc:AlternateContent xmlns:mc="http://schemas.openxmlformats.org/markup-compatibility/2006" xmlns:a14="http://schemas.microsoft.com/office/drawing/2010/main">
+        <mc:Choice Requires="a14">
           <p:sp>
             <p:nvSpPr>
               <p:cNvPr id="5" name="TextBox 4">
@@ -7023,7 +10013,7 @@
             </p:txBody>
           </p:sp>
         </mc:Choice>
-        <mc:Fallback>
+        <mc:Fallback xmlns="">
           <p:sp>
             <p:nvSpPr>
               <p:cNvPr id="5" name="TextBox 4">
@@ -7134,8 +10124,8 @@
           <a:chExt cx="0" cy="0"/>
         </a:xfrm>
       </p:grpSpPr>
-      <mc:AlternateContent xmlns:mc="http://schemas.openxmlformats.org/markup-compatibility/2006">
-        <mc:Choice xmlns:a14="http://schemas.microsoft.com/office/drawing/2010/main" Requires="a14">
+      <mc:AlternateContent xmlns:mc="http://schemas.openxmlformats.org/markup-compatibility/2006" xmlns:a14="http://schemas.microsoft.com/office/drawing/2010/main">
+        <mc:Choice Requires="a14">
           <p:sp>
             <p:nvSpPr>
               <p:cNvPr id="5" name="TextBox 4">
@@ -7299,7 +10289,7 @@
             </p:txBody>
           </p:sp>
         </mc:Choice>
-        <mc:Fallback>
+        <mc:Fallback xmlns="">
           <p:sp>
             <p:nvSpPr>
               <p:cNvPr id="5" name="TextBox 4">
@@ -8622,8 +11612,8 @@
           </a:prstGeom>
         </p:spPr>
       </p:pic>
-      <mc:AlternateContent xmlns:mc="http://schemas.openxmlformats.org/markup-compatibility/2006">
-        <mc:Choice xmlns:a14="http://schemas.microsoft.com/office/drawing/2010/main" Requires="a14">
+      <mc:AlternateContent xmlns:mc="http://schemas.openxmlformats.org/markup-compatibility/2006" xmlns:a14="http://schemas.microsoft.com/office/drawing/2010/main">
+        <mc:Choice Requires="a14">
           <p:sp>
             <p:nvSpPr>
               <p:cNvPr id="41" name="TextBox 40">
@@ -8680,7 +11670,7 @@
             </p:txBody>
           </p:sp>
         </mc:Choice>
-        <mc:Fallback>
+        <mc:Fallback xmlns="">
           <p:sp>
             <p:nvSpPr>
               <p:cNvPr id="41" name="TextBox 40">

</xml_diff>